<commit_message>
Minor changes to W5-6.
</commit_message>
<xml_diff>
--- a/W5/2. W5S2 final/W5S2.pptx
+++ b/W5/2. W5S2 final/W5S2.pptx
@@ -258,3038 +258,29 @@
 </p:presentation>
 </file>
 
-<file path=ppt/revisionInfo.xml><?xml version="1.0" encoding="utf-8"?>
-<p1510:revInfo xmlns:a="http://schemas.openxmlformats.org/drawingml/2006/main" xmlns:r="http://schemas.openxmlformats.org/officeDocument/2006/relationships" xmlns:p1510="http://schemas.microsoft.com/office/powerpoint/2015/10/main">
-  <p1510:revLst>
-    <p1510:client id="{2BA4306B-ED37-4BDD-81E3-054242F2750B}" v="20" dt="2025-03-03T11:32:36.486"/>
-  </p1510:revLst>
-</p1510:revInfo>
-</file>
-
 <file path=ppt/changesInfos/changesInfo1.xml><?xml version="1.0" encoding="utf-8"?>
 <pc:chgInfo xmlns:a="http://schemas.openxmlformats.org/drawingml/2006/main" xmlns:r="http://schemas.openxmlformats.org/officeDocument/2006/relationships" xmlns:ac="http://schemas.microsoft.com/office/drawing/2013/main/command" xmlns:pc="http://schemas.microsoft.com/office/powerpoint/2013/main/command">
   <pc:docChgLst>
-    <pc:chgData name="Matthieu De Mari" userId="dfb708c9-d8dc-439f-9a3b-c772bf4a311c" providerId="ADAL" clId="{23B9794A-8B54-47C4-827C-820833DFB1C7}"/>
-    <pc:docChg chg="undo custSel addSld delSld modSld modSection">
-      <pc:chgData name="Matthieu De Mari" userId="dfb708c9-d8dc-439f-9a3b-c772bf4a311c" providerId="ADAL" clId="{23B9794A-8B54-47C4-827C-820833DFB1C7}" dt="2023-07-06T07:50:52.378" v="526" actId="20577"/>
+    <pc:chgData name="Matthieu De Mari" userId="dfb708c9-d8dc-439f-9a3b-c772bf4a311c" providerId="ADAL" clId="{81E9B007-0C2C-493E-9B93-55A62C9C1F12}"/>
+    <pc:docChg chg="modSld">
+      <pc:chgData name="Matthieu De Mari" userId="dfb708c9-d8dc-439f-9a3b-c772bf4a311c" providerId="ADAL" clId="{81E9B007-0C2C-493E-9B93-55A62C9C1F12}" dt="2025-12-18T22:55:53.222" v="0" actId="20577"/>
       <pc:docMkLst>
         <pc:docMk/>
       </pc:docMkLst>
-      <pc:sldChg chg="add del">
-        <pc:chgData name="Matthieu De Mari" userId="dfb708c9-d8dc-439f-9a3b-c772bf4a311c" providerId="ADAL" clId="{23B9794A-8B54-47C4-827C-820833DFB1C7}" dt="2023-07-06T07:37:48.191" v="1"/>
-        <pc:sldMkLst>
-          <pc:docMk/>
-          <pc:sldMk cId="3425780644" sldId="407"/>
-        </pc:sldMkLst>
-      </pc:sldChg>
       <pc:sldChg chg="modSp mod">
-        <pc:chgData name="Matthieu De Mari" userId="dfb708c9-d8dc-439f-9a3b-c772bf4a311c" providerId="ADAL" clId="{23B9794A-8B54-47C4-827C-820833DFB1C7}" dt="2023-07-06T07:39:00.733" v="3" actId="113"/>
-        <pc:sldMkLst>
-          <pc:docMk/>
-          <pc:sldMk cId="4011461575" sldId="602"/>
-        </pc:sldMkLst>
-      </pc:sldChg>
-      <pc:sldChg chg="modSp mod">
-        <pc:chgData name="Matthieu De Mari" userId="dfb708c9-d8dc-439f-9a3b-c772bf4a311c" providerId="ADAL" clId="{23B9794A-8B54-47C4-827C-820833DFB1C7}" dt="2023-07-06T07:38:54.219" v="2" actId="20577"/>
+        <pc:chgData name="Matthieu De Mari" userId="dfb708c9-d8dc-439f-9a3b-c772bf4a311c" providerId="ADAL" clId="{81E9B007-0C2C-493E-9B93-55A62C9C1F12}" dt="2025-12-18T22:55:53.222" v="0" actId="20577"/>
         <pc:sldMkLst>
           <pc:docMk/>
           <pc:sldMk cId="1888637577" sldId="604"/>
         </pc:sldMkLst>
-      </pc:sldChg>
-      <pc:sldChg chg="modSp mod">
-        <pc:chgData name="Matthieu De Mari" userId="dfb708c9-d8dc-439f-9a3b-c772bf4a311c" providerId="ADAL" clId="{23B9794A-8B54-47C4-827C-820833DFB1C7}" dt="2023-07-06T07:40:04.273" v="8" actId="20577"/>
-        <pc:sldMkLst>
-          <pc:docMk/>
-          <pc:sldMk cId="1726322392" sldId="614"/>
-        </pc:sldMkLst>
-      </pc:sldChg>
-      <pc:sldChg chg="modSp mod">
-        <pc:chgData name="Matthieu De Mari" userId="dfb708c9-d8dc-439f-9a3b-c772bf4a311c" providerId="ADAL" clId="{23B9794A-8B54-47C4-827C-820833DFB1C7}" dt="2023-07-06T07:39:39.074" v="7" actId="20577"/>
-        <pc:sldMkLst>
-          <pc:docMk/>
-          <pc:sldMk cId="3403244392" sldId="630"/>
-        </pc:sldMkLst>
-      </pc:sldChg>
-      <pc:sldChg chg="modSp">
-        <pc:chgData name="Matthieu De Mari" userId="dfb708c9-d8dc-439f-9a3b-c772bf4a311c" providerId="ADAL" clId="{23B9794A-8B54-47C4-827C-820833DFB1C7}" dt="2023-07-06T07:39:21.759" v="6" actId="20577"/>
-        <pc:sldMkLst>
-          <pc:docMk/>
-          <pc:sldMk cId="956888542" sldId="635"/>
-        </pc:sldMkLst>
-      </pc:sldChg>
-      <pc:sldChg chg="modSp mod">
-        <pc:chgData name="Matthieu De Mari" userId="dfb708c9-d8dc-439f-9a3b-c772bf4a311c" providerId="ADAL" clId="{23B9794A-8B54-47C4-827C-820833DFB1C7}" dt="2023-07-06T07:47:41.037" v="412" actId="1076"/>
-        <pc:sldMkLst>
-          <pc:docMk/>
-          <pc:sldMk cId="1731878414" sldId="637"/>
-        </pc:sldMkLst>
-      </pc:sldChg>
-      <pc:sldChg chg="modSp mod">
-        <pc:chgData name="Matthieu De Mari" userId="dfb708c9-d8dc-439f-9a3b-c772bf4a311c" providerId="ADAL" clId="{23B9794A-8B54-47C4-827C-820833DFB1C7}" dt="2023-07-06T07:43:21.117" v="73" actId="20577"/>
-        <pc:sldMkLst>
-          <pc:docMk/>
-          <pc:sldMk cId="3527748531" sldId="640"/>
-        </pc:sldMkLst>
-      </pc:sldChg>
-      <pc:sldChg chg="modSp mod">
-        <pc:chgData name="Matthieu De Mari" userId="dfb708c9-d8dc-439f-9a3b-c772bf4a311c" providerId="ADAL" clId="{23B9794A-8B54-47C4-827C-820833DFB1C7}" dt="2023-07-06T07:43:26.735" v="74"/>
-        <pc:sldMkLst>
-          <pc:docMk/>
-          <pc:sldMk cId="3298110552" sldId="641"/>
-        </pc:sldMkLst>
-      </pc:sldChg>
-      <pc:sldChg chg="modSp mod">
-        <pc:chgData name="Matthieu De Mari" userId="dfb708c9-d8dc-439f-9a3b-c772bf4a311c" providerId="ADAL" clId="{23B9794A-8B54-47C4-827C-820833DFB1C7}" dt="2023-07-06T07:43:34.977" v="76"/>
-        <pc:sldMkLst>
-          <pc:docMk/>
-          <pc:sldMk cId="4241197121" sldId="642"/>
-        </pc:sldMkLst>
-      </pc:sldChg>
-      <pc:sldChg chg="modSp mod">
-        <pc:chgData name="Matthieu De Mari" userId="dfb708c9-d8dc-439f-9a3b-c772bf4a311c" providerId="ADAL" clId="{23B9794A-8B54-47C4-827C-820833DFB1C7}" dt="2023-07-06T07:43:44.055" v="86" actId="20577"/>
-        <pc:sldMkLst>
-          <pc:docMk/>
-          <pc:sldMk cId="715032396" sldId="644"/>
-        </pc:sldMkLst>
-      </pc:sldChg>
-      <pc:sldChg chg="modSp mod">
-        <pc:chgData name="Matthieu De Mari" userId="dfb708c9-d8dc-439f-9a3b-c772bf4a311c" providerId="ADAL" clId="{23B9794A-8B54-47C4-827C-820833DFB1C7}" dt="2023-07-06T07:43:47.391" v="89" actId="27636"/>
-        <pc:sldMkLst>
-          <pc:docMk/>
-          <pc:sldMk cId="1850403076" sldId="645"/>
-        </pc:sldMkLst>
-      </pc:sldChg>
-      <pc:sldChg chg="modSp mod">
-        <pc:chgData name="Matthieu De Mari" userId="dfb708c9-d8dc-439f-9a3b-c772bf4a311c" providerId="ADAL" clId="{23B9794A-8B54-47C4-827C-820833DFB1C7}" dt="2023-07-06T07:45:08.301" v="238" actId="20577"/>
-        <pc:sldMkLst>
-          <pc:docMk/>
-          <pc:sldMk cId="2404237809" sldId="648"/>
-        </pc:sldMkLst>
-      </pc:sldChg>
-      <pc:sldChg chg="addSp delSp modSp mod">
-        <pc:chgData name="Matthieu De Mari" userId="dfb708c9-d8dc-439f-9a3b-c772bf4a311c" providerId="ADAL" clId="{23B9794A-8B54-47C4-827C-820833DFB1C7}" dt="2023-07-06T07:46:33.431" v="363" actId="20577"/>
-        <pc:sldMkLst>
-          <pc:docMk/>
-          <pc:sldMk cId="1952442680" sldId="649"/>
-        </pc:sldMkLst>
-      </pc:sldChg>
-      <pc:sldChg chg="modSp mod">
-        <pc:chgData name="Matthieu De Mari" userId="dfb708c9-d8dc-439f-9a3b-c772bf4a311c" providerId="ADAL" clId="{23B9794A-8B54-47C4-827C-820833DFB1C7}" dt="2023-07-06T07:46:06.177" v="315" actId="1036"/>
-        <pc:sldMkLst>
-          <pc:docMk/>
-          <pc:sldMk cId="3215884619" sldId="650"/>
-        </pc:sldMkLst>
-      </pc:sldChg>
-      <pc:sldChg chg="modSp mod">
-        <pc:chgData name="Matthieu De Mari" userId="dfb708c9-d8dc-439f-9a3b-c772bf4a311c" providerId="ADAL" clId="{23B9794A-8B54-47C4-827C-820833DFB1C7}" dt="2023-07-06T07:43:30.731" v="75"/>
-        <pc:sldMkLst>
-          <pc:docMk/>
-          <pc:sldMk cId="2595195584" sldId="651"/>
-        </pc:sldMkLst>
-      </pc:sldChg>
-      <pc:sldChg chg="modSp mod">
-        <pc:chgData name="Matthieu De Mari" userId="dfb708c9-d8dc-439f-9a3b-c772bf4a311c" providerId="ADAL" clId="{23B9794A-8B54-47C4-827C-820833DFB1C7}" dt="2023-07-06T07:43:49.967" v="91" actId="27636"/>
-        <pc:sldMkLst>
-          <pc:docMk/>
-          <pc:sldMk cId="773672680" sldId="652"/>
-        </pc:sldMkLst>
-      </pc:sldChg>
-      <pc:sldChg chg="modSp mod">
-        <pc:chgData name="Matthieu De Mari" userId="dfb708c9-d8dc-439f-9a3b-c772bf4a311c" providerId="ADAL" clId="{23B9794A-8B54-47C4-827C-820833DFB1C7}" dt="2023-07-06T07:47:09.385" v="402" actId="20577"/>
-        <pc:sldMkLst>
-          <pc:docMk/>
-          <pc:sldMk cId="855321949" sldId="653"/>
-        </pc:sldMkLst>
-      </pc:sldChg>
-      <pc:sldChg chg="modSp mod">
-        <pc:chgData name="Matthieu De Mari" userId="dfb708c9-d8dc-439f-9a3b-c772bf4a311c" providerId="ADAL" clId="{23B9794A-8B54-47C4-827C-820833DFB1C7}" dt="2023-07-06T07:47:20.277" v="408" actId="20577"/>
-        <pc:sldMkLst>
-          <pc:docMk/>
-          <pc:sldMk cId="2099660639" sldId="654"/>
-        </pc:sldMkLst>
-      </pc:sldChg>
-      <pc:sldChg chg="modSp">
-        <pc:chgData name="Matthieu De Mari" userId="dfb708c9-d8dc-439f-9a3b-c772bf4a311c" providerId="ADAL" clId="{23B9794A-8B54-47C4-827C-820833DFB1C7}" dt="2023-07-06T07:48:47.006" v="460" actId="20577"/>
-        <pc:sldMkLst>
-          <pc:docMk/>
-          <pc:sldMk cId="2451971174" sldId="655"/>
-        </pc:sldMkLst>
-      </pc:sldChg>
-      <pc:sldChg chg="addSp delSp modSp mod">
-        <pc:chgData name="Matthieu De Mari" userId="dfb708c9-d8dc-439f-9a3b-c772bf4a311c" providerId="ADAL" clId="{23B9794A-8B54-47C4-827C-820833DFB1C7}" dt="2023-07-06T07:47:58.249" v="433" actId="1035"/>
-        <pc:sldMkLst>
-          <pc:docMk/>
-          <pc:sldMk cId="148017835" sldId="656"/>
-        </pc:sldMkLst>
-      </pc:sldChg>
-      <pc:sldChg chg="addSp delSp modSp mod">
-        <pc:chgData name="Matthieu De Mari" userId="dfb708c9-d8dc-439f-9a3b-c772bf4a311c" providerId="ADAL" clId="{23B9794A-8B54-47C4-827C-820833DFB1C7}" dt="2023-07-06T07:48:35.326" v="457" actId="1076"/>
-        <pc:sldMkLst>
-          <pc:docMk/>
-          <pc:sldMk cId="1922511899" sldId="657"/>
-        </pc:sldMkLst>
-      </pc:sldChg>
-      <pc:sldChg chg="modSp mod">
-        <pc:chgData name="Matthieu De Mari" userId="dfb708c9-d8dc-439f-9a3b-c772bf4a311c" providerId="ADAL" clId="{23B9794A-8B54-47C4-827C-820833DFB1C7}" dt="2023-07-06T07:49:33.233" v="484" actId="207"/>
-        <pc:sldMkLst>
-          <pc:docMk/>
-          <pc:sldMk cId="2096824087" sldId="659"/>
-        </pc:sldMkLst>
-      </pc:sldChg>
-      <pc:sldChg chg="modSp">
-        <pc:chgData name="Matthieu De Mari" userId="dfb708c9-d8dc-439f-9a3b-c772bf4a311c" providerId="ADAL" clId="{23B9794A-8B54-47C4-827C-820833DFB1C7}" dt="2023-07-06T07:49:54.460" v="494" actId="20577"/>
-        <pc:sldMkLst>
-          <pc:docMk/>
-          <pc:sldMk cId="3023865042" sldId="660"/>
-        </pc:sldMkLst>
-      </pc:sldChg>
-      <pc:sldChg chg="modSp mod">
-        <pc:chgData name="Matthieu De Mari" userId="dfb708c9-d8dc-439f-9a3b-c772bf4a311c" providerId="ADAL" clId="{23B9794A-8B54-47C4-827C-820833DFB1C7}" dt="2023-07-06T07:50:25.358" v="514" actId="207"/>
-        <pc:sldMkLst>
-          <pc:docMk/>
-          <pc:sldMk cId="2303339168" sldId="661"/>
-        </pc:sldMkLst>
-      </pc:sldChg>
-      <pc:sldChg chg="modSp mod">
-        <pc:chgData name="Matthieu De Mari" userId="dfb708c9-d8dc-439f-9a3b-c772bf4a311c" providerId="ADAL" clId="{23B9794A-8B54-47C4-827C-820833DFB1C7}" dt="2023-07-06T07:50:52.378" v="526" actId="20577"/>
-        <pc:sldMkLst>
-          <pc:docMk/>
-          <pc:sldMk cId="365986058" sldId="663"/>
-        </pc:sldMkLst>
-      </pc:sldChg>
-      <pc:sldChg chg="add">
-        <pc:chgData name="Matthieu De Mari" userId="dfb708c9-d8dc-439f-9a3b-c772bf4a311c" providerId="ADAL" clId="{23B9794A-8B54-47C4-827C-820833DFB1C7}" dt="2023-07-06T07:37:48.191" v="1"/>
-        <pc:sldMkLst>
-          <pc:docMk/>
-          <pc:sldMk cId="2828164903" sldId="668"/>
-        </pc:sldMkLst>
-      </pc:sldChg>
-      <pc:sldChg chg="add">
-        <pc:chgData name="Matthieu De Mari" userId="dfb708c9-d8dc-439f-9a3b-c772bf4a311c" providerId="ADAL" clId="{23B9794A-8B54-47C4-827C-820833DFB1C7}" dt="2023-07-06T07:37:48.191" v="1"/>
-        <pc:sldMkLst>
-          <pc:docMk/>
-          <pc:sldMk cId="3980169169" sldId="669"/>
-        </pc:sldMkLst>
-      </pc:sldChg>
-      <pc:sldChg chg="add">
-        <pc:chgData name="Matthieu De Mari" userId="dfb708c9-d8dc-439f-9a3b-c772bf4a311c" providerId="ADAL" clId="{23B9794A-8B54-47C4-827C-820833DFB1C7}" dt="2023-07-06T07:37:48.191" v="1"/>
-        <pc:sldMkLst>
-          <pc:docMk/>
-          <pc:sldMk cId="4122990920" sldId="670"/>
-        </pc:sldMkLst>
-      </pc:sldChg>
-    </pc:docChg>
-  </pc:docChgLst>
-  <pc:docChgLst>
-    <pc:chgData name="Matthieu De Mari" userId="dfb708c9-d8dc-439f-9a3b-c772bf4a311c" providerId="ADAL" clId="{2BA4306B-ED37-4BDD-81E3-054242F2750B}"/>
-    <pc:docChg chg="custSel addSld modSld modSection">
-      <pc:chgData name="Matthieu De Mari" userId="dfb708c9-d8dc-439f-9a3b-c772bf4a311c" providerId="ADAL" clId="{2BA4306B-ED37-4BDD-81E3-054242F2750B}" dt="2025-03-03T11:32:46.321" v="411" actId="14100"/>
-      <pc:docMkLst>
-        <pc:docMk/>
-      </pc:docMkLst>
-      <pc:sldChg chg="modSp mod">
-        <pc:chgData name="Matthieu De Mari" userId="dfb708c9-d8dc-439f-9a3b-c772bf4a311c" providerId="ADAL" clId="{2BA4306B-ED37-4BDD-81E3-054242F2750B}" dt="2025-02-24T02:29:03.186" v="3" actId="20577"/>
-        <pc:sldMkLst>
-          <pc:docMk/>
-          <pc:sldMk cId="3442501962" sldId="257"/>
-        </pc:sldMkLst>
         <pc:spChg chg="mod">
-          <ac:chgData name="Matthieu De Mari" userId="dfb708c9-d8dc-439f-9a3b-c772bf4a311c" providerId="ADAL" clId="{2BA4306B-ED37-4BDD-81E3-054242F2750B}" dt="2025-02-24T02:29:03.186" v="3" actId="20577"/>
+          <ac:chgData name="Matthieu De Mari" userId="dfb708c9-d8dc-439f-9a3b-c772bf4a311c" providerId="ADAL" clId="{81E9B007-0C2C-493E-9B93-55A62C9C1F12}" dt="2025-12-18T22:55:53.222" v="0" actId="20577"/>
           <ac:spMkLst>
             <pc:docMk/>
-            <pc:sldMk cId="3442501962" sldId="257"/>
-            <ac:spMk id="2" creationId="{49D40417-A4D3-4CE8-96E7-708E2439AE7B}"/>
-          </ac:spMkLst>
-        </pc:spChg>
-      </pc:sldChg>
-      <pc:sldChg chg="modSp mod">
-        <pc:chgData name="Matthieu De Mari" userId="dfb708c9-d8dc-439f-9a3b-c772bf4a311c" providerId="ADAL" clId="{2BA4306B-ED37-4BDD-81E3-054242F2750B}" dt="2025-02-24T02:28:59.612" v="1" actId="20577"/>
-        <pc:sldMkLst>
-          <pc:docMk/>
-          <pc:sldMk cId="37425589" sldId="591"/>
-        </pc:sldMkLst>
-        <pc:spChg chg="mod">
-          <ac:chgData name="Matthieu De Mari" userId="dfb708c9-d8dc-439f-9a3b-c772bf4a311c" providerId="ADAL" clId="{2BA4306B-ED37-4BDD-81E3-054242F2750B}" dt="2025-02-24T02:28:59.612" v="1" actId="20577"/>
-          <ac:spMkLst>
-            <pc:docMk/>
-            <pc:sldMk cId="37425589" sldId="591"/>
-            <ac:spMk id="2" creationId="{080CEB46-CC16-4D19-8C2C-AEE9471D8168}"/>
-          </ac:spMkLst>
-        </pc:spChg>
-      </pc:sldChg>
-      <pc:sldChg chg="delSp modSp mod modClrScheme chgLayout">
-        <pc:chgData name="Matthieu De Mari" userId="dfb708c9-d8dc-439f-9a3b-c772bf4a311c" providerId="ADAL" clId="{2BA4306B-ED37-4BDD-81E3-054242F2750B}" dt="2025-02-26T00:18:10.778" v="201" actId="20577"/>
-        <pc:sldMkLst>
-          <pc:docMk/>
-          <pc:sldMk cId="4011461575" sldId="602"/>
-        </pc:sldMkLst>
-        <pc:spChg chg="mod ord">
-          <ac:chgData name="Matthieu De Mari" userId="dfb708c9-d8dc-439f-9a3b-c772bf4a311c" providerId="ADAL" clId="{2BA4306B-ED37-4BDD-81E3-054242F2750B}" dt="2025-02-26T00:16:57.506" v="100" actId="700"/>
-          <ac:spMkLst>
-            <pc:docMk/>
-            <pc:sldMk cId="4011461575" sldId="602"/>
-            <ac:spMk id="2" creationId="{A5E4A4E9-9DD0-5D61-6F41-047DF9BAF529}"/>
-          </ac:spMkLst>
-        </pc:spChg>
-        <pc:spChg chg="mod ord">
-          <ac:chgData name="Matthieu De Mari" userId="dfb708c9-d8dc-439f-9a3b-c772bf4a311c" providerId="ADAL" clId="{2BA4306B-ED37-4BDD-81E3-054242F2750B}" dt="2025-02-26T00:18:10.778" v="201" actId="20577"/>
-          <ac:spMkLst>
-            <pc:docMk/>
-            <pc:sldMk cId="4011461575" sldId="602"/>
+            <pc:sldMk cId="1888637577" sldId="604"/>
             <ac:spMk id="3" creationId="{D17C42F1-3AC9-47C6-0B59-A6D4BF707BC9}"/>
           </ac:spMkLst>
         </pc:spChg>
-      </pc:sldChg>
-      <pc:sldChg chg="modSp">
-        <pc:chgData name="Matthieu De Mari" userId="dfb708c9-d8dc-439f-9a3b-c772bf4a311c" providerId="ADAL" clId="{2BA4306B-ED37-4BDD-81E3-054242F2750B}" dt="2025-02-26T00:19:12.027" v="216" actId="20577"/>
-        <pc:sldMkLst>
-          <pc:docMk/>
-          <pc:sldMk cId="9821103" sldId="636"/>
-        </pc:sldMkLst>
-        <pc:spChg chg="mod">
-          <ac:chgData name="Matthieu De Mari" userId="dfb708c9-d8dc-439f-9a3b-c772bf4a311c" providerId="ADAL" clId="{2BA4306B-ED37-4BDD-81E3-054242F2750B}" dt="2025-02-26T00:19:12.027" v="216" actId="20577"/>
-          <ac:spMkLst>
-            <pc:docMk/>
-            <pc:sldMk cId="9821103" sldId="636"/>
-            <ac:spMk id="3" creationId="{A5B88264-BB37-CFC8-0955-0927A7B14073}"/>
-          </ac:spMkLst>
-        </pc:spChg>
-      </pc:sldChg>
-      <pc:sldChg chg="modSp mod">
-        <pc:chgData name="Matthieu De Mari" userId="dfb708c9-d8dc-439f-9a3b-c772bf4a311c" providerId="ADAL" clId="{2BA4306B-ED37-4BDD-81E3-054242F2750B}" dt="2025-02-24T02:29:05.615" v="5" actId="20577"/>
-        <pc:sldMkLst>
-          <pc:docMk/>
-          <pc:sldMk cId="444206811" sldId="662"/>
-        </pc:sldMkLst>
-        <pc:spChg chg="mod">
-          <ac:chgData name="Matthieu De Mari" userId="dfb708c9-d8dc-439f-9a3b-c772bf4a311c" providerId="ADAL" clId="{2BA4306B-ED37-4BDD-81E3-054242F2750B}" dt="2025-02-24T02:29:05.615" v="5" actId="20577"/>
-          <ac:spMkLst>
-            <pc:docMk/>
-            <pc:sldMk cId="444206811" sldId="662"/>
-            <ac:spMk id="2" creationId="{49D40417-A4D3-4CE8-96E7-708E2439AE7B}"/>
-          </ac:spMkLst>
-        </pc:spChg>
-      </pc:sldChg>
-      <pc:sldChg chg="modSp mod">
-        <pc:chgData name="Matthieu De Mari" userId="dfb708c9-d8dc-439f-9a3b-c772bf4a311c" providerId="ADAL" clId="{2BA4306B-ED37-4BDD-81E3-054242F2750B}" dt="2025-02-26T00:16:24.897" v="69" actId="27636"/>
-        <pc:sldMkLst>
-          <pc:docMk/>
-          <pc:sldMk cId="2636755818" sldId="669"/>
-        </pc:sldMkLst>
-        <pc:spChg chg="mod">
-          <ac:chgData name="Matthieu De Mari" userId="dfb708c9-d8dc-439f-9a3b-c772bf4a311c" providerId="ADAL" clId="{2BA4306B-ED37-4BDD-81E3-054242F2750B}" dt="2025-02-26T00:16:24.897" v="69" actId="27636"/>
-          <ac:spMkLst>
-            <pc:docMk/>
-            <pc:sldMk cId="2636755818" sldId="669"/>
-            <ac:spMk id="3" creationId="{2C65FA57-03F7-0D2B-DC25-B384F224DA2C}"/>
-          </ac:spMkLst>
-        </pc:spChg>
-      </pc:sldChg>
-      <pc:sldChg chg="addSp delSp modSp add mod">
-        <pc:chgData name="Matthieu De Mari" userId="dfb708c9-d8dc-439f-9a3b-c772bf4a311c" providerId="ADAL" clId="{2BA4306B-ED37-4BDD-81E3-054242F2750B}" dt="2025-03-03T11:32:46.321" v="411" actId="14100"/>
-        <pc:sldMkLst>
-          <pc:docMk/>
-          <pc:sldMk cId="4022946169" sldId="671"/>
-        </pc:sldMkLst>
-        <pc:spChg chg="add mod">
-          <ac:chgData name="Matthieu De Mari" userId="dfb708c9-d8dc-439f-9a3b-c772bf4a311c" providerId="ADAL" clId="{2BA4306B-ED37-4BDD-81E3-054242F2750B}" dt="2025-03-03T11:31:54.667" v="395" actId="207"/>
-          <ac:spMkLst>
-            <pc:docMk/>
-            <pc:sldMk cId="4022946169" sldId="671"/>
-            <ac:spMk id="3" creationId="{F8C3F0F4-AB50-4CD1-9D40-034C9EDA062C}"/>
-          </ac:spMkLst>
-        </pc:spChg>
-        <pc:spChg chg="add mod">
-          <ac:chgData name="Matthieu De Mari" userId="dfb708c9-d8dc-439f-9a3b-c772bf4a311c" providerId="ADAL" clId="{2BA4306B-ED37-4BDD-81E3-054242F2750B}" dt="2025-03-03T11:32:16.814" v="403" actId="693"/>
-          <ac:spMkLst>
-            <pc:docMk/>
-            <pc:sldMk cId="4022946169" sldId="671"/>
-            <ac:spMk id="4" creationId="{1A9F63FE-C449-1957-A181-6F85594A8EA3}"/>
-          </ac:spMkLst>
-        </pc:spChg>
-        <pc:picChg chg="add mod modCrop">
-          <ac:chgData name="Matthieu De Mari" userId="dfb708c9-d8dc-439f-9a3b-c772bf4a311c" providerId="ADAL" clId="{2BA4306B-ED37-4BDD-81E3-054242F2750B}" dt="2025-03-03T11:31:07.819" v="237" actId="1076"/>
-          <ac:picMkLst>
-            <pc:docMk/>
-            <pc:sldMk cId="4022946169" sldId="671"/>
-            <ac:picMk id="2" creationId="{DA4E2DD4-54C1-525D-FA2C-22EC810AF57B}"/>
-          </ac:picMkLst>
-        </pc:picChg>
-        <pc:picChg chg="add del mod">
-          <ac:chgData name="Matthieu De Mari" userId="dfb708c9-d8dc-439f-9a3b-c772bf4a311c" providerId="ADAL" clId="{2BA4306B-ED37-4BDD-81E3-054242F2750B}" dt="2025-03-03T11:30:40.214" v="229" actId="478"/>
-          <ac:picMkLst>
-            <pc:docMk/>
-            <pc:sldMk cId="4022946169" sldId="671"/>
-            <ac:picMk id="7" creationId="{77017338-33D3-FE37-7562-7D7324D5C128}"/>
-          </ac:picMkLst>
-        </pc:picChg>
-        <pc:cxnChg chg="add mod">
-          <ac:chgData name="Matthieu De Mari" userId="dfb708c9-d8dc-439f-9a3b-c772bf4a311c" providerId="ADAL" clId="{2BA4306B-ED37-4BDD-81E3-054242F2750B}" dt="2025-03-03T11:32:46.321" v="411" actId="14100"/>
-          <ac:cxnSpMkLst>
-            <pc:docMk/>
-            <pc:sldMk cId="4022946169" sldId="671"/>
-            <ac:cxnSpMk id="6" creationId="{E884D96E-77C7-3AF6-3516-21F562ECF2DD}"/>
-          </ac:cxnSpMkLst>
-        </pc:cxnChg>
-      </pc:sldChg>
-      <pc:sldChg chg="addSp delSp modSp new mod">
-        <pc:chgData name="Matthieu De Mari" userId="dfb708c9-d8dc-439f-9a3b-c772bf4a311c" providerId="ADAL" clId="{2BA4306B-ED37-4BDD-81E3-054242F2750B}" dt="2025-03-03T11:30:35.929" v="228" actId="962"/>
-        <pc:sldMkLst>
-          <pc:docMk/>
-          <pc:sldMk cId="3190003112" sldId="672"/>
-        </pc:sldMkLst>
-        <pc:spChg chg="del">
-          <ac:chgData name="Matthieu De Mari" userId="dfb708c9-d8dc-439f-9a3b-c772bf4a311c" providerId="ADAL" clId="{2BA4306B-ED37-4BDD-81E3-054242F2750B}" dt="2025-03-03T11:30:32.079" v="224" actId="478"/>
-          <ac:spMkLst>
-            <pc:docMk/>
-            <pc:sldMk cId="3190003112" sldId="672"/>
-            <ac:spMk id="2" creationId="{FB33FFCC-F682-4ECF-2F4D-39FBCFED127E}"/>
-          </ac:spMkLst>
-        </pc:spChg>
-        <pc:spChg chg="del">
-          <ac:chgData name="Matthieu De Mari" userId="dfb708c9-d8dc-439f-9a3b-c772bf4a311c" providerId="ADAL" clId="{2BA4306B-ED37-4BDD-81E3-054242F2750B}" dt="2025-03-03T11:30:33.146" v="225" actId="478"/>
-          <ac:spMkLst>
-            <pc:docMk/>
-            <pc:sldMk cId="3190003112" sldId="672"/>
-            <ac:spMk id="3" creationId="{C818FB8C-C971-D0D2-118B-3EC9E19F8D4F}"/>
-          </ac:spMkLst>
-        </pc:spChg>
-        <pc:picChg chg="add mod">
-          <ac:chgData name="Matthieu De Mari" userId="dfb708c9-d8dc-439f-9a3b-c772bf4a311c" providerId="ADAL" clId="{2BA4306B-ED37-4BDD-81E3-054242F2750B}" dt="2025-03-03T11:30:35.929" v="228" actId="962"/>
-          <ac:picMkLst>
-            <pc:docMk/>
-            <pc:sldMk cId="3190003112" sldId="672"/>
-            <ac:picMk id="5" creationId="{B4E3B419-389E-8D12-B094-ADAFF3C07591}"/>
-          </ac:picMkLst>
-        </pc:picChg>
-      </pc:sldChg>
-    </pc:docChg>
-  </pc:docChgLst>
-  <pc:docChgLst>
-    <pc:chgData name="Matthieu De Mari" userId="dfb708c9-d8dc-439f-9a3b-c772bf4a311c" providerId="ADAL" clId="{8EE40018-26BD-4A7B-8D17-70AC8417C2D0}"/>
-    <pc:docChg chg="undo custSel addSld delSld modSld addSection delSection modSection">
-      <pc:chgData name="Matthieu De Mari" userId="dfb708c9-d8dc-439f-9a3b-c772bf4a311c" providerId="ADAL" clId="{8EE40018-26BD-4A7B-8D17-70AC8417C2D0}" dt="2022-11-16T06:55:05.435" v="67" actId="47"/>
-      <pc:docMkLst>
-        <pc:docMk/>
-      </pc:docMkLst>
-      <pc:sldChg chg="modSp mod">
-        <pc:chgData name="Matthieu De Mari" userId="dfb708c9-d8dc-439f-9a3b-c772bf4a311c" providerId="ADAL" clId="{8EE40018-26BD-4A7B-8D17-70AC8417C2D0}" dt="2022-11-16T06:55:04.205" v="66" actId="20577"/>
-        <pc:sldMkLst>
-          <pc:docMk/>
-          <pc:sldMk cId="3442501962" sldId="257"/>
-        </pc:sldMkLst>
-      </pc:sldChg>
-      <pc:sldChg chg="del">
-        <pc:chgData name="Matthieu De Mari" userId="dfb708c9-d8dc-439f-9a3b-c772bf4a311c" providerId="ADAL" clId="{8EE40018-26BD-4A7B-8D17-70AC8417C2D0}" dt="2022-11-16T06:54:01.441" v="17" actId="47"/>
-        <pc:sldMkLst>
-          <pc:docMk/>
-          <pc:sldMk cId="3556835968" sldId="261"/>
-        </pc:sldMkLst>
-      </pc:sldChg>
-      <pc:sldChg chg="modSp mod">
-        <pc:chgData name="Matthieu De Mari" userId="dfb708c9-d8dc-439f-9a3b-c772bf4a311c" providerId="ADAL" clId="{8EE40018-26BD-4A7B-8D17-70AC8417C2D0}" dt="2022-11-16T06:54:47.612" v="47" actId="20577"/>
-        <pc:sldMkLst>
-          <pc:docMk/>
-          <pc:sldMk cId="1893873068" sldId="266"/>
-        </pc:sldMkLst>
-      </pc:sldChg>
-      <pc:sldChg chg="modSp mod">
-        <pc:chgData name="Matthieu De Mari" userId="dfb708c9-d8dc-439f-9a3b-c772bf4a311c" providerId="ADAL" clId="{8EE40018-26BD-4A7B-8D17-70AC8417C2D0}" dt="2022-11-16T06:54:56.797" v="60" actId="20577"/>
-        <pc:sldMkLst>
-          <pc:docMk/>
-          <pc:sldMk cId="3880949074" sldId="267"/>
-        </pc:sldMkLst>
-      </pc:sldChg>
-      <pc:sldChg chg="del">
-        <pc:chgData name="Matthieu De Mari" userId="dfb708c9-d8dc-439f-9a3b-c772bf4a311c" providerId="ADAL" clId="{8EE40018-26BD-4A7B-8D17-70AC8417C2D0}" dt="2022-11-16T06:54:02.421" v="18" actId="47"/>
-        <pc:sldMkLst>
-          <pc:docMk/>
-          <pc:sldMk cId="969289828" sldId="271"/>
-        </pc:sldMkLst>
-      </pc:sldChg>
-      <pc:sldChg chg="del">
-        <pc:chgData name="Matthieu De Mari" userId="dfb708c9-d8dc-439f-9a3b-c772bf4a311c" providerId="ADAL" clId="{8EE40018-26BD-4A7B-8D17-70AC8417C2D0}" dt="2022-11-16T06:54:02.421" v="18" actId="47"/>
-        <pc:sldMkLst>
-          <pc:docMk/>
-          <pc:sldMk cId="543657650" sldId="273"/>
-        </pc:sldMkLst>
-      </pc:sldChg>
-      <pc:sldChg chg="del">
-        <pc:chgData name="Matthieu De Mari" userId="dfb708c9-d8dc-439f-9a3b-c772bf4a311c" providerId="ADAL" clId="{8EE40018-26BD-4A7B-8D17-70AC8417C2D0}" dt="2022-11-16T06:54:01.441" v="17" actId="47"/>
-        <pc:sldMkLst>
-          <pc:docMk/>
-          <pc:sldMk cId="3687792543" sldId="275"/>
-        </pc:sldMkLst>
-      </pc:sldChg>
-      <pc:sldChg chg="del">
-        <pc:chgData name="Matthieu De Mari" userId="dfb708c9-d8dc-439f-9a3b-c772bf4a311c" providerId="ADAL" clId="{8EE40018-26BD-4A7B-8D17-70AC8417C2D0}" dt="2022-11-16T06:54:03.510" v="19" actId="47"/>
-        <pc:sldMkLst>
-          <pc:docMk/>
-          <pc:sldMk cId="1852878019" sldId="276"/>
-        </pc:sldMkLst>
-      </pc:sldChg>
-      <pc:sldChg chg="del">
-        <pc:chgData name="Matthieu De Mari" userId="dfb708c9-d8dc-439f-9a3b-c772bf4a311c" providerId="ADAL" clId="{8EE40018-26BD-4A7B-8D17-70AC8417C2D0}" dt="2022-11-16T06:54:02.421" v="18" actId="47"/>
-        <pc:sldMkLst>
-          <pc:docMk/>
-          <pc:sldMk cId="355509003" sldId="278"/>
-        </pc:sldMkLst>
-      </pc:sldChg>
-      <pc:sldChg chg="del">
-        <pc:chgData name="Matthieu De Mari" userId="dfb708c9-d8dc-439f-9a3b-c772bf4a311c" providerId="ADAL" clId="{8EE40018-26BD-4A7B-8D17-70AC8417C2D0}" dt="2022-11-16T06:54:02.421" v="18" actId="47"/>
-        <pc:sldMkLst>
-          <pc:docMk/>
-          <pc:sldMk cId="3873470932" sldId="280"/>
-        </pc:sldMkLst>
-      </pc:sldChg>
-      <pc:sldChg chg="del">
-        <pc:chgData name="Matthieu De Mari" userId="dfb708c9-d8dc-439f-9a3b-c772bf4a311c" providerId="ADAL" clId="{8EE40018-26BD-4A7B-8D17-70AC8417C2D0}" dt="2022-11-16T06:54:02.421" v="18" actId="47"/>
-        <pc:sldMkLst>
-          <pc:docMk/>
-          <pc:sldMk cId="3477464442" sldId="281"/>
-        </pc:sldMkLst>
-      </pc:sldChg>
-      <pc:sldChg chg="del">
-        <pc:chgData name="Matthieu De Mari" userId="dfb708c9-d8dc-439f-9a3b-c772bf4a311c" providerId="ADAL" clId="{8EE40018-26BD-4A7B-8D17-70AC8417C2D0}" dt="2022-11-16T06:54:02.421" v="18" actId="47"/>
-        <pc:sldMkLst>
-          <pc:docMk/>
-          <pc:sldMk cId="4219540979" sldId="282"/>
-        </pc:sldMkLst>
-      </pc:sldChg>
-      <pc:sldChg chg="modSp del mod">
-        <pc:chgData name="Matthieu De Mari" userId="dfb708c9-d8dc-439f-9a3b-c772bf4a311c" providerId="ADAL" clId="{8EE40018-26BD-4A7B-8D17-70AC8417C2D0}" dt="2022-11-16T06:55:05.435" v="67" actId="47"/>
-        <pc:sldMkLst>
-          <pc:docMk/>
-          <pc:sldMk cId="2071167148" sldId="284"/>
-        </pc:sldMkLst>
-      </pc:sldChg>
-      <pc:sldChg chg="del">
-        <pc:chgData name="Matthieu De Mari" userId="dfb708c9-d8dc-439f-9a3b-c772bf4a311c" providerId="ADAL" clId="{8EE40018-26BD-4A7B-8D17-70AC8417C2D0}" dt="2022-11-16T06:54:14.637" v="28" actId="47"/>
-        <pc:sldMkLst>
-          <pc:docMk/>
-          <pc:sldMk cId="3743280645" sldId="285"/>
-        </pc:sldMkLst>
-      </pc:sldChg>
-      <pc:sldChg chg="del">
-        <pc:chgData name="Matthieu De Mari" userId="dfb708c9-d8dc-439f-9a3b-c772bf4a311c" providerId="ADAL" clId="{8EE40018-26BD-4A7B-8D17-70AC8417C2D0}" dt="2022-11-16T06:54:02.421" v="18" actId="47"/>
-        <pc:sldMkLst>
-          <pc:docMk/>
-          <pc:sldMk cId="2640130553" sldId="286"/>
-        </pc:sldMkLst>
-      </pc:sldChg>
-      <pc:sldChg chg="del">
-        <pc:chgData name="Matthieu De Mari" userId="dfb708c9-d8dc-439f-9a3b-c772bf4a311c" providerId="ADAL" clId="{8EE40018-26BD-4A7B-8D17-70AC8417C2D0}" dt="2022-11-16T06:54:03.510" v="19" actId="47"/>
-        <pc:sldMkLst>
-          <pc:docMk/>
-          <pc:sldMk cId="3356285317" sldId="289"/>
-        </pc:sldMkLst>
-      </pc:sldChg>
-      <pc:sldChg chg="del">
-        <pc:chgData name="Matthieu De Mari" userId="dfb708c9-d8dc-439f-9a3b-c772bf4a311c" providerId="ADAL" clId="{8EE40018-26BD-4A7B-8D17-70AC8417C2D0}" dt="2022-11-16T06:54:03.510" v="19" actId="47"/>
-        <pc:sldMkLst>
-          <pc:docMk/>
-          <pc:sldMk cId="473860244" sldId="290"/>
-        </pc:sldMkLst>
-      </pc:sldChg>
-      <pc:sldChg chg="del">
-        <pc:chgData name="Matthieu De Mari" userId="dfb708c9-d8dc-439f-9a3b-c772bf4a311c" providerId="ADAL" clId="{8EE40018-26BD-4A7B-8D17-70AC8417C2D0}" dt="2022-11-16T06:54:03.510" v="19" actId="47"/>
-        <pc:sldMkLst>
-          <pc:docMk/>
-          <pc:sldMk cId="290213158" sldId="291"/>
-        </pc:sldMkLst>
-      </pc:sldChg>
-      <pc:sldChg chg="del">
-        <pc:chgData name="Matthieu De Mari" userId="dfb708c9-d8dc-439f-9a3b-c772bf4a311c" providerId="ADAL" clId="{8EE40018-26BD-4A7B-8D17-70AC8417C2D0}" dt="2022-11-16T06:54:03.510" v="19" actId="47"/>
-        <pc:sldMkLst>
-          <pc:docMk/>
-          <pc:sldMk cId="3717810270" sldId="292"/>
-        </pc:sldMkLst>
-      </pc:sldChg>
-      <pc:sldChg chg="del">
-        <pc:chgData name="Matthieu De Mari" userId="dfb708c9-d8dc-439f-9a3b-c772bf4a311c" providerId="ADAL" clId="{8EE40018-26BD-4A7B-8D17-70AC8417C2D0}" dt="2022-11-16T06:54:03.510" v="19" actId="47"/>
-        <pc:sldMkLst>
-          <pc:docMk/>
-          <pc:sldMk cId="2783948156" sldId="293"/>
-        </pc:sldMkLst>
-      </pc:sldChg>
-      <pc:sldChg chg="del">
-        <pc:chgData name="Matthieu De Mari" userId="dfb708c9-d8dc-439f-9a3b-c772bf4a311c" providerId="ADAL" clId="{8EE40018-26BD-4A7B-8D17-70AC8417C2D0}" dt="2022-11-16T06:54:04.458" v="20" actId="47"/>
-        <pc:sldMkLst>
-          <pc:docMk/>
-          <pc:sldMk cId="4179829315" sldId="294"/>
-        </pc:sldMkLst>
-      </pc:sldChg>
-      <pc:sldChg chg="del">
-        <pc:chgData name="Matthieu De Mari" userId="dfb708c9-d8dc-439f-9a3b-c772bf4a311c" providerId="ADAL" clId="{8EE40018-26BD-4A7B-8D17-70AC8417C2D0}" dt="2022-11-16T06:54:12.971" v="26" actId="47"/>
-        <pc:sldMkLst>
-          <pc:docMk/>
-          <pc:sldMk cId="709624762" sldId="295"/>
-        </pc:sldMkLst>
-      </pc:sldChg>
-      <pc:sldChg chg="del">
-        <pc:chgData name="Matthieu De Mari" userId="dfb708c9-d8dc-439f-9a3b-c772bf4a311c" providerId="ADAL" clId="{8EE40018-26BD-4A7B-8D17-70AC8417C2D0}" dt="2022-11-16T06:54:11.293" v="25" actId="47"/>
-        <pc:sldMkLst>
-          <pc:docMk/>
-          <pc:sldMk cId="2576857052" sldId="297"/>
-        </pc:sldMkLst>
-      </pc:sldChg>
-      <pc:sldChg chg="del">
-        <pc:chgData name="Matthieu De Mari" userId="dfb708c9-d8dc-439f-9a3b-c772bf4a311c" providerId="ADAL" clId="{8EE40018-26BD-4A7B-8D17-70AC8417C2D0}" dt="2022-11-16T06:54:04.458" v="20" actId="47"/>
-        <pc:sldMkLst>
-          <pc:docMk/>
-          <pc:sldMk cId="1885656403" sldId="298"/>
-        </pc:sldMkLst>
-      </pc:sldChg>
-      <pc:sldChg chg="del">
-        <pc:chgData name="Matthieu De Mari" userId="dfb708c9-d8dc-439f-9a3b-c772bf4a311c" providerId="ADAL" clId="{8EE40018-26BD-4A7B-8D17-70AC8417C2D0}" dt="2022-11-16T06:54:04.458" v="20" actId="47"/>
-        <pc:sldMkLst>
-          <pc:docMk/>
-          <pc:sldMk cId="3768793426" sldId="299"/>
-        </pc:sldMkLst>
-      </pc:sldChg>
-      <pc:sldChg chg="del">
-        <pc:chgData name="Matthieu De Mari" userId="dfb708c9-d8dc-439f-9a3b-c772bf4a311c" providerId="ADAL" clId="{8EE40018-26BD-4A7B-8D17-70AC8417C2D0}" dt="2022-11-16T06:54:07.519" v="22" actId="47"/>
-        <pc:sldMkLst>
-          <pc:docMk/>
-          <pc:sldMk cId="902380433" sldId="300"/>
-        </pc:sldMkLst>
-      </pc:sldChg>
-      <pc:sldChg chg="del">
-        <pc:chgData name="Matthieu De Mari" userId="dfb708c9-d8dc-439f-9a3b-c772bf4a311c" providerId="ADAL" clId="{8EE40018-26BD-4A7B-8D17-70AC8417C2D0}" dt="2022-11-16T06:54:08.404" v="23" actId="47"/>
-        <pc:sldMkLst>
-          <pc:docMk/>
-          <pc:sldMk cId="2202284175" sldId="301"/>
-        </pc:sldMkLst>
-      </pc:sldChg>
-      <pc:sldChg chg="del">
-        <pc:chgData name="Matthieu De Mari" userId="dfb708c9-d8dc-439f-9a3b-c772bf4a311c" providerId="ADAL" clId="{8EE40018-26BD-4A7B-8D17-70AC8417C2D0}" dt="2022-11-16T06:54:09.190" v="24" actId="47"/>
-        <pc:sldMkLst>
-          <pc:docMk/>
-          <pc:sldMk cId="1547433389" sldId="302"/>
-        </pc:sldMkLst>
-      </pc:sldChg>
-      <pc:sldChg chg="del">
-        <pc:chgData name="Matthieu De Mari" userId="dfb708c9-d8dc-439f-9a3b-c772bf4a311c" providerId="ADAL" clId="{8EE40018-26BD-4A7B-8D17-70AC8417C2D0}" dt="2022-11-16T06:54:04.458" v="20" actId="47"/>
-        <pc:sldMkLst>
-          <pc:docMk/>
-          <pc:sldMk cId="3335250243" sldId="303"/>
-        </pc:sldMkLst>
-      </pc:sldChg>
-      <pc:sldChg chg="del">
-        <pc:chgData name="Matthieu De Mari" userId="dfb708c9-d8dc-439f-9a3b-c772bf4a311c" providerId="ADAL" clId="{8EE40018-26BD-4A7B-8D17-70AC8417C2D0}" dt="2022-11-16T06:54:03.510" v="19" actId="47"/>
-        <pc:sldMkLst>
-          <pc:docMk/>
-          <pc:sldMk cId="349456406" sldId="305"/>
-        </pc:sldMkLst>
-      </pc:sldChg>
-      <pc:sldChg chg="del">
-        <pc:chgData name="Matthieu De Mari" userId="dfb708c9-d8dc-439f-9a3b-c772bf4a311c" providerId="ADAL" clId="{8EE40018-26BD-4A7B-8D17-70AC8417C2D0}" dt="2022-11-16T06:54:06.554" v="21" actId="47"/>
-        <pc:sldMkLst>
-          <pc:docMk/>
-          <pc:sldMk cId="1917974936" sldId="307"/>
-        </pc:sldMkLst>
-      </pc:sldChg>
-      <pc:sldChg chg="del">
-        <pc:chgData name="Matthieu De Mari" userId="dfb708c9-d8dc-439f-9a3b-c772bf4a311c" providerId="ADAL" clId="{8EE40018-26BD-4A7B-8D17-70AC8417C2D0}" dt="2022-11-16T06:54:06.554" v="21" actId="47"/>
-        <pc:sldMkLst>
-          <pc:docMk/>
-          <pc:sldMk cId="2278752964" sldId="309"/>
-        </pc:sldMkLst>
-      </pc:sldChg>
-      <pc:sldChg chg="del">
-        <pc:chgData name="Matthieu De Mari" userId="dfb708c9-d8dc-439f-9a3b-c772bf4a311c" providerId="ADAL" clId="{8EE40018-26BD-4A7B-8D17-70AC8417C2D0}" dt="2022-11-16T06:54:06.554" v="21" actId="47"/>
-        <pc:sldMkLst>
-          <pc:docMk/>
-          <pc:sldMk cId="3317882412" sldId="310"/>
-        </pc:sldMkLst>
-      </pc:sldChg>
-      <pc:sldChg chg="del">
-        <pc:chgData name="Matthieu De Mari" userId="dfb708c9-d8dc-439f-9a3b-c772bf4a311c" providerId="ADAL" clId="{8EE40018-26BD-4A7B-8D17-70AC8417C2D0}" dt="2022-11-16T06:54:06.554" v="21" actId="47"/>
-        <pc:sldMkLst>
-          <pc:docMk/>
-          <pc:sldMk cId="3051144984" sldId="311"/>
-        </pc:sldMkLst>
-      </pc:sldChg>
-      <pc:sldChg chg="del">
-        <pc:chgData name="Matthieu De Mari" userId="dfb708c9-d8dc-439f-9a3b-c772bf4a311c" providerId="ADAL" clId="{8EE40018-26BD-4A7B-8D17-70AC8417C2D0}" dt="2022-11-16T06:54:06.554" v="21" actId="47"/>
-        <pc:sldMkLst>
-          <pc:docMk/>
-          <pc:sldMk cId="666448182" sldId="313"/>
-        </pc:sldMkLst>
-      </pc:sldChg>
-      <pc:sldChg chg="del">
-        <pc:chgData name="Matthieu De Mari" userId="dfb708c9-d8dc-439f-9a3b-c772bf4a311c" providerId="ADAL" clId="{8EE40018-26BD-4A7B-8D17-70AC8417C2D0}" dt="2022-11-16T06:54:06.554" v="21" actId="47"/>
-        <pc:sldMkLst>
-          <pc:docMk/>
-          <pc:sldMk cId="1701431758" sldId="314"/>
-        </pc:sldMkLst>
-      </pc:sldChg>
-      <pc:sldChg chg="del">
-        <pc:chgData name="Matthieu De Mari" userId="dfb708c9-d8dc-439f-9a3b-c772bf4a311c" providerId="ADAL" clId="{8EE40018-26BD-4A7B-8D17-70AC8417C2D0}" dt="2022-11-16T06:54:06.554" v="21" actId="47"/>
-        <pc:sldMkLst>
-          <pc:docMk/>
-          <pc:sldMk cId="1813469429" sldId="315"/>
-        </pc:sldMkLst>
-      </pc:sldChg>
-      <pc:sldChg chg="del">
-        <pc:chgData name="Matthieu De Mari" userId="dfb708c9-d8dc-439f-9a3b-c772bf4a311c" providerId="ADAL" clId="{8EE40018-26BD-4A7B-8D17-70AC8417C2D0}" dt="2022-11-16T06:54:07.519" v="22" actId="47"/>
-        <pc:sldMkLst>
-          <pc:docMk/>
-          <pc:sldMk cId="3619476332" sldId="316"/>
-        </pc:sldMkLst>
-      </pc:sldChg>
-      <pc:sldChg chg="del">
-        <pc:chgData name="Matthieu De Mari" userId="dfb708c9-d8dc-439f-9a3b-c772bf4a311c" providerId="ADAL" clId="{8EE40018-26BD-4A7B-8D17-70AC8417C2D0}" dt="2022-11-16T06:54:07.519" v="22" actId="47"/>
-        <pc:sldMkLst>
-          <pc:docMk/>
-          <pc:sldMk cId="3133188960" sldId="317"/>
-        </pc:sldMkLst>
-      </pc:sldChg>
-      <pc:sldChg chg="del">
-        <pc:chgData name="Matthieu De Mari" userId="dfb708c9-d8dc-439f-9a3b-c772bf4a311c" providerId="ADAL" clId="{8EE40018-26BD-4A7B-8D17-70AC8417C2D0}" dt="2022-11-16T06:54:07.519" v="22" actId="47"/>
-        <pc:sldMkLst>
-          <pc:docMk/>
-          <pc:sldMk cId="913491245" sldId="318"/>
-        </pc:sldMkLst>
-      </pc:sldChg>
-      <pc:sldChg chg="del">
-        <pc:chgData name="Matthieu De Mari" userId="dfb708c9-d8dc-439f-9a3b-c772bf4a311c" providerId="ADAL" clId="{8EE40018-26BD-4A7B-8D17-70AC8417C2D0}" dt="2022-11-16T06:54:07.519" v="22" actId="47"/>
-        <pc:sldMkLst>
-          <pc:docMk/>
-          <pc:sldMk cId="369927457" sldId="319"/>
-        </pc:sldMkLst>
-      </pc:sldChg>
-      <pc:sldChg chg="del">
-        <pc:chgData name="Matthieu De Mari" userId="dfb708c9-d8dc-439f-9a3b-c772bf4a311c" providerId="ADAL" clId="{8EE40018-26BD-4A7B-8D17-70AC8417C2D0}" dt="2022-11-16T06:54:07.519" v="22" actId="47"/>
-        <pc:sldMkLst>
-          <pc:docMk/>
-          <pc:sldMk cId="868347224" sldId="320"/>
-        </pc:sldMkLst>
-      </pc:sldChg>
-      <pc:sldChg chg="del">
-        <pc:chgData name="Matthieu De Mari" userId="dfb708c9-d8dc-439f-9a3b-c772bf4a311c" providerId="ADAL" clId="{8EE40018-26BD-4A7B-8D17-70AC8417C2D0}" dt="2022-11-16T06:54:07.519" v="22" actId="47"/>
-        <pc:sldMkLst>
-          <pc:docMk/>
-          <pc:sldMk cId="2901421326" sldId="321"/>
-        </pc:sldMkLst>
-      </pc:sldChg>
-      <pc:sldChg chg="del">
-        <pc:chgData name="Matthieu De Mari" userId="dfb708c9-d8dc-439f-9a3b-c772bf4a311c" providerId="ADAL" clId="{8EE40018-26BD-4A7B-8D17-70AC8417C2D0}" dt="2022-11-16T06:54:07.519" v="22" actId="47"/>
-        <pc:sldMkLst>
-          <pc:docMk/>
-          <pc:sldMk cId="386318379" sldId="322"/>
-        </pc:sldMkLst>
-      </pc:sldChg>
-      <pc:sldChg chg="del">
-        <pc:chgData name="Matthieu De Mari" userId="dfb708c9-d8dc-439f-9a3b-c772bf4a311c" providerId="ADAL" clId="{8EE40018-26BD-4A7B-8D17-70AC8417C2D0}" dt="2022-11-16T06:54:07.519" v="22" actId="47"/>
-        <pc:sldMkLst>
-          <pc:docMk/>
-          <pc:sldMk cId="535785749" sldId="323"/>
-        </pc:sldMkLst>
-      </pc:sldChg>
-      <pc:sldChg chg="del">
-        <pc:chgData name="Matthieu De Mari" userId="dfb708c9-d8dc-439f-9a3b-c772bf4a311c" providerId="ADAL" clId="{8EE40018-26BD-4A7B-8D17-70AC8417C2D0}" dt="2022-11-16T06:54:07.519" v="22" actId="47"/>
-        <pc:sldMkLst>
-          <pc:docMk/>
-          <pc:sldMk cId="573807039" sldId="324"/>
-        </pc:sldMkLst>
-      </pc:sldChg>
-      <pc:sldChg chg="del">
-        <pc:chgData name="Matthieu De Mari" userId="dfb708c9-d8dc-439f-9a3b-c772bf4a311c" providerId="ADAL" clId="{8EE40018-26BD-4A7B-8D17-70AC8417C2D0}" dt="2022-11-16T06:54:07.519" v="22" actId="47"/>
-        <pc:sldMkLst>
-          <pc:docMk/>
-          <pc:sldMk cId="3026304390" sldId="325"/>
-        </pc:sldMkLst>
-      </pc:sldChg>
-      <pc:sldChg chg="del">
-        <pc:chgData name="Matthieu De Mari" userId="dfb708c9-d8dc-439f-9a3b-c772bf4a311c" providerId="ADAL" clId="{8EE40018-26BD-4A7B-8D17-70AC8417C2D0}" dt="2022-11-16T06:54:07.519" v="22" actId="47"/>
-        <pc:sldMkLst>
-          <pc:docMk/>
-          <pc:sldMk cId="4144845603" sldId="326"/>
-        </pc:sldMkLst>
-      </pc:sldChg>
-      <pc:sldChg chg="del">
-        <pc:chgData name="Matthieu De Mari" userId="dfb708c9-d8dc-439f-9a3b-c772bf4a311c" providerId="ADAL" clId="{8EE40018-26BD-4A7B-8D17-70AC8417C2D0}" dt="2022-11-16T06:54:07.519" v="22" actId="47"/>
-        <pc:sldMkLst>
-          <pc:docMk/>
-          <pc:sldMk cId="2128704617" sldId="328"/>
-        </pc:sldMkLst>
-      </pc:sldChg>
-      <pc:sldChg chg="del">
-        <pc:chgData name="Matthieu De Mari" userId="dfb708c9-d8dc-439f-9a3b-c772bf4a311c" providerId="ADAL" clId="{8EE40018-26BD-4A7B-8D17-70AC8417C2D0}" dt="2022-11-16T06:54:07.519" v="22" actId="47"/>
-        <pc:sldMkLst>
-          <pc:docMk/>
-          <pc:sldMk cId="1228181526" sldId="329"/>
-        </pc:sldMkLst>
-      </pc:sldChg>
-      <pc:sldChg chg="del">
-        <pc:chgData name="Matthieu De Mari" userId="dfb708c9-d8dc-439f-9a3b-c772bf4a311c" providerId="ADAL" clId="{8EE40018-26BD-4A7B-8D17-70AC8417C2D0}" dt="2022-11-16T06:54:07.519" v="22" actId="47"/>
-        <pc:sldMkLst>
-          <pc:docMk/>
-          <pc:sldMk cId="1086607777" sldId="331"/>
-        </pc:sldMkLst>
-      </pc:sldChg>
-      <pc:sldChg chg="del">
-        <pc:chgData name="Matthieu De Mari" userId="dfb708c9-d8dc-439f-9a3b-c772bf4a311c" providerId="ADAL" clId="{8EE40018-26BD-4A7B-8D17-70AC8417C2D0}" dt="2022-11-16T06:54:08.404" v="23" actId="47"/>
-        <pc:sldMkLst>
-          <pc:docMk/>
-          <pc:sldMk cId="3744088925" sldId="332"/>
-        </pc:sldMkLst>
-      </pc:sldChg>
-      <pc:sldChg chg="del">
-        <pc:chgData name="Matthieu De Mari" userId="dfb708c9-d8dc-439f-9a3b-c772bf4a311c" providerId="ADAL" clId="{8EE40018-26BD-4A7B-8D17-70AC8417C2D0}" dt="2022-11-16T06:54:08.404" v="23" actId="47"/>
-        <pc:sldMkLst>
-          <pc:docMk/>
-          <pc:sldMk cId="1824898086" sldId="334"/>
-        </pc:sldMkLst>
-      </pc:sldChg>
-      <pc:sldChg chg="del">
-        <pc:chgData name="Matthieu De Mari" userId="dfb708c9-d8dc-439f-9a3b-c772bf4a311c" providerId="ADAL" clId="{8EE40018-26BD-4A7B-8D17-70AC8417C2D0}" dt="2022-11-16T06:54:13.895" v="27" actId="47"/>
-        <pc:sldMkLst>
-          <pc:docMk/>
-          <pc:sldMk cId="3704706604" sldId="335"/>
-        </pc:sldMkLst>
-      </pc:sldChg>
-      <pc:sldChg chg="del">
-        <pc:chgData name="Matthieu De Mari" userId="dfb708c9-d8dc-439f-9a3b-c772bf4a311c" providerId="ADAL" clId="{8EE40018-26BD-4A7B-8D17-70AC8417C2D0}" dt="2022-11-16T06:54:11.293" v="25" actId="47"/>
-        <pc:sldMkLst>
-          <pc:docMk/>
-          <pc:sldMk cId="503014896" sldId="336"/>
-        </pc:sldMkLst>
-      </pc:sldChg>
-      <pc:sldChg chg="del">
-        <pc:chgData name="Matthieu De Mari" userId="dfb708c9-d8dc-439f-9a3b-c772bf4a311c" providerId="ADAL" clId="{8EE40018-26BD-4A7B-8D17-70AC8417C2D0}" dt="2022-11-16T06:54:11.293" v="25" actId="47"/>
-        <pc:sldMkLst>
-          <pc:docMk/>
-          <pc:sldMk cId="1757180629" sldId="338"/>
-        </pc:sldMkLst>
-      </pc:sldChg>
-      <pc:sldChg chg="del">
-        <pc:chgData name="Matthieu De Mari" userId="dfb708c9-d8dc-439f-9a3b-c772bf4a311c" providerId="ADAL" clId="{8EE40018-26BD-4A7B-8D17-70AC8417C2D0}" dt="2022-11-16T06:54:11.293" v="25" actId="47"/>
-        <pc:sldMkLst>
-          <pc:docMk/>
-          <pc:sldMk cId="3251712844" sldId="339"/>
-        </pc:sldMkLst>
-      </pc:sldChg>
-      <pc:sldChg chg="del">
-        <pc:chgData name="Matthieu De Mari" userId="dfb708c9-d8dc-439f-9a3b-c772bf4a311c" providerId="ADAL" clId="{8EE40018-26BD-4A7B-8D17-70AC8417C2D0}" dt="2022-11-16T06:54:11.293" v="25" actId="47"/>
-        <pc:sldMkLst>
-          <pc:docMk/>
-          <pc:sldMk cId="3000047863" sldId="341"/>
-        </pc:sldMkLst>
-      </pc:sldChg>
-      <pc:sldChg chg="del">
-        <pc:chgData name="Matthieu De Mari" userId="dfb708c9-d8dc-439f-9a3b-c772bf4a311c" providerId="ADAL" clId="{8EE40018-26BD-4A7B-8D17-70AC8417C2D0}" dt="2022-11-16T06:54:11.293" v="25" actId="47"/>
-        <pc:sldMkLst>
-          <pc:docMk/>
-          <pc:sldMk cId="3607475250" sldId="342"/>
-        </pc:sldMkLst>
-      </pc:sldChg>
-      <pc:sldChg chg="del">
-        <pc:chgData name="Matthieu De Mari" userId="dfb708c9-d8dc-439f-9a3b-c772bf4a311c" providerId="ADAL" clId="{8EE40018-26BD-4A7B-8D17-70AC8417C2D0}" dt="2022-11-16T06:54:11.293" v="25" actId="47"/>
-        <pc:sldMkLst>
-          <pc:docMk/>
-          <pc:sldMk cId="2202386436" sldId="343"/>
-        </pc:sldMkLst>
-      </pc:sldChg>
-      <pc:sldChg chg="del">
-        <pc:chgData name="Matthieu De Mari" userId="dfb708c9-d8dc-439f-9a3b-c772bf4a311c" providerId="ADAL" clId="{8EE40018-26BD-4A7B-8D17-70AC8417C2D0}" dt="2022-11-16T06:54:14.637" v="28" actId="47"/>
-        <pc:sldMkLst>
-          <pc:docMk/>
-          <pc:sldMk cId="4222503966" sldId="345"/>
-        </pc:sldMkLst>
-      </pc:sldChg>
-      <pc:sldChg chg="modSp add del mod">
-        <pc:chgData name="Matthieu De Mari" userId="dfb708c9-d8dc-439f-9a3b-c772bf4a311c" providerId="ADAL" clId="{8EE40018-26BD-4A7B-8D17-70AC8417C2D0}" dt="2022-11-16T06:54:26.067" v="39" actId="20577"/>
-        <pc:sldMkLst>
-          <pc:docMk/>
-          <pc:sldMk cId="1036081419" sldId="346"/>
-        </pc:sldMkLst>
-      </pc:sldChg>
-      <pc:sldChg chg="del">
-        <pc:chgData name="Matthieu De Mari" userId="dfb708c9-d8dc-439f-9a3b-c772bf4a311c" providerId="ADAL" clId="{8EE40018-26BD-4A7B-8D17-70AC8417C2D0}" dt="2022-11-16T06:54:11.293" v="25" actId="47"/>
-        <pc:sldMkLst>
-          <pc:docMk/>
-          <pc:sldMk cId="2902606749" sldId="350"/>
-        </pc:sldMkLst>
-      </pc:sldChg>
-      <pc:sldChg chg="del">
-        <pc:chgData name="Matthieu De Mari" userId="dfb708c9-d8dc-439f-9a3b-c772bf4a311c" providerId="ADAL" clId="{8EE40018-26BD-4A7B-8D17-70AC8417C2D0}" dt="2022-11-16T06:54:11.293" v="25" actId="47"/>
-        <pc:sldMkLst>
-          <pc:docMk/>
-          <pc:sldMk cId="1008855396" sldId="352"/>
-        </pc:sldMkLst>
-      </pc:sldChg>
-      <pc:sldChg chg="del">
-        <pc:chgData name="Matthieu De Mari" userId="dfb708c9-d8dc-439f-9a3b-c772bf4a311c" providerId="ADAL" clId="{8EE40018-26BD-4A7B-8D17-70AC8417C2D0}" dt="2022-11-16T06:54:11.293" v="25" actId="47"/>
-        <pc:sldMkLst>
-          <pc:docMk/>
-          <pc:sldMk cId="1005123530" sldId="353"/>
-        </pc:sldMkLst>
-      </pc:sldChg>
-      <pc:sldChg chg="del">
-        <pc:chgData name="Matthieu De Mari" userId="dfb708c9-d8dc-439f-9a3b-c772bf4a311c" providerId="ADAL" clId="{8EE40018-26BD-4A7B-8D17-70AC8417C2D0}" dt="2022-11-16T06:54:11.293" v="25" actId="47"/>
-        <pc:sldMkLst>
-          <pc:docMk/>
-          <pc:sldMk cId="304430080" sldId="354"/>
-        </pc:sldMkLst>
-      </pc:sldChg>
-      <pc:sldChg chg="del">
-        <pc:chgData name="Matthieu De Mari" userId="dfb708c9-d8dc-439f-9a3b-c772bf4a311c" providerId="ADAL" clId="{8EE40018-26BD-4A7B-8D17-70AC8417C2D0}" dt="2022-11-16T06:54:11.293" v="25" actId="47"/>
-        <pc:sldMkLst>
-          <pc:docMk/>
-          <pc:sldMk cId="2530765258" sldId="355"/>
-        </pc:sldMkLst>
-      </pc:sldChg>
-      <pc:sldChg chg="del">
-        <pc:chgData name="Matthieu De Mari" userId="dfb708c9-d8dc-439f-9a3b-c772bf4a311c" providerId="ADAL" clId="{8EE40018-26BD-4A7B-8D17-70AC8417C2D0}" dt="2022-11-16T06:54:11.293" v="25" actId="47"/>
-        <pc:sldMkLst>
-          <pc:docMk/>
-          <pc:sldMk cId="2900566505" sldId="356"/>
-        </pc:sldMkLst>
-      </pc:sldChg>
-      <pc:sldChg chg="del">
-        <pc:chgData name="Matthieu De Mari" userId="dfb708c9-d8dc-439f-9a3b-c772bf4a311c" providerId="ADAL" clId="{8EE40018-26BD-4A7B-8D17-70AC8417C2D0}" dt="2022-11-16T06:54:11.293" v="25" actId="47"/>
-        <pc:sldMkLst>
-          <pc:docMk/>
-          <pc:sldMk cId="151041797" sldId="357"/>
-        </pc:sldMkLst>
-      </pc:sldChg>
-      <pc:sldChg chg="del">
-        <pc:chgData name="Matthieu De Mari" userId="dfb708c9-d8dc-439f-9a3b-c772bf4a311c" providerId="ADAL" clId="{8EE40018-26BD-4A7B-8D17-70AC8417C2D0}" dt="2022-11-16T06:54:11.293" v="25" actId="47"/>
-        <pc:sldMkLst>
-          <pc:docMk/>
-          <pc:sldMk cId="2341017383" sldId="358"/>
-        </pc:sldMkLst>
-      </pc:sldChg>
-      <pc:sldChg chg="del">
-        <pc:chgData name="Matthieu De Mari" userId="dfb708c9-d8dc-439f-9a3b-c772bf4a311c" providerId="ADAL" clId="{8EE40018-26BD-4A7B-8D17-70AC8417C2D0}" dt="2022-11-16T06:54:12.971" v="26" actId="47"/>
-        <pc:sldMkLst>
-          <pc:docMk/>
-          <pc:sldMk cId="843036564" sldId="360"/>
-        </pc:sldMkLst>
-      </pc:sldChg>
-      <pc:sldChg chg="del">
-        <pc:chgData name="Matthieu De Mari" userId="dfb708c9-d8dc-439f-9a3b-c772bf4a311c" providerId="ADAL" clId="{8EE40018-26BD-4A7B-8D17-70AC8417C2D0}" dt="2022-11-16T06:54:12.971" v="26" actId="47"/>
-        <pc:sldMkLst>
-          <pc:docMk/>
-          <pc:sldMk cId="1543635220" sldId="363"/>
-        </pc:sldMkLst>
-      </pc:sldChg>
-      <pc:sldChg chg="del">
-        <pc:chgData name="Matthieu De Mari" userId="dfb708c9-d8dc-439f-9a3b-c772bf4a311c" providerId="ADAL" clId="{8EE40018-26BD-4A7B-8D17-70AC8417C2D0}" dt="2022-11-16T06:54:12.971" v="26" actId="47"/>
-        <pc:sldMkLst>
-          <pc:docMk/>
-          <pc:sldMk cId="467323081" sldId="364"/>
-        </pc:sldMkLst>
-      </pc:sldChg>
-      <pc:sldChg chg="del">
-        <pc:chgData name="Matthieu De Mari" userId="dfb708c9-d8dc-439f-9a3b-c772bf4a311c" providerId="ADAL" clId="{8EE40018-26BD-4A7B-8D17-70AC8417C2D0}" dt="2022-11-16T06:54:12.971" v="26" actId="47"/>
-        <pc:sldMkLst>
-          <pc:docMk/>
-          <pc:sldMk cId="2557491043" sldId="365"/>
-        </pc:sldMkLst>
-      </pc:sldChg>
-      <pc:sldChg chg="del">
-        <pc:chgData name="Matthieu De Mari" userId="dfb708c9-d8dc-439f-9a3b-c772bf4a311c" providerId="ADAL" clId="{8EE40018-26BD-4A7B-8D17-70AC8417C2D0}" dt="2022-11-16T06:54:12.971" v="26" actId="47"/>
-        <pc:sldMkLst>
-          <pc:docMk/>
-          <pc:sldMk cId="30137941" sldId="366"/>
-        </pc:sldMkLst>
-      </pc:sldChg>
-      <pc:sldChg chg="del">
-        <pc:chgData name="Matthieu De Mari" userId="dfb708c9-d8dc-439f-9a3b-c772bf4a311c" providerId="ADAL" clId="{8EE40018-26BD-4A7B-8D17-70AC8417C2D0}" dt="2022-11-16T06:54:12.971" v="26" actId="47"/>
-        <pc:sldMkLst>
-          <pc:docMk/>
-          <pc:sldMk cId="2759705435" sldId="367"/>
-        </pc:sldMkLst>
-      </pc:sldChg>
-      <pc:sldChg chg="del">
-        <pc:chgData name="Matthieu De Mari" userId="dfb708c9-d8dc-439f-9a3b-c772bf4a311c" providerId="ADAL" clId="{8EE40018-26BD-4A7B-8D17-70AC8417C2D0}" dt="2022-11-16T06:54:12.971" v="26" actId="47"/>
-        <pc:sldMkLst>
-          <pc:docMk/>
-          <pc:sldMk cId="3578341878" sldId="368"/>
-        </pc:sldMkLst>
-      </pc:sldChg>
-      <pc:sldChg chg="del">
-        <pc:chgData name="Matthieu De Mari" userId="dfb708c9-d8dc-439f-9a3b-c772bf4a311c" providerId="ADAL" clId="{8EE40018-26BD-4A7B-8D17-70AC8417C2D0}" dt="2022-11-16T06:54:12.971" v="26" actId="47"/>
-        <pc:sldMkLst>
-          <pc:docMk/>
-          <pc:sldMk cId="2979488587" sldId="369"/>
-        </pc:sldMkLst>
-      </pc:sldChg>
-      <pc:sldChg chg="del">
-        <pc:chgData name="Matthieu De Mari" userId="dfb708c9-d8dc-439f-9a3b-c772bf4a311c" providerId="ADAL" clId="{8EE40018-26BD-4A7B-8D17-70AC8417C2D0}" dt="2022-11-16T06:54:12.971" v="26" actId="47"/>
-        <pc:sldMkLst>
-          <pc:docMk/>
-          <pc:sldMk cId="954723006" sldId="371"/>
-        </pc:sldMkLst>
-      </pc:sldChg>
-      <pc:sldChg chg="del">
-        <pc:chgData name="Matthieu De Mari" userId="dfb708c9-d8dc-439f-9a3b-c772bf4a311c" providerId="ADAL" clId="{8EE40018-26BD-4A7B-8D17-70AC8417C2D0}" dt="2022-11-16T06:54:12.971" v="26" actId="47"/>
-        <pc:sldMkLst>
-          <pc:docMk/>
-          <pc:sldMk cId="1007393074" sldId="372"/>
-        </pc:sldMkLst>
-      </pc:sldChg>
-      <pc:sldChg chg="del">
-        <pc:chgData name="Matthieu De Mari" userId="dfb708c9-d8dc-439f-9a3b-c772bf4a311c" providerId="ADAL" clId="{8EE40018-26BD-4A7B-8D17-70AC8417C2D0}" dt="2022-11-16T06:54:12.971" v="26" actId="47"/>
-        <pc:sldMkLst>
-          <pc:docMk/>
-          <pc:sldMk cId="4039951211" sldId="373"/>
-        </pc:sldMkLst>
-      </pc:sldChg>
-      <pc:sldChg chg="del">
-        <pc:chgData name="Matthieu De Mari" userId="dfb708c9-d8dc-439f-9a3b-c772bf4a311c" providerId="ADAL" clId="{8EE40018-26BD-4A7B-8D17-70AC8417C2D0}" dt="2022-11-16T06:54:12.971" v="26" actId="47"/>
-        <pc:sldMkLst>
-          <pc:docMk/>
-          <pc:sldMk cId="3074715825" sldId="374"/>
-        </pc:sldMkLst>
-      </pc:sldChg>
-      <pc:sldChg chg="del">
-        <pc:chgData name="Matthieu De Mari" userId="dfb708c9-d8dc-439f-9a3b-c772bf4a311c" providerId="ADAL" clId="{8EE40018-26BD-4A7B-8D17-70AC8417C2D0}" dt="2022-11-16T06:54:13.895" v="27" actId="47"/>
-        <pc:sldMkLst>
-          <pc:docMk/>
-          <pc:sldMk cId="1113800729" sldId="376"/>
-        </pc:sldMkLst>
-      </pc:sldChg>
-      <pc:sldChg chg="modSp mod">
-        <pc:chgData name="Matthieu De Mari" userId="dfb708c9-d8dc-439f-9a3b-c772bf4a311c" providerId="ADAL" clId="{8EE40018-26BD-4A7B-8D17-70AC8417C2D0}" dt="2022-11-16T06:53:49.572" v="12" actId="20577"/>
-        <pc:sldMkLst>
-          <pc:docMk/>
-          <pc:sldMk cId="1040156172" sldId="377"/>
-        </pc:sldMkLst>
-      </pc:sldChg>
-      <pc:sldChg chg="del">
-        <pc:chgData name="Matthieu De Mari" userId="dfb708c9-d8dc-439f-9a3b-c772bf4a311c" providerId="ADAL" clId="{8EE40018-26BD-4A7B-8D17-70AC8417C2D0}" dt="2022-11-16T06:54:08.404" v="23" actId="47"/>
-        <pc:sldMkLst>
-          <pc:docMk/>
-          <pc:sldMk cId="2236780210" sldId="378"/>
-        </pc:sldMkLst>
-      </pc:sldChg>
-      <pc:sldChg chg="del">
-        <pc:chgData name="Matthieu De Mari" userId="dfb708c9-d8dc-439f-9a3b-c772bf4a311c" providerId="ADAL" clId="{8EE40018-26BD-4A7B-8D17-70AC8417C2D0}" dt="2022-11-16T06:54:09.190" v="24" actId="47"/>
-        <pc:sldMkLst>
-          <pc:docMk/>
-          <pc:sldMk cId="3686470996" sldId="379"/>
-        </pc:sldMkLst>
-      </pc:sldChg>
-      <pc:sldChg chg="del">
-        <pc:chgData name="Matthieu De Mari" userId="dfb708c9-d8dc-439f-9a3b-c772bf4a311c" providerId="ADAL" clId="{8EE40018-26BD-4A7B-8D17-70AC8417C2D0}" dt="2022-11-16T06:54:13.895" v="27" actId="47"/>
-        <pc:sldMkLst>
-          <pc:docMk/>
-          <pc:sldMk cId="2665897880" sldId="380"/>
-        </pc:sldMkLst>
-      </pc:sldChg>
-      <pc:sldChg chg="del">
-        <pc:chgData name="Matthieu De Mari" userId="dfb708c9-d8dc-439f-9a3b-c772bf4a311c" providerId="ADAL" clId="{8EE40018-26BD-4A7B-8D17-70AC8417C2D0}" dt="2022-11-16T06:54:42.327" v="41" actId="47"/>
-        <pc:sldMkLst>
-          <pc:docMk/>
-          <pc:sldMk cId="1174542860" sldId="381"/>
-        </pc:sldMkLst>
-      </pc:sldChg>
-      <pc:sldChg chg="del">
-        <pc:chgData name="Matthieu De Mari" userId="dfb708c9-d8dc-439f-9a3b-c772bf4a311c" providerId="ADAL" clId="{8EE40018-26BD-4A7B-8D17-70AC8417C2D0}" dt="2022-11-16T06:54:07.519" v="22" actId="47"/>
-        <pc:sldMkLst>
-          <pc:docMk/>
-          <pc:sldMk cId="370210852" sldId="382"/>
-        </pc:sldMkLst>
-      </pc:sldChg>
-      <pc:sldChg chg="del">
-        <pc:chgData name="Matthieu De Mari" userId="dfb708c9-d8dc-439f-9a3b-c772bf4a311c" providerId="ADAL" clId="{8EE40018-26BD-4A7B-8D17-70AC8417C2D0}" dt="2022-11-16T06:54:06.554" v="21" actId="47"/>
-        <pc:sldMkLst>
-          <pc:docMk/>
-          <pc:sldMk cId="3654187078" sldId="383"/>
-        </pc:sldMkLst>
-      </pc:sldChg>
-      <pc:sldChg chg="del">
-        <pc:chgData name="Matthieu De Mari" userId="dfb708c9-d8dc-439f-9a3b-c772bf4a311c" providerId="ADAL" clId="{8EE40018-26BD-4A7B-8D17-70AC8417C2D0}" dt="2022-11-16T06:54:11.293" v="25" actId="47"/>
-        <pc:sldMkLst>
-          <pc:docMk/>
-          <pc:sldMk cId="1145882535" sldId="384"/>
-        </pc:sldMkLst>
-      </pc:sldChg>
-      <pc:sldChg chg="del">
-        <pc:chgData name="Matthieu De Mari" userId="dfb708c9-d8dc-439f-9a3b-c772bf4a311c" providerId="ADAL" clId="{8EE40018-26BD-4A7B-8D17-70AC8417C2D0}" dt="2022-11-16T06:54:12.971" v="26" actId="47"/>
-        <pc:sldMkLst>
-          <pc:docMk/>
-          <pc:sldMk cId="2609241577" sldId="385"/>
-        </pc:sldMkLst>
-      </pc:sldChg>
-      <pc:sldChg chg="del">
-        <pc:chgData name="Matthieu De Mari" userId="dfb708c9-d8dc-439f-9a3b-c772bf4a311c" providerId="ADAL" clId="{8EE40018-26BD-4A7B-8D17-70AC8417C2D0}" dt="2022-11-16T06:54:13.895" v="27" actId="47"/>
-        <pc:sldMkLst>
-          <pc:docMk/>
-          <pc:sldMk cId="2448415676" sldId="387"/>
-        </pc:sldMkLst>
-      </pc:sldChg>
-      <pc:sldChg chg="del">
-        <pc:chgData name="Matthieu De Mari" userId="dfb708c9-d8dc-439f-9a3b-c772bf4a311c" providerId="ADAL" clId="{8EE40018-26BD-4A7B-8D17-70AC8417C2D0}" dt="2022-11-16T06:54:13.895" v="27" actId="47"/>
-        <pc:sldMkLst>
-          <pc:docMk/>
-          <pc:sldMk cId="993695443" sldId="388"/>
-        </pc:sldMkLst>
-      </pc:sldChg>
-      <pc:sldChg chg="del">
-        <pc:chgData name="Matthieu De Mari" userId="dfb708c9-d8dc-439f-9a3b-c772bf4a311c" providerId="ADAL" clId="{8EE40018-26BD-4A7B-8D17-70AC8417C2D0}" dt="2022-11-16T06:54:13.895" v="27" actId="47"/>
-        <pc:sldMkLst>
-          <pc:docMk/>
-          <pc:sldMk cId="3051477034" sldId="389"/>
-        </pc:sldMkLst>
-      </pc:sldChg>
-      <pc:sldChg chg="del">
-        <pc:chgData name="Matthieu De Mari" userId="dfb708c9-d8dc-439f-9a3b-c772bf4a311c" providerId="ADAL" clId="{8EE40018-26BD-4A7B-8D17-70AC8417C2D0}" dt="2022-11-16T06:54:13.895" v="27" actId="47"/>
-        <pc:sldMkLst>
-          <pc:docMk/>
-          <pc:sldMk cId="2663658166" sldId="390"/>
-        </pc:sldMkLst>
-      </pc:sldChg>
-      <pc:sldChg chg="del">
-        <pc:chgData name="Matthieu De Mari" userId="dfb708c9-d8dc-439f-9a3b-c772bf4a311c" providerId="ADAL" clId="{8EE40018-26BD-4A7B-8D17-70AC8417C2D0}" dt="2022-11-16T06:54:39.791" v="40" actId="47"/>
-        <pc:sldMkLst>
-          <pc:docMk/>
-          <pc:sldMk cId="1682911312" sldId="391"/>
-        </pc:sldMkLst>
-      </pc:sldChg>
-    </pc:docChg>
-  </pc:docChgLst>
-  <pc:docChgLst>
-    <pc:chgData name="Matthieu De Mari" userId="dfb708c9-d8dc-439f-9a3b-c772bf4a311c" providerId="ADAL" clId="{1002CE28-12E1-453F-8E06-90F32FAF9697}"/>
-    <pc:docChg chg="mod delSld modSld sldOrd modMainMaster delSection modSection">
-      <pc:chgData name="Matthieu De Mari" userId="dfb708c9-d8dc-439f-9a3b-c772bf4a311c" providerId="ADAL" clId="{1002CE28-12E1-453F-8E06-90F32FAF9697}" dt="2022-10-19T06:32:13.307" v="17" actId="20577"/>
-      <pc:docMkLst>
-        <pc:docMk/>
-      </pc:docMkLst>
-      <pc:sldChg chg="modSp del mod">
-        <pc:chgData name="Matthieu De Mari" userId="dfb708c9-d8dc-439f-9a3b-c772bf4a311c" providerId="ADAL" clId="{1002CE28-12E1-453F-8E06-90F32FAF9697}" dt="2022-10-19T06:32:10.067" v="8" actId="47"/>
-        <pc:sldMkLst>
-          <pc:docMk/>
-          <pc:sldMk cId="4221035150" sldId="256"/>
-        </pc:sldMkLst>
-      </pc:sldChg>
-      <pc:sldChg chg="del">
-        <pc:chgData name="Matthieu De Mari" userId="dfb708c9-d8dc-439f-9a3b-c772bf4a311c" providerId="ADAL" clId="{1002CE28-12E1-453F-8E06-90F32FAF9697}" dt="2022-10-19T06:32:06.571" v="5" actId="47"/>
-        <pc:sldMkLst>
-          <pc:docMk/>
-          <pc:sldMk cId="2169851104" sldId="258"/>
-        </pc:sldMkLst>
-      </pc:sldChg>
-      <pc:sldChg chg="del">
-        <pc:chgData name="Matthieu De Mari" userId="dfb708c9-d8dc-439f-9a3b-c772bf4a311c" providerId="ADAL" clId="{1002CE28-12E1-453F-8E06-90F32FAF9697}" dt="2022-10-19T06:32:06.571" v="5" actId="47"/>
-        <pc:sldMkLst>
-          <pc:docMk/>
-          <pc:sldMk cId="1814682152" sldId="259"/>
-        </pc:sldMkLst>
-      </pc:sldChg>
-      <pc:sldChg chg="del">
-        <pc:chgData name="Matthieu De Mari" userId="dfb708c9-d8dc-439f-9a3b-c772bf4a311c" providerId="ADAL" clId="{1002CE28-12E1-453F-8E06-90F32FAF9697}" dt="2022-10-19T06:32:06.571" v="5" actId="47"/>
-        <pc:sldMkLst>
-          <pc:docMk/>
-          <pc:sldMk cId="753975277" sldId="260"/>
-        </pc:sldMkLst>
-      </pc:sldChg>
-      <pc:sldChg chg="del">
-        <pc:chgData name="Matthieu De Mari" userId="dfb708c9-d8dc-439f-9a3b-c772bf4a311c" providerId="ADAL" clId="{1002CE28-12E1-453F-8E06-90F32FAF9697}" dt="2022-10-19T06:32:06.571" v="5" actId="47"/>
-        <pc:sldMkLst>
-          <pc:docMk/>
-          <pc:sldMk cId="968033501" sldId="268"/>
-        </pc:sldMkLst>
-      </pc:sldChg>
-      <pc:sldChg chg="modSp mod ord">
-        <pc:chgData name="Matthieu De Mari" userId="dfb708c9-d8dc-439f-9a3b-c772bf4a311c" providerId="ADAL" clId="{1002CE28-12E1-453F-8E06-90F32FAF9697}" dt="2022-10-19T06:32:13.307" v="17" actId="20577"/>
-        <pc:sldMkLst>
-          <pc:docMk/>
-          <pc:sldMk cId="1040156172" sldId="377"/>
-        </pc:sldMkLst>
-      </pc:sldChg>
-      <pc:sldMasterChg chg="addSp mod">
-        <pc:chgData name="Matthieu De Mari" userId="dfb708c9-d8dc-439f-9a3b-c772bf4a311c" providerId="ADAL" clId="{1002CE28-12E1-453F-8E06-90F32FAF9697}" dt="2022-10-19T06:30:58.618" v="0" actId="33475"/>
-        <pc:sldMasterMkLst>
-          <pc:docMk/>
-          <pc:sldMasterMk cId="2168708284" sldId="2147483648"/>
-        </pc:sldMasterMkLst>
-      </pc:sldMasterChg>
-    </pc:docChg>
-  </pc:docChgLst>
-  <pc:docChgLst>
-    <pc:chgData name="Matthieu De Mari" userId="dfb708c9-d8dc-439f-9a3b-c772bf4a311c" providerId="ADAL" clId="{403567CB-61B7-4D72-87CB-85A35F135302}"/>
-    <pc:docChg chg="undo custSel addSld delSld modSld sldOrd addSection delSection modSection">
-      <pc:chgData name="Matthieu De Mari" userId="dfb708c9-d8dc-439f-9a3b-c772bf4a311c" providerId="ADAL" clId="{403567CB-61B7-4D72-87CB-85A35F135302}" dt="2023-02-28T06:18:00.125" v="363" actId="207"/>
-      <pc:docMkLst>
-        <pc:docMk/>
-      </pc:docMkLst>
-      <pc:sldChg chg="modSp mod">
-        <pc:chgData name="Matthieu De Mari" userId="dfb708c9-d8dc-439f-9a3b-c772bf4a311c" providerId="ADAL" clId="{403567CB-61B7-4D72-87CB-85A35F135302}" dt="2023-02-28T06:14:17.791" v="215" actId="20577"/>
-        <pc:sldMkLst>
-          <pc:docMk/>
-          <pc:sldMk cId="1036081419" sldId="346"/>
-        </pc:sldMkLst>
-      </pc:sldChg>
-      <pc:sldChg chg="del">
-        <pc:chgData name="Matthieu De Mari" userId="dfb708c9-d8dc-439f-9a3b-c772bf4a311c" providerId="ADAL" clId="{403567CB-61B7-4D72-87CB-85A35F135302}" dt="2023-02-26T09:44:35.919" v="52" actId="47"/>
-        <pc:sldMkLst>
-          <pc:docMk/>
-          <pc:sldMk cId="1040156172" sldId="377"/>
-        </pc:sldMkLst>
-      </pc:sldChg>
-      <pc:sldChg chg="del">
-        <pc:chgData name="Matthieu De Mari" userId="dfb708c9-d8dc-439f-9a3b-c772bf4a311c" providerId="ADAL" clId="{403567CB-61B7-4D72-87CB-85A35F135302}" dt="2023-02-26T09:43:40.755" v="1" actId="47"/>
-        <pc:sldMkLst>
-          <pc:docMk/>
-          <pc:sldMk cId="1119657896" sldId="378"/>
-        </pc:sldMkLst>
-      </pc:sldChg>
-      <pc:sldChg chg="del">
-        <pc:chgData name="Matthieu De Mari" userId="dfb708c9-d8dc-439f-9a3b-c772bf4a311c" providerId="ADAL" clId="{403567CB-61B7-4D72-87CB-85A35F135302}" dt="2023-02-26T09:43:39.694" v="0" actId="47"/>
-        <pc:sldMkLst>
-          <pc:docMk/>
-          <pc:sldMk cId="3946144614" sldId="379"/>
-        </pc:sldMkLst>
-      </pc:sldChg>
-      <pc:sldChg chg="del">
-        <pc:chgData name="Matthieu De Mari" userId="dfb708c9-d8dc-439f-9a3b-c772bf4a311c" providerId="ADAL" clId="{403567CB-61B7-4D72-87CB-85A35F135302}" dt="2023-02-26T09:43:40.755" v="1" actId="47"/>
-        <pc:sldMkLst>
-          <pc:docMk/>
-          <pc:sldMk cId="2141271085" sldId="380"/>
-        </pc:sldMkLst>
-      </pc:sldChg>
-      <pc:sldChg chg="del">
-        <pc:chgData name="Matthieu De Mari" userId="dfb708c9-d8dc-439f-9a3b-c772bf4a311c" providerId="ADAL" clId="{403567CB-61B7-4D72-87CB-85A35F135302}" dt="2023-02-26T09:43:40.755" v="1" actId="47"/>
-        <pc:sldMkLst>
-          <pc:docMk/>
-          <pc:sldMk cId="1990152231" sldId="381"/>
-        </pc:sldMkLst>
-      </pc:sldChg>
-      <pc:sldChg chg="del">
-        <pc:chgData name="Matthieu De Mari" userId="dfb708c9-d8dc-439f-9a3b-c772bf4a311c" providerId="ADAL" clId="{403567CB-61B7-4D72-87CB-85A35F135302}" dt="2023-02-26T09:43:40.755" v="1" actId="47"/>
-        <pc:sldMkLst>
-          <pc:docMk/>
-          <pc:sldMk cId="356330123" sldId="382"/>
-        </pc:sldMkLst>
-      </pc:sldChg>
-      <pc:sldChg chg="del">
-        <pc:chgData name="Matthieu De Mari" userId="dfb708c9-d8dc-439f-9a3b-c772bf4a311c" providerId="ADAL" clId="{403567CB-61B7-4D72-87CB-85A35F135302}" dt="2023-02-26T09:43:40.755" v="1" actId="47"/>
-        <pc:sldMkLst>
-          <pc:docMk/>
-          <pc:sldMk cId="3535228966" sldId="384"/>
-        </pc:sldMkLst>
-      </pc:sldChg>
-      <pc:sldChg chg="del">
-        <pc:chgData name="Matthieu De Mari" userId="dfb708c9-d8dc-439f-9a3b-c772bf4a311c" providerId="ADAL" clId="{403567CB-61B7-4D72-87CB-85A35F135302}" dt="2023-02-26T09:43:40.755" v="1" actId="47"/>
-        <pc:sldMkLst>
-          <pc:docMk/>
-          <pc:sldMk cId="3334002964" sldId="386"/>
-        </pc:sldMkLst>
-      </pc:sldChg>
-      <pc:sldChg chg="del">
-        <pc:chgData name="Matthieu De Mari" userId="dfb708c9-d8dc-439f-9a3b-c772bf4a311c" providerId="ADAL" clId="{403567CB-61B7-4D72-87CB-85A35F135302}" dt="2023-02-26T09:43:39.694" v="0" actId="47"/>
-        <pc:sldMkLst>
-          <pc:docMk/>
-          <pc:sldMk cId="3292999532" sldId="387"/>
-        </pc:sldMkLst>
-      </pc:sldChg>
-      <pc:sldChg chg="del">
-        <pc:chgData name="Matthieu De Mari" userId="dfb708c9-d8dc-439f-9a3b-c772bf4a311c" providerId="ADAL" clId="{403567CB-61B7-4D72-87CB-85A35F135302}" dt="2023-02-26T09:43:39.694" v="0" actId="47"/>
-        <pc:sldMkLst>
-          <pc:docMk/>
-          <pc:sldMk cId="2586666001" sldId="388"/>
-        </pc:sldMkLst>
-      </pc:sldChg>
-      <pc:sldChg chg="del">
-        <pc:chgData name="Matthieu De Mari" userId="dfb708c9-d8dc-439f-9a3b-c772bf4a311c" providerId="ADAL" clId="{403567CB-61B7-4D72-87CB-85A35F135302}" dt="2023-02-26T09:43:41.767" v="2" actId="47"/>
-        <pc:sldMkLst>
-          <pc:docMk/>
-          <pc:sldMk cId="699795487" sldId="390"/>
-        </pc:sldMkLst>
-      </pc:sldChg>
-      <pc:sldChg chg="del">
-        <pc:chgData name="Matthieu De Mari" userId="dfb708c9-d8dc-439f-9a3b-c772bf4a311c" providerId="ADAL" clId="{403567CB-61B7-4D72-87CB-85A35F135302}" dt="2023-02-26T09:43:42.904" v="3" actId="47"/>
-        <pc:sldMkLst>
-          <pc:docMk/>
-          <pc:sldMk cId="3438165640" sldId="391"/>
-        </pc:sldMkLst>
-      </pc:sldChg>
-      <pc:sldChg chg="del">
-        <pc:chgData name="Matthieu De Mari" userId="dfb708c9-d8dc-439f-9a3b-c772bf4a311c" providerId="ADAL" clId="{403567CB-61B7-4D72-87CB-85A35F135302}" dt="2023-02-26T09:43:42.904" v="3" actId="47"/>
-        <pc:sldMkLst>
-          <pc:docMk/>
-          <pc:sldMk cId="2064353129" sldId="392"/>
-        </pc:sldMkLst>
-      </pc:sldChg>
-      <pc:sldChg chg="del">
-        <pc:chgData name="Matthieu De Mari" userId="dfb708c9-d8dc-439f-9a3b-c772bf4a311c" providerId="ADAL" clId="{403567CB-61B7-4D72-87CB-85A35F135302}" dt="2023-02-26T09:43:41.767" v="2" actId="47"/>
-        <pc:sldMkLst>
-          <pc:docMk/>
-          <pc:sldMk cId="3842187934" sldId="393"/>
-        </pc:sldMkLst>
-      </pc:sldChg>
-      <pc:sldChg chg="del">
-        <pc:chgData name="Matthieu De Mari" userId="dfb708c9-d8dc-439f-9a3b-c772bf4a311c" providerId="ADAL" clId="{403567CB-61B7-4D72-87CB-85A35F135302}" dt="2023-02-26T09:43:41.767" v="2" actId="47"/>
-        <pc:sldMkLst>
-          <pc:docMk/>
-          <pc:sldMk cId="781649533" sldId="394"/>
-        </pc:sldMkLst>
-      </pc:sldChg>
-      <pc:sldChg chg="del">
-        <pc:chgData name="Matthieu De Mari" userId="dfb708c9-d8dc-439f-9a3b-c772bf4a311c" providerId="ADAL" clId="{403567CB-61B7-4D72-87CB-85A35F135302}" dt="2023-02-26T09:43:41.767" v="2" actId="47"/>
-        <pc:sldMkLst>
-          <pc:docMk/>
-          <pc:sldMk cId="2316878562" sldId="395"/>
-        </pc:sldMkLst>
-      </pc:sldChg>
-      <pc:sldChg chg="del">
-        <pc:chgData name="Matthieu De Mari" userId="dfb708c9-d8dc-439f-9a3b-c772bf4a311c" providerId="ADAL" clId="{403567CB-61B7-4D72-87CB-85A35F135302}" dt="2023-02-26T09:43:42.904" v="3" actId="47"/>
-        <pc:sldMkLst>
-          <pc:docMk/>
-          <pc:sldMk cId="1870305378" sldId="396"/>
-        </pc:sldMkLst>
-      </pc:sldChg>
-      <pc:sldChg chg="del">
-        <pc:chgData name="Matthieu De Mari" userId="dfb708c9-d8dc-439f-9a3b-c772bf4a311c" providerId="ADAL" clId="{403567CB-61B7-4D72-87CB-85A35F135302}" dt="2023-02-26T09:43:42.904" v="3" actId="47"/>
-        <pc:sldMkLst>
-          <pc:docMk/>
-          <pc:sldMk cId="1413966137" sldId="397"/>
-        </pc:sldMkLst>
-      </pc:sldChg>
-      <pc:sldChg chg="del">
-        <pc:chgData name="Matthieu De Mari" userId="dfb708c9-d8dc-439f-9a3b-c772bf4a311c" providerId="ADAL" clId="{403567CB-61B7-4D72-87CB-85A35F135302}" dt="2023-02-26T09:43:44.047" v="4" actId="47"/>
-        <pc:sldMkLst>
-          <pc:docMk/>
-          <pc:sldMk cId="2506346402" sldId="398"/>
-        </pc:sldMkLst>
-      </pc:sldChg>
-      <pc:sldChg chg="del">
-        <pc:chgData name="Matthieu De Mari" userId="dfb708c9-d8dc-439f-9a3b-c772bf4a311c" providerId="ADAL" clId="{403567CB-61B7-4D72-87CB-85A35F135302}" dt="2023-02-26T09:43:44.047" v="4" actId="47"/>
-        <pc:sldMkLst>
-          <pc:docMk/>
-          <pc:sldMk cId="1835834167" sldId="399"/>
-        </pc:sldMkLst>
-      </pc:sldChg>
-      <pc:sldChg chg="del">
-        <pc:chgData name="Matthieu De Mari" userId="dfb708c9-d8dc-439f-9a3b-c772bf4a311c" providerId="ADAL" clId="{403567CB-61B7-4D72-87CB-85A35F135302}" dt="2023-02-26T09:43:42.904" v="3" actId="47"/>
-        <pc:sldMkLst>
-          <pc:docMk/>
-          <pc:sldMk cId="4048808033" sldId="400"/>
-        </pc:sldMkLst>
-      </pc:sldChg>
-      <pc:sldChg chg="del">
-        <pc:chgData name="Matthieu De Mari" userId="dfb708c9-d8dc-439f-9a3b-c772bf4a311c" providerId="ADAL" clId="{403567CB-61B7-4D72-87CB-85A35F135302}" dt="2023-02-26T09:43:44.047" v="4" actId="47"/>
-        <pc:sldMkLst>
-          <pc:docMk/>
-          <pc:sldMk cId="736987387" sldId="402"/>
-        </pc:sldMkLst>
-      </pc:sldChg>
-      <pc:sldChg chg="del">
-        <pc:chgData name="Matthieu De Mari" userId="dfb708c9-d8dc-439f-9a3b-c772bf4a311c" providerId="ADAL" clId="{403567CB-61B7-4D72-87CB-85A35F135302}" dt="2023-02-26T09:43:44.047" v="4" actId="47"/>
-        <pc:sldMkLst>
-          <pc:docMk/>
-          <pc:sldMk cId="105113267" sldId="403"/>
-        </pc:sldMkLst>
-      </pc:sldChg>
-      <pc:sldChg chg="del">
-        <pc:chgData name="Matthieu De Mari" userId="dfb708c9-d8dc-439f-9a3b-c772bf4a311c" providerId="ADAL" clId="{403567CB-61B7-4D72-87CB-85A35F135302}" dt="2023-02-26T09:44:31.317" v="49" actId="47"/>
-        <pc:sldMkLst>
-          <pc:docMk/>
-          <pc:sldMk cId="1663617131" sldId="404"/>
-        </pc:sldMkLst>
-      </pc:sldChg>
-      <pc:sldChg chg="del">
-        <pc:chgData name="Matthieu De Mari" userId="dfb708c9-d8dc-439f-9a3b-c772bf4a311c" providerId="ADAL" clId="{403567CB-61B7-4D72-87CB-85A35F135302}" dt="2023-02-26T09:43:45.724" v="5" actId="47"/>
-        <pc:sldMkLst>
-          <pc:docMk/>
-          <pc:sldMk cId="2755235485" sldId="405"/>
-        </pc:sldMkLst>
-      </pc:sldChg>
-      <pc:sldChg chg="del">
-        <pc:chgData name="Matthieu De Mari" userId="dfb708c9-d8dc-439f-9a3b-c772bf4a311c" providerId="ADAL" clId="{403567CB-61B7-4D72-87CB-85A35F135302}" dt="2023-02-26T09:43:49.943" v="7" actId="47"/>
-        <pc:sldMkLst>
-          <pc:docMk/>
-          <pc:sldMk cId="2781272903" sldId="406"/>
-        </pc:sldMkLst>
-      </pc:sldChg>
-      <pc:sldChg chg="del">
-        <pc:chgData name="Matthieu De Mari" userId="dfb708c9-d8dc-439f-9a3b-c772bf4a311c" providerId="ADAL" clId="{403567CB-61B7-4D72-87CB-85A35F135302}" dt="2023-02-26T09:44:31.317" v="49" actId="47"/>
-        <pc:sldMkLst>
-          <pc:docMk/>
-          <pc:sldMk cId="3078664734" sldId="574"/>
-        </pc:sldMkLst>
-      </pc:sldChg>
-      <pc:sldChg chg="del">
-        <pc:chgData name="Matthieu De Mari" userId="dfb708c9-d8dc-439f-9a3b-c772bf4a311c" providerId="ADAL" clId="{403567CB-61B7-4D72-87CB-85A35F135302}" dt="2023-02-26T09:43:45.724" v="5" actId="47"/>
-        <pc:sldMkLst>
-          <pc:docMk/>
-          <pc:sldMk cId="3542276236" sldId="575"/>
-        </pc:sldMkLst>
-      </pc:sldChg>
-      <pc:sldChg chg="del">
-        <pc:chgData name="Matthieu De Mari" userId="dfb708c9-d8dc-439f-9a3b-c772bf4a311c" providerId="ADAL" clId="{403567CB-61B7-4D72-87CB-85A35F135302}" dt="2023-02-26T09:43:45.724" v="5" actId="47"/>
-        <pc:sldMkLst>
-          <pc:docMk/>
-          <pc:sldMk cId="1343460073" sldId="576"/>
-        </pc:sldMkLst>
-      </pc:sldChg>
-      <pc:sldChg chg="del">
-        <pc:chgData name="Matthieu De Mari" userId="dfb708c9-d8dc-439f-9a3b-c772bf4a311c" providerId="ADAL" clId="{403567CB-61B7-4D72-87CB-85A35F135302}" dt="2023-02-26T09:43:45.724" v="5" actId="47"/>
-        <pc:sldMkLst>
-          <pc:docMk/>
-          <pc:sldMk cId="3821622736" sldId="577"/>
-        </pc:sldMkLst>
-      </pc:sldChg>
-      <pc:sldChg chg="del">
-        <pc:chgData name="Matthieu De Mari" userId="dfb708c9-d8dc-439f-9a3b-c772bf4a311c" providerId="ADAL" clId="{403567CB-61B7-4D72-87CB-85A35F135302}" dt="2023-02-26T09:43:47.843" v="6" actId="47"/>
-        <pc:sldMkLst>
-          <pc:docMk/>
-          <pc:sldMk cId="3867797258" sldId="578"/>
-        </pc:sldMkLst>
-      </pc:sldChg>
-      <pc:sldChg chg="del">
-        <pc:chgData name="Matthieu De Mari" userId="dfb708c9-d8dc-439f-9a3b-c772bf4a311c" providerId="ADAL" clId="{403567CB-61B7-4D72-87CB-85A35F135302}" dt="2023-02-26T09:43:45.724" v="5" actId="47"/>
-        <pc:sldMkLst>
-          <pc:docMk/>
-          <pc:sldMk cId="884373967" sldId="580"/>
-        </pc:sldMkLst>
-      </pc:sldChg>
-      <pc:sldChg chg="del">
-        <pc:chgData name="Matthieu De Mari" userId="dfb708c9-d8dc-439f-9a3b-c772bf4a311c" providerId="ADAL" clId="{403567CB-61B7-4D72-87CB-85A35F135302}" dt="2023-02-26T09:43:47.843" v="6" actId="47"/>
-        <pc:sldMkLst>
-          <pc:docMk/>
-          <pc:sldMk cId="4262229869" sldId="581"/>
-        </pc:sldMkLst>
-      </pc:sldChg>
-      <pc:sldChg chg="del">
-        <pc:chgData name="Matthieu De Mari" userId="dfb708c9-d8dc-439f-9a3b-c772bf4a311c" providerId="ADAL" clId="{403567CB-61B7-4D72-87CB-85A35F135302}" dt="2023-02-26T09:43:49.943" v="7" actId="47"/>
-        <pc:sldMkLst>
-          <pc:docMk/>
-          <pc:sldMk cId="445144023" sldId="582"/>
-        </pc:sldMkLst>
-      </pc:sldChg>
-      <pc:sldChg chg="del">
-        <pc:chgData name="Matthieu De Mari" userId="dfb708c9-d8dc-439f-9a3b-c772bf4a311c" providerId="ADAL" clId="{403567CB-61B7-4D72-87CB-85A35F135302}" dt="2023-02-26T09:43:49.943" v="7" actId="47"/>
-        <pc:sldMkLst>
-          <pc:docMk/>
-          <pc:sldMk cId="1327648275" sldId="583"/>
-        </pc:sldMkLst>
-      </pc:sldChg>
-      <pc:sldChg chg="del">
-        <pc:chgData name="Matthieu De Mari" userId="dfb708c9-d8dc-439f-9a3b-c772bf4a311c" providerId="ADAL" clId="{403567CB-61B7-4D72-87CB-85A35F135302}" dt="2023-02-26T09:43:49.943" v="7" actId="47"/>
-        <pc:sldMkLst>
-          <pc:docMk/>
-          <pc:sldMk cId="1700821507" sldId="584"/>
-        </pc:sldMkLst>
-      </pc:sldChg>
-      <pc:sldChg chg="del">
-        <pc:chgData name="Matthieu De Mari" userId="dfb708c9-d8dc-439f-9a3b-c772bf4a311c" providerId="ADAL" clId="{403567CB-61B7-4D72-87CB-85A35F135302}" dt="2023-02-26T09:43:49.943" v="7" actId="47"/>
-        <pc:sldMkLst>
-          <pc:docMk/>
-          <pc:sldMk cId="2986323806" sldId="585"/>
-        </pc:sldMkLst>
-      </pc:sldChg>
-      <pc:sldChg chg="del">
-        <pc:chgData name="Matthieu De Mari" userId="dfb708c9-d8dc-439f-9a3b-c772bf4a311c" providerId="ADAL" clId="{403567CB-61B7-4D72-87CB-85A35F135302}" dt="2023-02-26T09:43:49.943" v="7" actId="47"/>
-        <pc:sldMkLst>
-          <pc:docMk/>
-          <pc:sldMk cId="2080496661" sldId="586"/>
-        </pc:sldMkLst>
-      </pc:sldChg>
-      <pc:sldChg chg="del">
-        <pc:chgData name="Matthieu De Mari" userId="dfb708c9-d8dc-439f-9a3b-c772bf4a311c" providerId="ADAL" clId="{403567CB-61B7-4D72-87CB-85A35F135302}" dt="2023-02-26T09:44:31.317" v="49" actId="47"/>
-        <pc:sldMkLst>
-          <pc:docMk/>
-          <pc:sldMk cId="2743590117" sldId="588"/>
-        </pc:sldMkLst>
-      </pc:sldChg>
-      <pc:sldChg chg="del">
-        <pc:chgData name="Matthieu De Mari" userId="dfb708c9-d8dc-439f-9a3b-c772bf4a311c" providerId="ADAL" clId="{403567CB-61B7-4D72-87CB-85A35F135302}" dt="2023-02-26T09:44:31.317" v="49" actId="47"/>
-        <pc:sldMkLst>
-          <pc:docMk/>
-          <pc:sldMk cId="1885554493" sldId="589"/>
-        </pc:sldMkLst>
-      </pc:sldChg>
-      <pc:sldChg chg="ord">
-        <pc:chgData name="Matthieu De Mari" userId="dfb708c9-d8dc-439f-9a3b-c772bf4a311c" providerId="ADAL" clId="{403567CB-61B7-4D72-87CB-85A35F135302}" dt="2023-02-26T09:44:34.303" v="51"/>
-        <pc:sldMkLst>
-          <pc:docMk/>
-          <pc:sldMk cId="37425589" sldId="591"/>
-        </pc:sldMkLst>
-      </pc:sldChg>
-      <pc:sldChg chg="del">
-        <pc:chgData name="Matthieu De Mari" userId="dfb708c9-d8dc-439f-9a3b-c772bf4a311c" providerId="ADAL" clId="{403567CB-61B7-4D72-87CB-85A35F135302}" dt="2023-02-26T09:43:49.943" v="7" actId="47"/>
-        <pc:sldMkLst>
-          <pc:docMk/>
-          <pc:sldMk cId="3292545768" sldId="596"/>
-        </pc:sldMkLst>
-      </pc:sldChg>
-      <pc:sldChg chg="del">
-        <pc:chgData name="Matthieu De Mari" userId="dfb708c9-d8dc-439f-9a3b-c772bf4a311c" providerId="ADAL" clId="{403567CB-61B7-4D72-87CB-85A35F135302}" dt="2023-02-28T06:08:27.444" v="55" actId="47"/>
-        <pc:sldMkLst>
-          <pc:docMk/>
-          <pc:sldMk cId="337788125" sldId="597"/>
-        </pc:sldMkLst>
-      </pc:sldChg>
-      <pc:sldChg chg="modSp">
-        <pc:chgData name="Matthieu De Mari" userId="dfb708c9-d8dc-439f-9a3b-c772bf4a311c" providerId="ADAL" clId="{403567CB-61B7-4D72-87CB-85A35F135302}" dt="2023-02-28T06:15:15.666" v="292" actId="113"/>
-        <pc:sldMkLst>
-          <pc:docMk/>
-          <pc:sldMk cId="3298110552" sldId="641"/>
-        </pc:sldMkLst>
-      </pc:sldChg>
-      <pc:sldChg chg="modSp mod">
-        <pc:chgData name="Matthieu De Mari" userId="dfb708c9-d8dc-439f-9a3b-c772bf4a311c" providerId="ADAL" clId="{403567CB-61B7-4D72-87CB-85A35F135302}" dt="2023-02-28T06:16:20.728" v="303" actId="20577"/>
-        <pc:sldMkLst>
-          <pc:docMk/>
-          <pc:sldMk cId="1850403076" sldId="645"/>
-        </pc:sldMkLst>
-      </pc:sldChg>
-      <pc:sldChg chg="modSp mod">
-        <pc:chgData name="Matthieu De Mari" userId="dfb708c9-d8dc-439f-9a3b-c772bf4a311c" providerId="ADAL" clId="{403567CB-61B7-4D72-87CB-85A35F135302}" dt="2023-02-28T06:16:35.626" v="309" actId="113"/>
-        <pc:sldMkLst>
-          <pc:docMk/>
-          <pc:sldMk cId="3708794977" sldId="646"/>
-        </pc:sldMkLst>
-      </pc:sldChg>
-      <pc:sldChg chg="modSp mod">
-        <pc:chgData name="Matthieu De Mari" userId="dfb708c9-d8dc-439f-9a3b-c772bf4a311c" providerId="ADAL" clId="{403567CB-61B7-4D72-87CB-85A35F135302}" dt="2023-02-28T06:16:50.571" v="319" actId="113"/>
-        <pc:sldMkLst>
-          <pc:docMk/>
-          <pc:sldMk cId="2404237809" sldId="648"/>
-        </pc:sldMkLst>
-      </pc:sldChg>
-      <pc:sldChg chg="modSp mod">
-        <pc:chgData name="Matthieu De Mari" userId="dfb708c9-d8dc-439f-9a3b-c772bf4a311c" providerId="ADAL" clId="{403567CB-61B7-4D72-87CB-85A35F135302}" dt="2023-02-28T06:11:56.660" v="138" actId="20577"/>
-        <pc:sldMkLst>
-          <pc:docMk/>
-          <pc:sldMk cId="3215884619" sldId="650"/>
-        </pc:sldMkLst>
-      </pc:sldChg>
-      <pc:sldChg chg="addSp delSp modSp mod">
-        <pc:chgData name="Matthieu De Mari" userId="dfb708c9-d8dc-439f-9a3b-c772bf4a311c" providerId="ADAL" clId="{403567CB-61B7-4D72-87CB-85A35F135302}" dt="2023-02-28T06:16:25.409" v="308" actId="20577"/>
-        <pc:sldMkLst>
-          <pc:docMk/>
-          <pc:sldMk cId="773672680" sldId="652"/>
-        </pc:sldMkLst>
-      </pc:sldChg>
-      <pc:sldChg chg="modSp mod">
-        <pc:chgData name="Matthieu De Mari" userId="dfb708c9-d8dc-439f-9a3b-c772bf4a311c" providerId="ADAL" clId="{403567CB-61B7-4D72-87CB-85A35F135302}" dt="2023-02-28T06:17:49.500" v="358" actId="207"/>
-        <pc:sldMkLst>
-          <pc:docMk/>
-          <pc:sldMk cId="855321949" sldId="653"/>
-        </pc:sldMkLst>
-      </pc:sldChg>
-      <pc:sldChg chg="modSp mod">
-        <pc:chgData name="Matthieu De Mari" userId="dfb708c9-d8dc-439f-9a3b-c772bf4a311c" providerId="ADAL" clId="{403567CB-61B7-4D72-87CB-85A35F135302}" dt="2023-02-28T06:18:00.125" v="363" actId="207"/>
-        <pc:sldMkLst>
-          <pc:docMk/>
-          <pc:sldMk cId="2099660639" sldId="654"/>
-        </pc:sldMkLst>
-      </pc:sldChg>
-      <pc:sldChg chg="modSp">
-        <pc:chgData name="Matthieu De Mari" userId="dfb708c9-d8dc-439f-9a3b-c772bf4a311c" providerId="ADAL" clId="{403567CB-61B7-4D72-87CB-85A35F135302}" dt="2023-02-28T06:13:07.100" v="157" actId="20577"/>
-        <pc:sldMkLst>
-          <pc:docMk/>
-          <pc:sldMk cId="2451971174" sldId="655"/>
-        </pc:sldMkLst>
-      </pc:sldChg>
-      <pc:sldChg chg="modSp mod">
-        <pc:chgData name="Matthieu De Mari" userId="dfb708c9-d8dc-439f-9a3b-c772bf4a311c" providerId="ADAL" clId="{403567CB-61B7-4D72-87CB-85A35F135302}" dt="2023-02-28T06:13:16.340" v="172" actId="20577"/>
-        <pc:sldMkLst>
-          <pc:docMk/>
-          <pc:sldMk cId="4035742227" sldId="658"/>
-        </pc:sldMkLst>
-      </pc:sldChg>
-      <pc:sldChg chg="modSp mod">
-        <pc:chgData name="Matthieu De Mari" userId="dfb708c9-d8dc-439f-9a3b-c772bf4a311c" providerId="ADAL" clId="{403567CB-61B7-4D72-87CB-85A35F135302}" dt="2023-02-28T06:13:54.567" v="210" actId="20577"/>
-        <pc:sldMkLst>
-          <pc:docMk/>
-          <pc:sldMk cId="2303339168" sldId="661"/>
-        </pc:sldMkLst>
-      </pc:sldChg>
-      <pc:sldChg chg="modSp mod">
-        <pc:chgData name="Matthieu De Mari" userId="dfb708c9-d8dc-439f-9a3b-c772bf4a311c" providerId="ADAL" clId="{403567CB-61B7-4D72-87CB-85A35F135302}" dt="2023-02-28T06:14:05.133" v="211"/>
-        <pc:sldMkLst>
-          <pc:docMk/>
-          <pc:sldMk cId="365986058" sldId="663"/>
-        </pc:sldMkLst>
-      </pc:sldChg>
-      <pc:sldChg chg="addSp delSp modSp new mod modClrScheme chgLayout">
-        <pc:chgData name="Matthieu De Mari" userId="dfb708c9-d8dc-439f-9a3b-c772bf4a311c" providerId="ADAL" clId="{403567CB-61B7-4D72-87CB-85A35F135302}" dt="2023-02-28T06:14:59.372" v="291" actId="20577"/>
-        <pc:sldMkLst>
-          <pc:docMk/>
-          <pc:sldMk cId="2175023596" sldId="664"/>
-        </pc:sldMkLst>
-      </pc:sldChg>
-      <pc:sldChg chg="addSp delSp modSp new del mod modClrScheme chgLayout">
-        <pc:chgData name="Matthieu De Mari" userId="dfb708c9-d8dc-439f-9a3b-c772bf4a311c" providerId="ADAL" clId="{403567CB-61B7-4D72-87CB-85A35F135302}" dt="2023-02-26T09:44:19.157" v="48" actId="47"/>
-        <pc:sldMkLst>
-          <pc:docMk/>
-          <pc:sldMk cId="2187151882" sldId="664"/>
-        </pc:sldMkLst>
-      </pc:sldChg>
-    </pc:docChg>
-  </pc:docChgLst>
-  <pc:docChgLst>
-    <pc:chgData name="Matthieu De Mari" userId="dfb708c9-d8dc-439f-9a3b-c772bf4a311c" providerId="ADAL" clId="{AFBB5070-511B-4CA0-9A42-F23C012C9EC3}"/>
-    <pc:docChg chg="undo custSel addSld delSld modSld delSection modSection">
-      <pc:chgData name="Matthieu De Mari" userId="dfb708c9-d8dc-439f-9a3b-c772bf4a311c" providerId="ADAL" clId="{AFBB5070-511B-4CA0-9A42-F23C012C9EC3}" dt="2024-03-05T09:25:46.441" v="2293" actId="47"/>
-      <pc:docMkLst>
-        <pc:docMk/>
-      </pc:docMkLst>
-      <pc:sldChg chg="modSp mod">
-        <pc:chgData name="Matthieu De Mari" userId="dfb708c9-d8dc-439f-9a3b-c772bf4a311c" providerId="ADAL" clId="{AFBB5070-511B-4CA0-9A42-F23C012C9EC3}" dt="2024-02-09T00:48:57.597" v="0" actId="207"/>
-        <pc:sldMkLst>
-          <pc:docMk/>
-          <pc:sldMk cId="3442501962" sldId="257"/>
-        </pc:sldMkLst>
-      </pc:sldChg>
-      <pc:sldChg chg="modSp del mod">
-        <pc:chgData name="Matthieu De Mari" userId="dfb708c9-d8dc-439f-9a3b-c772bf4a311c" providerId="ADAL" clId="{AFBB5070-511B-4CA0-9A42-F23C012C9EC3}" dt="2024-03-05T09:25:43.622" v="2292" actId="47"/>
-        <pc:sldMkLst>
-          <pc:docMk/>
-          <pc:sldMk cId="1036081419" sldId="346"/>
-        </pc:sldMkLst>
-      </pc:sldChg>
-      <pc:sldChg chg="del">
-        <pc:chgData name="Matthieu De Mari" userId="dfb708c9-d8dc-439f-9a3b-c772bf4a311c" providerId="ADAL" clId="{AFBB5070-511B-4CA0-9A42-F23C012C9EC3}" dt="2024-02-09T00:49:42.822" v="1" actId="47"/>
-        <pc:sldMkLst>
-          <pc:docMk/>
-          <pc:sldMk cId="3425780644" sldId="407"/>
-        </pc:sldMkLst>
-      </pc:sldChg>
-      <pc:sldChg chg="modSp mod">
-        <pc:chgData name="Matthieu De Mari" userId="dfb708c9-d8dc-439f-9a3b-c772bf4a311c" providerId="ADAL" clId="{AFBB5070-511B-4CA0-9A42-F23C012C9EC3}" dt="2024-02-09T00:50:16.570" v="45" actId="20577"/>
-        <pc:sldMkLst>
-          <pc:docMk/>
-          <pc:sldMk cId="1390758074" sldId="599"/>
-        </pc:sldMkLst>
-      </pc:sldChg>
-      <pc:sldChg chg="modSp mod">
-        <pc:chgData name="Matthieu De Mari" userId="dfb708c9-d8dc-439f-9a3b-c772bf4a311c" providerId="ADAL" clId="{AFBB5070-511B-4CA0-9A42-F23C012C9EC3}" dt="2024-02-09T00:51:45.116" v="59" actId="20577"/>
-        <pc:sldMkLst>
-          <pc:docMk/>
-          <pc:sldMk cId="1913740079" sldId="601"/>
-        </pc:sldMkLst>
-      </pc:sldChg>
-      <pc:sldChg chg="modSp mod">
-        <pc:chgData name="Matthieu De Mari" userId="dfb708c9-d8dc-439f-9a3b-c772bf4a311c" providerId="ADAL" clId="{AFBB5070-511B-4CA0-9A42-F23C012C9EC3}" dt="2024-03-05T09:01:06.191" v="1306" actId="14100"/>
-        <pc:sldMkLst>
-          <pc:docMk/>
-          <pc:sldMk cId="4011461575" sldId="602"/>
-        </pc:sldMkLst>
-      </pc:sldChg>
-      <pc:sldChg chg="modSp mod">
-        <pc:chgData name="Matthieu De Mari" userId="dfb708c9-d8dc-439f-9a3b-c772bf4a311c" providerId="ADAL" clId="{AFBB5070-511B-4CA0-9A42-F23C012C9EC3}" dt="2024-02-09T00:52:30.450" v="87" actId="27636"/>
-        <pc:sldMkLst>
-          <pc:docMk/>
-          <pc:sldMk cId="2445909842" sldId="603"/>
-        </pc:sldMkLst>
-      </pc:sldChg>
-      <pc:sldChg chg="modSp mod">
-        <pc:chgData name="Matthieu De Mari" userId="dfb708c9-d8dc-439f-9a3b-c772bf4a311c" providerId="ADAL" clId="{AFBB5070-511B-4CA0-9A42-F23C012C9EC3}" dt="2024-02-09T00:52:44.719" v="94" actId="20577"/>
-        <pc:sldMkLst>
-          <pc:docMk/>
-          <pc:sldMk cId="1888637577" sldId="604"/>
-        </pc:sldMkLst>
-      </pc:sldChg>
-      <pc:sldChg chg="addSp delSp modSp mod">
-        <pc:chgData name="Matthieu De Mari" userId="dfb708c9-d8dc-439f-9a3b-c772bf4a311c" providerId="ADAL" clId="{AFBB5070-511B-4CA0-9A42-F23C012C9EC3}" dt="2024-03-05T09:23:46.134" v="2282" actId="1076"/>
-        <pc:sldMkLst>
-          <pc:docMk/>
-          <pc:sldMk cId="544744450" sldId="606"/>
-        </pc:sldMkLst>
-      </pc:sldChg>
-      <pc:sldChg chg="addSp delSp modSp mod">
-        <pc:chgData name="Matthieu De Mari" userId="dfb708c9-d8dc-439f-9a3b-c772bf4a311c" providerId="ADAL" clId="{AFBB5070-511B-4CA0-9A42-F23C012C9EC3}" dt="2024-03-05T09:22:55.335" v="2277" actId="1076"/>
-        <pc:sldMkLst>
-          <pc:docMk/>
-          <pc:sldMk cId="2835508014" sldId="607"/>
-        </pc:sldMkLst>
-      </pc:sldChg>
-      <pc:sldChg chg="modSp mod">
-        <pc:chgData name="Matthieu De Mari" userId="dfb708c9-d8dc-439f-9a3b-c772bf4a311c" providerId="ADAL" clId="{AFBB5070-511B-4CA0-9A42-F23C012C9EC3}" dt="2024-03-05T09:21:29.328" v="2265" actId="20577"/>
-        <pc:sldMkLst>
-          <pc:docMk/>
-          <pc:sldMk cId="1655947162" sldId="611"/>
-        </pc:sldMkLst>
-      </pc:sldChg>
-      <pc:sldChg chg="addSp delSp modSp mod">
-        <pc:chgData name="Matthieu De Mari" userId="dfb708c9-d8dc-439f-9a3b-c772bf4a311c" providerId="ADAL" clId="{AFBB5070-511B-4CA0-9A42-F23C012C9EC3}" dt="2024-03-05T09:22:20.716" v="2270" actId="14100"/>
-        <pc:sldMkLst>
-          <pc:docMk/>
-          <pc:sldMk cId="1079237185" sldId="612"/>
-        </pc:sldMkLst>
-      </pc:sldChg>
-      <pc:sldChg chg="modSp">
-        <pc:chgData name="Matthieu De Mari" userId="dfb708c9-d8dc-439f-9a3b-c772bf4a311c" providerId="ADAL" clId="{AFBB5070-511B-4CA0-9A42-F23C012C9EC3}" dt="2024-03-05T09:21:08.403" v="2230" actId="20577"/>
-        <pc:sldMkLst>
-          <pc:docMk/>
-          <pc:sldMk cId="3584089474" sldId="613"/>
-        </pc:sldMkLst>
-      </pc:sldChg>
-      <pc:sldChg chg="addSp delSp modSp mod">
-        <pc:chgData name="Matthieu De Mari" userId="dfb708c9-d8dc-439f-9a3b-c772bf4a311c" providerId="ADAL" clId="{AFBB5070-511B-4CA0-9A42-F23C012C9EC3}" dt="2024-03-05T09:24:36.942" v="2287" actId="1076"/>
-        <pc:sldMkLst>
-          <pc:docMk/>
-          <pc:sldMk cId="1478687394" sldId="615"/>
-        </pc:sldMkLst>
-      </pc:sldChg>
-      <pc:sldChg chg="addSp delSp modSp mod modClrScheme chgLayout">
-        <pc:chgData name="Matthieu De Mari" userId="dfb708c9-d8dc-439f-9a3b-c772bf4a311c" providerId="ADAL" clId="{AFBB5070-511B-4CA0-9A42-F23C012C9EC3}" dt="2024-02-27T02:39:21.271" v="565" actId="207"/>
-        <pc:sldMkLst>
-          <pc:docMk/>
-          <pc:sldMk cId="2697134679" sldId="616"/>
-        </pc:sldMkLst>
-      </pc:sldChg>
-      <pc:sldChg chg="modSp mod">
-        <pc:chgData name="Matthieu De Mari" userId="dfb708c9-d8dc-439f-9a3b-c772bf4a311c" providerId="ADAL" clId="{AFBB5070-511B-4CA0-9A42-F23C012C9EC3}" dt="2024-02-09T00:53:57.046" v="168" actId="115"/>
-        <pc:sldMkLst>
-          <pc:docMk/>
-          <pc:sldMk cId="1087818113" sldId="617"/>
-        </pc:sldMkLst>
-      </pc:sldChg>
-      <pc:sldChg chg="addSp delSp modSp mod modClrScheme chgLayout">
-        <pc:chgData name="Matthieu De Mari" userId="dfb708c9-d8dc-439f-9a3b-c772bf4a311c" providerId="ADAL" clId="{AFBB5070-511B-4CA0-9A42-F23C012C9EC3}" dt="2024-02-27T02:40:05.950" v="682" actId="20577"/>
-        <pc:sldMkLst>
-          <pc:docMk/>
-          <pc:sldMk cId="2052607657" sldId="619"/>
-        </pc:sldMkLst>
-      </pc:sldChg>
-      <pc:sldChg chg="modSp mod">
-        <pc:chgData name="Matthieu De Mari" userId="dfb708c9-d8dc-439f-9a3b-c772bf4a311c" providerId="ADAL" clId="{AFBB5070-511B-4CA0-9A42-F23C012C9EC3}" dt="2024-03-05T09:10:31.976" v="1975" actId="20577"/>
-        <pc:sldMkLst>
-          <pc:docMk/>
-          <pc:sldMk cId="3109980527" sldId="624"/>
-        </pc:sldMkLst>
-      </pc:sldChg>
-      <pc:sldChg chg="modSp">
-        <pc:chgData name="Matthieu De Mari" userId="dfb708c9-d8dc-439f-9a3b-c772bf4a311c" providerId="ADAL" clId="{AFBB5070-511B-4CA0-9A42-F23C012C9EC3}" dt="2024-03-05T09:17:29.333" v="2199" actId="20577"/>
-        <pc:sldMkLst>
-          <pc:docMk/>
-          <pc:sldMk cId="491578291" sldId="627"/>
-        </pc:sldMkLst>
-      </pc:sldChg>
-      <pc:sldChg chg="addSp delSp modSp mod">
-        <pc:chgData name="Matthieu De Mari" userId="dfb708c9-d8dc-439f-9a3b-c772bf4a311c" providerId="ADAL" clId="{AFBB5070-511B-4CA0-9A42-F23C012C9EC3}" dt="2024-03-05T09:18:44.315" v="2205" actId="1076"/>
-        <pc:sldMkLst>
-          <pc:docMk/>
-          <pc:sldMk cId="4059265678" sldId="628"/>
-        </pc:sldMkLst>
-      </pc:sldChg>
-      <pc:sldChg chg="addSp delSp modSp mod">
-        <pc:chgData name="Matthieu De Mari" userId="dfb708c9-d8dc-439f-9a3b-c772bf4a311c" providerId="ADAL" clId="{AFBB5070-511B-4CA0-9A42-F23C012C9EC3}" dt="2024-03-05T09:19:23.738" v="2214" actId="1035"/>
-        <pc:sldMkLst>
-          <pc:docMk/>
-          <pc:sldMk cId="2696285505" sldId="629"/>
-        </pc:sldMkLst>
-      </pc:sldChg>
-      <pc:sldChg chg="modSp mod">
-        <pc:chgData name="Matthieu De Mari" userId="dfb708c9-d8dc-439f-9a3b-c772bf4a311c" providerId="ADAL" clId="{AFBB5070-511B-4CA0-9A42-F23C012C9EC3}" dt="2024-02-09T00:58:01.890" v="308" actId="1076"/>
-        <pc:sldMkLst>
-          <pc:docMk/>
-          <pc:sldMk cId="3403244392" sldId="630"/>
-        </pc:sldMkLst>
-      </pc:sldChg>
-      <pc:sldChg chg="addSp delSp modSp mod">
-        <pc:chgData name="Matthieu De Mari" userId="dfb708c9-d8dc-439f-9a3b-c772bf4a311c" providerId="ADAL" clId="{AFBB5070-511B-4CA0-9A42-F23C012C9EC3}" dt="2024-03-05T09:20:59.053" v="2220" actId="1076"/>
-        <pc:sldMkLst>
-          <pc:docMk/>
-          <pc:sldMk cId="3378674748" sldId="631"/>
-        </pc:sldMkLst>
-      </pc:sldChg>
-      <pc:sldChg chg="modSp mod">
-        <pc:chgData name="Matthieu De Mari" userId="dfb708c9-d8dc-439f-9a3b-c772bf4a311c" providerId="ADAL" clId="{AFBB5070-511B-4CA0-9A42-F23C012C9EC3}" dt="2024-03-05T08:54:44.345" v="690" actId="20577"/>
-        <pc:sldMkLst>
-          <pc:docMk/>
-          <pc:sldMk cId="3237577112" sldId="632"/>
-        </pc:sldMkLst>
-      </pc:sldChg>
-      <pc:sldChg chg="modSp">
-        <pc:chgData name="Matthieu De Mari" userId="dfb708c9-d8dc-439f-9a3b-c772bf4a311c" providerId="ADAL" clId="{AFBB5070-511B-4CA0-9A42-F23C012C9EC3}" dt="2024-02-09T00:55:52.996" v="276" actId="20577"/>
-        <pc:sldMkLst>
-          <pc:docMk/>
-          <pc:sldMk cId="875945898" sldId="634"/>
-        </pc:sldMkLst>
-      </pc:sldChg>
-      <pc:sldChg chg="addSp delSp modSp mod modClrScheme chgLayout">
-        <pc:chgData name="Matthieu De Mari" userId="dfb708c9-d8dc-439f-9a3b-c772bf4a311c" providerId="ADAL" clId="{AFBB5070-511B-4CA0-9A42-F23C012C9EC3}" dt="2024-03-05T09:06:18.398" v="1810" actId="207"/>
-        <pc:sldMkLst>
-          <pc:docMk/>
-          <pc:sldMk cId="956888542" sldId="635"/>
-        </pc:sldMkLst>
-      </pc:sldChg>
-      <pc:sldChg chg="modSp mod">
-        <pc:chgData name="Matthieu De Mari" userId="dfb708c9-d8dc-439f-9a3b-c772bf4a311c" providerId="ADAL" clId="{AFBB5070-511B-4CA0-9A42-F23C012C9EC3}" dt="2024-03-05T09:17:14.129" v="2187" actId="20577"/>
-        <pc:sldMkLst>
-          <pc:docMk/>
-          <pc:sldMk cId="9821103" sldId="636"/>
-        </pc:sldMkLst>
-      </pc:sldChg>
-      <pc:sldChg chg="del">
-        <pc:chgData name="Matthieu De Mari" userId="dfb708c9-d8dc-439f-9a3b-c772bf4a311c" providerId="ADAL" clId="{AFBB5070-511B-4CA0-9A42-F23C012C9EC3}" dt="2024-03-05T09:25:36.666" v="2290" actId="47"/>
-        <pc:sldMkLst>
-          <pc:docMk/>
-          <pc:sldMk cId="1731878414" sldId="637"/>
-        </pc:sldMkLst>
-      </pc:sldChg>
-      <pc:sldChg chg="del">
-        <pc:chgData name="Matthieu De Mari" userId="dfb708c9-d8dc-439f-9a3b-c772bf4a311c" providerId="ADAL" clId="{AFBB5070-511B-4CA0-9A42-F23C012C9EC3}" dt="2024-03-05T09:25:33.676" v="2288" actId="47"/>
-        <pc:sldMkLst>
-          <pc:docMk/>
-          <pc:sldMk cId="1290242122" sldId="638"/>
-        </pc:sldMkLst>
-      </pc:sldChg>
-      <pc:sldChg chg="del">
-        <pc:chgData name="Matthieu De Mari" userId="dfb708c9-d8dc-439f-9a3b-c772bf4a311c" providerId="ADAL" clId="{AFBB5070-511B-4CA0-9A42-F23C012C9EC3}" dt="2024-03-05T09:25:33.676" v="2288" actId="47"/>
-        <pc:sldMkLst>
-          <pc:docMk/>
-          <pc:sldMk cId="4283342382" sldId="639"/>
-        </pc:sldMkLst>
-      </pc:sldChg>
-      <pc:sldChg chg="del">
-        <pc:chgData name="Matthieu De Mari" userId="dfb708c9-d8dc-439f-9a3b-c772bf4a311c" providerId="ADAL" clId="{AFBB5070-511B-4CA0-9A42-F23C012C9EC3}" dt="2024-03-05T09:25:33.676" v="2288" actId="47"/>
-        <pc:sldMkLst>
-          <pc:docMk/>
-          <pc:sldMk cId="3527748531" sldId="640"/>
-        </pc:sldMkLst>
-      </pc:sldChg>
-      <pc:sldChg chg="modSp del">
-        <pc:chgData name="Matthieu De Mari" userId="dfb708c9-d8dc-439f-9a3b-c772bf4a311c" providerId="ADAL" clId="{AFBB5070-511B-4CA0-9A42-F23C012C9EC3}" dt="2024-03-05T09:25:33.676" v="2288" actId="47"/>
-        <pc:sldMkLst>
-          <pc:docMk/>
-          <pc:sldMk cId="3298110552" sldId="641"/>
-        </pc:sldMkLst>
-      </pc:sldChg>
-      <pc:sldChg chg="del">
-        <pc:chgData name="Matthieu De Mari" userId="dfb708c9-d8dc-439f-9a3b-c772bf4a311c" providerId="ADAL" clId="{AFBB5070-511B-4CA0-9A42-F23C012C9EC3}" dt="2024-03-05T09:25:33.676" v="2288" actId="47"/>
-        <pc:sldMkLst>
-          <pc:docMk/>
-          <pc:sldMk cId="4241197121" sldId="642"/>
-        </pc:sldMkLst>
-      </pc:sldChg>
-      <pc:sldChg chg="del">
-        <pc:chgData name="Matthieu De Mari" userId="dfb708c9-d8dc-439f-9a3b-c772bf4a311c" providerId="ADAL" clId="{AFBB5070-511B-4CA0-9A42-F23C012C9EC3}" dt="2024-03-05T09:25:33.676" v="2288" actId="47"/>
-        <pc:sldMkLst>
-          <pc:docMk/>
-          <pc:sldMk cId="1487822837" sldId="643"/>
-        </pc:sldMkLst>
-      </pc:sldChg>
-      <pc:sldChg chg="modSp del mod">
-        <pc:chgData name="Matthieu De Mari" userId="dfb708c9-d8dc-439f-9a3b-c772bf4a311c" providerId="ADAL" clId="{AFBB5070-511B-4CA0-9A42-F23C012C9EC3}" dt="2024-03-05T09:25:33.676" v="2288" actId="47"/>
-        <pc:sldMkLst>
-          <pc:docMk/>
-          <pc:sldMk cId="715032396" sldId="644"/>
-        </pc:sldMkLst>
-      </pc:sldChg>
-      <pc:sldChg chg="addSp delSp modSp del mod">
-        <pc:chgData name="Matthieu De Mari" userId="dfb708c9-d8dc-439f-9a3b-c772bf4a311c" providerId="ADAL" clId="{AFBB5070-511B-4CA0-9A42-F23C012C9EC3}" dt="2024-03-05T09:25:33.676" v="2288" actId="47"/>
-        <pc:sldMkLst>
-          <pc:docMk/>
-          <pc:sldMk cId="1850403076" sldId="645"/>
-        </pc:sldMkLst>
-      </pc:sldChg>
-      <pc:sldChg chg="addSp delSp modSp del mod">
-        <pc:chgData name="Matthieu De Mari" userId="dfb708c9-d8dc-439f-9a3b-c772bf4a311c" providerId="ADAL" clId="{AFBB5070-511B-4CA0-9A42-F23C012C9EC3}" dt="2024-03-05T09:25:35.051" v="2289" actId="47"/>
-        <pc:sldMkLst>
-          <pc:docMk/>
-          <pc:sldMk cId="3708794977" sldId="646"/>
-        </pc:sldMkLst>
-      </pc:sldChg>
-      <pc:sldChg chg="del">
-        <pc:chgData name="Matthieu De Mari" userId="dfb708c9-d8dc-439f-9a3b-c772bf4a311c" providerId="ADAL" clId="{AFBB5070-511B-4CA0-9A42-F23C012C9EC3}" dt="2024-02-09T01:03:14.436" v="373" actId="47"/>
-        <pc:sldMkLst>
-          <pc:docMk/>
-          <pc:sldMk cId="2404237809" sldId="648"/>
-        </pc:sldMkLst>
-      </pc:sldChg>
-      <pc:sldChg chg="modSp del mod">
-        <pc:chgData name="Matthieu De Mari" userId="dfb708c9-d8dc-439f-9a3b-c772bf4a311c" providerId="ADAL" clId="{AFBB5070-511B-4CA0-9A42-F23C012C9EC3}" dt="2024-03-05T09:25:35.051" v="2289" actId="47"/>
-        <pc:sldMkLst>
-          <pc:docMk/>
-          <pc:sldMk cId="1952442680" sldId="649"/>
-        </pc:sldMkLst>
-      </pc:sldChg>
-      <pc:sldChg chg="del">
-        <pc:chgData name="Matthieu De Mari" userId="dfb708c9-d8dc-439f-9a3b-c772bf4a311c" providerId="ADAL" clId="{AFBB5070-511B-4CA0-9A42-F23C012C9EC3}" dt="2024-03-05T09:25:35.051" v="2289" actId="47"/>
-        <pc:sldMkLst>
-          <pc:docMk/>
-          <pc:sldMk cId="3215884619" sldId="650"/>
-        </pc:sldMkLst>
-      </pc:sldChg>
-      <pc:sldChg chg="del">
-        <pc:chgData name="Matthieu De Mari" userId="dfb708c9-d8dc-439f-9a3b-c772bf4a311c" providerId="ADAL" clId="{AFBB5070-511B-4CA0-9A42-F23C012C9EC3}" dt="2024-03-05T09:25:33.676" v="2288" actId="47"/>
-        <pc:sldMkLst>
-          <pc:docMk/>
-          <pc:sldMk cId="2595195584" sldId="651"/>
-        </pc:sldMkLst>
-      </pc:sldChg>
-      <pc:sldChg chg="addSp delSp modSp del mod">
-        <pc:chgData name="Matthieu De Mari" userId="dfb708c9-d8dc-439f-9a3b-c772bf4a311c" providerId="ADAL" clId="{AFBB5070-511B-4CA0-9A42-F23C012C9EC3}" dt="2024-03-05T09:25:33.676" v="2288" actId="47"/>
-        <pc:sldMkLst>
-          <pc:docMk/>
-          <pc:sldMk cId="773672680" sldId="652"/>
-        </pc:sldMkLst>
-      </pc:sldChg>
-      <pc:sldChg chg="del">
-        <pc:chgData name="Matthieu De Mari" userId="dfb708c9-d8dc-439f-9a3b-c772bf4a311c" providerId="ADAL" clId="{AFBB5070-511B-4CA0-9A42-F23C012C9EC3}" dt="2024-03-05T09:25:35.051" v="2289" actId="47"/>
-        <pc:sldMkLst>
-          <pc:docMk/>
-          <pc:sldMk cId="855321949" sldId="653"/>
-        </pc:sldMkLst>
-      </pc:sldChg>
-      <pc:sldChg chg="modSp del mod">
-        <pc:chgData name="Matthieu De Mari" userId="dfb708c9-d8dc-439f-9a3b-c772bf4a311c" providerId="ADAL" clId="{AFBB5070-511B-4CA0-9A42-F23C012C9EC3}" dt="2024-02-09T01:06:07.404" v="444" actId="47"/>
-        <pc:sldMkLst>
-          <pc:docMk/>
-          <pc:sldMk cId="2099660639" sldId="654"/>
-        </pc:sldMkLst>
-      </pc:sldChg>
-      <pc:sldChg chg="del">
-        <pc:chgData name="Matthieu De Mari" userId="dfb708c9-d8dc-439f-9a3b-c772bf4a311c" providerId="ADAL" clId="{AFBB5070-511B-4CA0-9A42-F23C012C9EC3}" dt="2024-03-05T09:25:36.666" v="2290" actId="47"/>
-        <pc:sldMkLst>
-          <pc:docMk/>
-          <pc:sldMk cId="2451971174" sldId="655"/>
-        </pc:sldMkLst>
-      </pc:sldChg>
-      <pc:sldChg chg="del">
-        <pc:chgData name="Matthieu De Mari" userId="dfb708c9-d8dc-439f-9a3b-c772bf4a311c" providerId="ADAL" clId="{AFBB5070-511B-4CA0-9A42-F23C012C9EC3}" dt="2024-03-05T09:25:36.666" v="2290" actId="47"/>
-        <pc:sldMkLst>
-          <pc:docMk/>
-          <pc:sldMk cId="148017835" sldId="656"/>
-        </pc:sldMkLst>
-      </pc:sldChg>
-      <pc:sldChg chg="del">
-        <pc:chgData name="Matthieu De Mari" userId="dfb708c9-d8dc-439f-9a3b-c772bf4a311c" providerId="ADAL" clId="{AFBB5070-511B-4CA0-9A42-F23C012C9EC3}" dt="2024-03-05T09:25:36.666" v="2290" actId="47"/>
-        <pc:sldMkLst>
-          <pc:docMk/>
-          <pc:sldMk cId="1922511899" sldId="657"/>
-        </pc:sldMkLst>
-      </pc:sldChg>
-      <pc:sldChg chg="del">
-        <pc:chgData name="Matthieu De Mari" userId="dfb708c9-d8dc-439f-9a3b-c772bf4a311c" providerId="ADAL" clId="{AFBB5070-511B-4CA0-9A42-F23C012C9EC3}" dt="2024-03-05T09:25:36.666" v="2290" actId="47"/>
-        <pc:sldMkLst>
-          <pc:docMk/>
-          <pc:sldMk cId="4035742227" sldId="658"/>
-        </pc:sldMkLst>
-      </pc:sldChg>
-      <pc:sldChg chg="del">
-        <pc:chgData name="Matthieu De Mari" userId="dfb708c9-d8dc-439f-9a3b-c772bf4a311c" providerId="ADAL" clId="{AFBB5070-511B-4CA0-9A42-F23C012C9EC3}" dt="2024-03-05T09:25:36.666" v="2290" actId="47"/>
-        <pc:sldMkLst>
-          <pc:docMk/>
-          <pc:sldMk cId="2096824087" sldId="659"/>
-        </pc:sldMkLst>
-      </pc:sldChg>
-      <pc:sldChg chg="del">
-        <pc:chgData name="Matthieu De Mari" userId="dfb708c9-d8dc-439f-9a3b-c772bf4a311c" providerId="ADAL" clId="{AFBB5070-511B-4CA0-9A42-F23C012C9EC3}" dt="2024-03-05T09:25:36.666" v="2290" actId="47"/>
-        <pc:sldMkLst>
-          <pc:docMk/>
-          <pc:sldMk cId="3023865042" sldId="660"/>
-        </pc:sldMkLst>
-      </pc:sldChg>
-      <pc:sldChg chg="delSp modSp del mod">
-        <pc:chgData name="Matthieu De Mari" userId="dfb708c9-d8dc-439f-9a3b-c772bf4a311c" providerId="ADAL" clId="{AFBB5070-511B-4CA0-9A42-F23C012C9EC3}" dt="2024-03-05T09:25:36.666" v="2290" actId="47"/>
-        <pc:sldMkLst>
-          <pc:docMk/>
-          <pc:sldMk cId="2303339168" sldId="661"/>
-        </pc:sldMkLst>
-      </pc:sldChg>
-      <pc:sldChg chg="modSp del mod">
-        <pc:chgData name="Matthieu De Mari" userId="dfb708c9-d8dc-439f-9a3b-c772bf4a311c" providerId="ADAL" clId="{AFBB5070-511B-4CA0-9A42-F23C012C9EC3}" dt="2024-03-05T09:25:36.666" v="2290" actId="47"/>
-        <pc:sldMkLst>
-          <pc:docMk/>
-          <pc:sldMk cId="365986058" sldId="663"/>
-        </pc:sldMkLst>
-      </pc:sldChg>
-      <pc:sldChg chg="del">
-        <pc:chgData name="Matthieu De Mari" userId="dfb708c9-d8dc-439f-9a3b-c772bf4a311c" providerId="ADAL" clId="{AFBB5070-511B-4CA0-9A42-F23C012C9EC3}" dt="2024-03-05T09:25:33.676" v="2288" actId="47"/>
-        <pc:sldMkLst>
-          <pc:docMk/>
-          <pc:sldMk cId="2175023596" sldId="664"/>
-        </pc:sldMkLst>
-      </pc:sldChg>
-      <pc:sldChg chg="delSp modSp add mod modClrScheme chgLayout">
-        <pc:chgData name="Matthieu De Mari" userId="dfb708c9-d8dc-439f-9a3b-c772bf4a311c" providerId="ADAL" clId="{AFBB5070-511B-4CA0-9A42-F23C012C9EC3}" dt="2024-03-05T09:06:13.449" v="1809" actId="207"/>
-        <pc:sldMkLst>
-          <pc:docMk/>
-          <pc:sldMk cId="3985714035" sldId="665"/>
-        </pc:sldMkLst>
-      </pc:sldChg>
-      <pc:sldChg chg="delSp modSp add mod modClrScheme chgLayout">
-        <pc:chgData name="Matthieu De Mari" userId="dfb708c9-d8dc-439f-9a3b-c772bf4a311c" providerId="ADAL" clId="{AFBB5070-511B-4CA0-9A42-F23C012C9EC3}" dt="2024-02-27T02:38:56.906" v="515" actId="20577"/>
-        <pc:sldMkLst>
-          <pc:docMk/>
-          <pc:sldMk cId="328652294" sldId="666"/>
-        </pc:sldMkLst>
-      </pc:sldChg>
-      <pc:sldChg chg="delSp modSp add mod modClrScheme chgLayout">
-        <pc:chgData name="Matthieu De Mari" userId="dfb708c9-d8dc-439f-9a3b-c772bf4a311c" providerId="ADAL" clId="{AFBB5070-511B-4CA0-9A42-F23C012C9EC3}" dt="2024-02-09T01:01:15.301" v="340" actId="27636"/>
-        <pc:sldMkLst>
-          <pc:docMk/>
-          <pc:sldMk cId="4024913740" sldId="667"/>
-        </pc:sldMkLst>
-      </pc:sldChg>
-      <pc:sldChg chg="del">
-        <pc:chgData name="Matthieu De Mari" userId="dfb708c9-d8dc-439f-9a3b-c772bf4a311c" providerId="ADAL" clId="{AFBB5070-511B-4CA0-9A42-F23C012C9EC3}" dt="2024-02-09T00:49:55.084" v="4" actId="47"/>
-        <pc:sldMkLst>
-          <pc:docMk/>
-          <pc:sldMk cId="2828164903" sldId="668"/>
-        </pc:sldMkLst>
-      </pc:sldChg>
-      <pc:sldChg chg="addSp modSp add del mod">
-        <pc:chgData name="Matthieu De Mari" userId="dfb708c9-d8dc-439f-9a3b-c772bf4a311c" providerId="ADAL" clId="{AFBB5070-511B-4CA0-9A42-F23C012C9EC3}" dt="2024-03-05T09:25:36.666" v="2290" actId="47"/>
-        <pc:sldMkLst>
-          <pc:docMk/>
-          <pc:sldMk cId="2917180269" sldId="668"/>
-        </pc:sldMkLst>
-      </pc:sldChg>
-      <pc:sldChg chg="modSp add mod">
-        <pc:chgData name="Matthieu De Mari" userId="dfb708c9-d8dc-439f-9a3b-c772bf4a311c" providerId="ADAL" clId="{AFBB5070-511B-4CA0-9A42-F23C012C9EC3}" dt="2024-03-05T08:58:55.719" v="1152" actId="113"/>
-        <pc:sldMkLst>
-          <pc:docMk/>
-          <pc:sldMk cId="2636755818" sldId="669"/>
-        </pc:sldMkLst>
-      </pc:sldChg>
-      <pc:sldChg chg="del">
-        <pc:chgData name="Matthieu De Mari" userId="dfb708c9-d8dc-439f-9a3b-c772bf4a311c" providerId="ADAL" clId="{AFBB5070-511B-4CA0-9A42-F23C012C9EC3}" dt="2024-02-09T00:49:51.166" v="3" actId="47"/>
-        <pc:sldMkLst>
-          <pc:docMk/>
-          <pc:sldMk cId="3980169169" sldId="669"/>
-        </pc:sldMkLst>
-      </pc:sldChg>
-      <pc:sldChg chg="modSp add mod">
-        <pc:chgData name="Matthieu De Mari" userId="dfb708c9-d8dc-439f-9a3b-c772bf4a311c" providerId="ADAL" clId="{AFBB5070-511B-4CA0-9A42-F23C012C9EC3}" dt="2024-03-05T09:04:21.151" v="1733" actId="20577"/>
-        <pc:sldMkLst>
-          <pc:docMk/>
-          <pc:sldMk cId="370734377" sldId="670"/>
-        </pc:sldMkLst>
-      </pc:sldChg>
-      <pc:sldChg chg="del">
-        <pc:chgData name="Matthieu De Mari" userId="dfb708c9-d8dc-439f-9a3b-c772bf4a311c" providerId="ADAL" clId="{AFBB5070-511B-4CA0-9A42-F23C012C9EC3}" dt="2024-02-09T00:49:44.944" v="2" actId="47"/>
-        <pc:sldMkLst>
-          <pc:docMk/>
-          <pc:sldMk cId="4122990920" sldId="670"/>
-        </pc:sldMkLst>
-      </pc:sldChg>
-    </pc:docChg>
-  </pc:docChgLst>
-  <pc:docChgLst>
-    <pc:chgData name="Matthieu De Mari" userId="dfb708c9-d8dc-439f-9a3b-c772bf4a311c" providerId="ADAL" clId="{95DC2182-BA54-4583-9E8E-B21E5C8D4D55}"/>
-    <pc:docChg chg="undo custSel addSld delSld modSld sldOrd addSection delSection modSection">
-      <pc:chgData name="Matthieu De Mari" userId="dfb708c9-d8dc-439f-9a3b-c772bf4a311c" providerId="ADAL" clId="{95DC2182-BA54-4583-9E8E-B21E5C8D4D55}" dt="2023-02-26T09:05:17.993" v="27185" actId="20577"/>
-      <pc:docMkLst>
-        <pc:docMk/>
-      </pc:docMkLst>
-      <pc:sldChg chg="modSp mod">
-        <pc:chgData name="Matthieu De Mari" userId="dfb708c9-d8dc-439f-9a3b-c772bf4a311c" providerId="ADAL" clId="{95DC2182-BA54-4583-9E8E-B21E5C8D4D55}" dt="2023-02-26T08:54:41.980" v="25991" actId="113"/>
-        <pc:sldMkLst>
-          <pc:docMk/>
-          <pc:sldMk cId="3442501962" sldId="257"/>
-        </pc:sldMkLst>
-      </pc:sldChg>
-      <pc:sldChg chg="addSp delSp modSp mod">
-        <pc:chgData name="Matthieu De Mari" userId="dfb708c9-d8dc-439f-9a3b-c772bf4a311c" providerId="ADAL" clId="{95DC2182-BA54-4583-9E8E-B21E5C8D4D55}" dt="2023-02-26T09:05:17.993" v="27185" actId="20577"/>
-        <pc:sldMkLst>
-          <pc:docMk/>
-          <pc:sldMk cId="1893873068" sldId="266"/>
-        </pc:sldMkLst>
-      </pc:sldChg>
-      <pc:sldChg chg="modSp mod">
-        <pc:chgData name="Matthieu De Mari" userId="dfb708c9-d8dc-439f-9a3b-c772bf4a311c" providerId="ADAL" clId="{95DC2182-BA54-4583-9E8E-B21E5C8D4D55}" dt="2023-02-23T11:31:31.567" v="17653" actId="207"/>
-        <pc:sldMkLst>
-          <pc:docMk/>
-          <pc:sldMk cId="3880949074" sldId="267"/>
-        </pc:sldMkLst>
-      </pc:sldChg>
-      <pc:sldChg chg="modSp mod">
-        <pc:chgData name="Matthieu De Mari" userId="dfb708c9-d8dc-439f-9a3b-c772bf4a311c" providerId="ADAL" clId="{95DC2182-BA54-4583-9E8E-B21E5C8D4D55}" dt="2023-02-26T09:02:44.409" v="26989" actId="20577"/>
-        <pc:sldMkLst>
-          <pc:docMk/>
-          <pc:sldMk cId="1036081419" sldId="346"/>
-        </pc:sldMkLst>
-      </pc:sldChg>
-      <pc:sldChg chg="modSp mod">
-        <pc:chgData name="Matthieu De Mari" userId="dfb708c9-d8dc-439f-9a3b-c772bf4a311c" providerId="ADAL" clId="{95DC2182-BA54-4583-9E8E-B21E5C8D4D55}" dt="2023-02-21T11:02:32.442" v="9700" actId="20577"/>
-        <pc:sldMkLst>
-          <pc:docMk/>
-          <pc:sldMk cId="1040156172" sldId="377"/>
-        </pc:sldMkLst>
-      </pc:sldChg>
-      <pc:sldChg chg="addSp delSp modSp new mod ord modClrScheme chgLayout">
-        <pc:chgData name="Matthieu De Mari" userId="dfb708c9-d8dc-439f-9a3b-c772bf4a311c" providerId="ADAL" clId="{95DC2182-BA54-4583-9E8E-B21E5C8D4D55}" dt="2023-02-17T09:41:10.957" v="4103"/>
-        <pc:sldMkLst>
-          <pc:docMk/>
-          <pc:sldMk cId="1119657896" sldId="378"/>
-        </pc:sldMkLst>
-      </pc:sldChg>
-      <pc:sldChg chg="modSp add mod ord">
-        <pc:chgData name="Matthieu De Mari" userId="dfb708c9-d8dc-439f-9a3b-c772bf4a311c" providerId="ADAL" clId="{95DC2182-BA54-4583-9E8E-B21E5C8D4D55}" dt="2023-02-26T07:17:50.059" v="19240" actId="5793"/>
-        <pc:sldMkLst>
-          <pc:docMk/>
-          <pc:sldMk cId="3946144614" sldId="379"/>
-        </pc:sldMkLst>
-      </pc:sldChg>
-      <pc:sldChg chg="addSp delSp modSp add mod ord chgLayout">
-        <pc:chgData name="Matthieu De Mari" userId="dfb708c9-d8dc-439f-9a3b-c772bf4a311c" providerId="ADAL" clId="{95DC2182-BA54-4583-9E8E-B21E5C8D4D55}" dt="2023-02-23T02:52:26.148" v="9713" actId="20577"/>
-        <pc:sldMkLst>
-          <pc:docMk/>
-          <pc:sldMk cId="2141271085" sldId="380"/>
-        </pc:sldMkLst>
-      </pc:sldChg>
-      <pc:sldChg chg="addSp modSp add mod ord">
-        <pc:chgData name="Matthieu De Mari" userId="dfb708c9-d8dc-439f-9a3b-c772bf4a311c" providerId="ADAL" clId="{95DC2182-BA54-4583-9E8E-B21E5C8D4D55}" dt="2023-02-17T09:41:10.957" v="4103"/>
-        <pc:sldMkLst>
-          <pc:docMk/>
-          <pc:sldMk cId="1990152231" sldId="381"/>
-        </pc:sldMkLst>
-      </pc:sldChg>
-      <pc:sldChg chg="addSp delSp modSp new mod ord modClrScheme chgLayout">
-        <pc:chgData name="Matthieu De Mari" userId="dfb708c9-d8dc-439f-9a3b-c772bf4a311c" providerId="ADAL" clId="{95DC2182-BA54-4583-9E8E-B21E5C8D4D55}" dt="2023-02-17T09:41:10.957" v="4103"/>
-        <pc:sldMkLst>
-          <pc:docMk/>
-          <pc:sldMk cId="356330123" sldId="382"/>
-        </pc:sldMkLst>
-      </pc:sldChg>
-      <pc:sldChg chg="addSp delSp modSp add del mod">
-        <pc:chgData name="Matthieu De Mari" userId="dfb708c9-d8dc-439f-9a3b-c772bf4a311c" providerId="ADAL" clId="{95DC2182-BA54-4583-9E8E-B21E5C8D4D55}" dt="2023-02-17T08:42:23.672" v="637" actId="47"/>
-        <pc:sldMkLst>
-          <pc:docMk/>
-          <pc:sldMk cId="1597381135" sldId="383"/>
-        </pc:sldMkLst>
-      </pc:sldChg>
-      <pc:sldChg chg="addSp delSp modSp add mod ord modClrScheme chgLayout">
-        <pc:chgData name="Matthieu De Mari" userId="dfb708c9-d8dc-439f-9a3b-c772bf4a311c" providerId="ADAL" clId="{95DC2182-BA54-4583-9E8E-B21E5C8D4D55}" dt="2023-02-23T02:52:10.916" v="9711" actId="113"/>
-        <pc:sldMkLst>
-          <pc:docMk/>
-          <pc:sldMk cId="3535228966" sldId="384"/>
-        </pc:sldMkLst>
-      </pc:sldChg>
-      <pc:sldChg chg="modSp add del mod ord">
-        <pc:chgData name="Matthieu De Mari" userId="dfb708c9-d8dc-439f-9a3b-c772bf4a311c" providerId="ADAL" clId="{95DC2182-BA54-4583-9E8E-B21E5C8D4D55}" dt="2023-02-23T02:52:38.516" v="9714" actId="47"/>
-        <pc:sldMkLst>
-          <pc:docMk/>
-          <pc:sldMk cId="1845912647" sldId="385"/>
-        </pc:sldMkLst>
-      </pc:sldChg>
-      <pc:sldChg chg="addSp modSp add mod ord">
-        <pc:chgData name="Matthieu De Mari" userId="dfb708c9-d8dc-439f-9a3b-c772bf4a311c" providerId="ADAL" clId="{95DC2182-BA54-4583-9E8E-B21E5C8D4D55}" dt="2023-02-21T08:53:50.845" v="4525" actId="20577"/>
-        <pc:sldMkLst>
-          <pc:docMk/>
-          <pc:sldMk cId="3334002964" sldId="386"/>
-        </pc:sldMkLst>
-      </pc:sldChg>
-      <pc:sldChg chg="addSp delSp modSp new mod">
-        <pc:chgData name="Matthieu De Mari" userId="dfb708c9-d8dc-439f-9a3b-c772bf4a311c" providerId="ADAL" clId="{95DC2182-BA54-4583-9E8E-B21E5C8D4D55}" dt="2023-02-26T07:18:05.355" v="19243" actId="113"/>
-        <pc:sldMkLst>
-          <pc:docMk/>
-          <pc:sldMk cId="3292999532" sldId="387"/>
-        </pc:sldMkLst>
-      </pc:sldChg>
-      <pc:sldChg chg="addSp delSp modSp add mod">
-        <pc:chgData name="Matthieu De Mari" userId="dfb708c9-d8dc-439f-9a3b-c772bf4a311c" providerId="ADAL" clId="{95DC2182-BA54-4583-9E8E-B21E5C8D4D55}" dt="2023-02-21T08:53:09.228" v="4502" actId="20577"/>
-        <pc:sldMkLst>
-          <pc:docMk/>
-          <pc:sldMk cId="2586666001" sldId="388"/>
-        </pc:sldMkLst>
-      </pc:sldChg>
-      <pc:sldChg chg="modSp add del mod">
-        <pc:chgData name="Matthieu De Mari" userId="dfb708c9-d8dc-439f-9a3b-c772bf4a311c" providerId="ADAL" clId="{95DC2182-BA54-4583-9E8E-B21E5C8D4D55}" dt="2023-02-17T09:21:02.572" v="2876" actId="47"/>
-        <pc:sldMkLst>
-          <pc:docMk/>
-          <pc:sldMk cId="1425256713" sldId="389"/>
-        </pc:sldMkLst>
-      </pc:sldChg>
-      <pc:sldChg chg="addSp delSp modSp add mod chgLayout">
-        <pc:chgData name="Matthieu De Mari" userId="dfb708c9-d8dc-439f-9a3b-c772bf4a311c" providerId="ADAL" clId="{95DC2182-BA54-4583-9E8E-B21E5C8D4D55}" dt="2023-02-23T02:53:51.114" v="9725" actId="20577"/>
-        <pc:sldMkLst>
-          <pc:docMk/>
-          <pc:sldMk cId="699795487" sldId="390"/>
-        </pc:sldMkLst>
-      </pc:sldChg>
-      <pc:sldChg chg="addSp delSp modSp add mod">
-        <pc:chgData name="Matthieu De Mari" userId="dfb708c9-d8dc-439f-9a3b-c772bf4a311c" providerId="ADAL" clId="{95DC2182-BA54-4583-9E8E-B21E5C8D4D55}" dt="2023-02-26T07:19:07.424" v="19248"/>
-        <pc:sldMkLst>
-          <pc:docMk/>
-          <pc:sldMk cId="3438165640" sldId="391"/>
-        </pc:sldMkLst>
-      </pc:sldChg>
-      <pc:sldChg chg="addSp delSp modSp add mod ord">
-        <pc:chgData name="Matthieu De Mari" userId="dfb708c9-d8dc-439f-9a3b-c772bf4a311c" providerId="ADAL" clId="{95DC2182-BA54-4583-9E8E-B21E5C8D4D55}" dt="2023-02-17T09:22:42.121" v="3052" actId="20577"/>
-        <pc:sldMkLst>
-          <pc:docMk/>
-          <pc:sldMk cId="2064353129" sldId="392"/>
-        </pc:sldMkLst>
-      </pc:sldChg>
-      <pc:sldChg chg="addSp delSp modSp add mod">
-        <pc:chgData name="Matthieu De Mari" userId="dfb708c9-d8dc-439f-9a3b-c772bf4a311c" providerId="ADAL" clId="{95DC2182-BA54-4583-9E8E-B21E5C8D4D55}" dt="2023-02-23T02:54:05.876" v="9727" actId="20577"/>
-        <pc:sldMkLst>
-          <pc:docMk/>
-          <pc:sldMk cId="3842187934" sldId="393"/>
-        </pc:sldMkLst>
-      </pc:sldChg>
-      <pc:sldChg chg="addSp delSp modSp add mod">
-        <pc:chgData name="Matthieu De Mari" userId="dfb708c9-d8dc-439f-9a3b-c772bf4a311c" providerId="ADAL" clId="{95DC2182-BA54-4583-9E8E-B21E5C8D4D55}" dt="2023-02-21T08:55:11.719" v="4562"/>
-        <pc:sldMkLst>
-          <pc:docMk/>
-          <pc:sldMk cId="781649533" sldId="394"/>
-        </pc:sldMkLst>
-      </pc:sldChg>
-      <pc:sldChg chg="addSp delSp modSp add mod modClrScheme chgLayout">
-        <pc:chgData name="Matthieu De Mari" userId="dfb708c9-d8dc-439f-9a3b-c772bf4a311c" providerId="ADAL" clId="{95DC2182-BA54-4583-9E8E-B21E5C8D4D55}" dt="2023-02-23T02:54:30.470" v="9741" actId="20577"/>
-        <pc:sldMkLst>
-          <pc:docMk/>
-          <pc:sldMk cId="2316878562" sldId="395"/>
-        </pc:sldMkLst>
-      </pc:sldChg>
-      <pc:sldChg chg="addSp delSp modSp new mod">
-        <pc:chgData name="Matthieu De Mari" userId="dfb708c9-d8dc-439f-9a3b-c772bf4a311c" providerId="ADAL" clId="{95DC2182-BA54-4583-9E8E-B21E5C8D4D55}" dt="2023-02-26T07:19:06.094" v="19247"/>
-        <pc:sldMkLst>
-          <pc:docMk/>
-          <pc:sldMk cId="1870305378" sldId="396"/>
-        </pc:sldMkLst>
-      </pc:sldChg>
-      <pc:sldChg chg="addSp delSp modSp add mod">
-        <pc:chgData name="Matthieu De Mari" userId="dfb708c9-d8dc-439f-9a3b-c772bf4a311c" providerId="ADAL" clId="{95DC2182-BA54-4583-9E8E-B21E5C8D4D55}" dt="2023-02-23T02:58:02.175" v="9793" actId="20577"/>
-        <pc:sldMkLst>
-          <pc:docMk/>
-          <pc:sldMk cId="1413966137" sldId="397"/>
-        </pc:sldMkLst>
-      </pc:sldChg>
-      <pc:sldChg chg="addSp delSp modSp new mod">
-        <pc:chgData name="Matthieu De Mari" userId="dfb708c9-d8dc-439f-9a3b-c772bf4a311c" providerId="ADAL" clId="{95DC2182-BA54-4583-9E8E-B21E5C8D4D55}" dt="2023-02-23T02:59:11.897" v="9835" actId="20577"/>
-        <pc:sldMkLst>
-          <pc:docMk/>
-          <pc:sldMk cId="2506346402" sldId="398"/>
-        </pc:sldMkLst>
-      </pc:sldChg>
-      <pc:sldChg chg="addSp delSp modSp add mod modClrScheme chgLayout">
-        <pc:chgData name="Matthieu De Mari" userId="dfb708c9-d8dc-439f-9a3b-c772bf4a311c" providerId="ADAL" clId="{95DC2182-BA54-4583-9E8E-B21E5C8D4D55}" dt="2023-02-17T09:40:50.204" v="4101" actId="20577"/>
-        <pc:sldMkLst>
-          <pc:docMk/>
-          <pc:sldMk cId="1835834167" sldId="399"/>
-        </pc:sldMkLst>
-      </pc:sldChg>
-      <pc:sldChg chg="addSp delSp modSp add mod ord modClrScheme chgLayout">
-        <pc:chgData name="Matthieu De Mari" userId="dfb708c9-d8dc-439f-9a3b-c772bf4a311c" providerId="ADAL" clId="{95DC2182-BA54-4583-9E8E-B21E5C8D4D55}" dt="2023-02-23T02:58:40.249" v="9816" actId="20577"/>
-        <pc:sldMkLst>
-          <pc:docMk/>
-          <pc:sldMk cId="4048808033" sldId="400"/>
-        </pc:sldMkLst>
-      </pc:sldChg>
-      <pc:sldChg chg="addSp delSp new del mod">
-        <pc:chgData name="Matthieu De Mari" userId="dfb708c9-d8dc-439f-9a3b-c772bf4a311c" providerId="ADAL" clId="{95DC2182-BA54-4583-9E8E-B21E5C8D4D55}" dt="2023-02-17T09:43:44.070" v="4143" actId="47"/>
-        <pc:sldMkLst>
-          <pc:docMk/>
-          <pc:sldMk cId="4083174369" sldId="401"/>
-        </pc:sldMkLst>
-      </pc:sldChg>
-      <pc:sldChg chg="addSp delSp modSp add mod ord">
-        <pc:chgData name="Matthieu De Mari" userId="dfb708c9-d8dc-439f-9a3b-c772bf4a311c" providerId="ADAL" clId="{95DC2182-BA54-4583-9E8E-B21E5C8D4D55}" dt="2023-02-26T07:19:59.779" v="19287" actId="20577"/>
-        <pc:sldMkLst>
-          <pc:docMk/>
-          <pc:sldMk cId="736987387" sldId="402"/>
-        </pc:sldMkLst>
-      </pc:sldChg>
-      <pc:sldChg chg="addSp delSp modSp add mod ord">
-        <pc:chgData name="Matthieu De Mari" userId="dfb708c9-d8dc-439f-9a3b-c772bf4a311c" providerId="ADAL" clId="{95DC2182-BA54-4583-9E8E-B21E5C8D4D55}" dt="2023-02-23T03:00:12.707" v="9872" actId="20577"/>
-        <pc:sldMkLst>
-          <pc:docMk/>
-          <pc:sldMk cId="105113267" sldId="403"/>
-        </pc:sldMkLst>
-      </pc:sldChg>
-      <pc:sldChg chg="modSp new del mod">
-        <pc:chgData name="Matthieu De Mari" userId="dfb708c9-d8dc-439f-9a3b-c772bf4a311c" providerId="ADAL" clId="{95DC2182-BA54-4583-9E8E-B21E5C8D4D55}" dt="2023-02-21T10:03:31.963" v="5683" actId="2696"/>
-        <pc:sldMkLst>
-          <pc:docMk/>
-          <pc:sldMk cId="955831919" sldId="404"/>
-        </pc:sldMkLst>
-      </pc:sldChg>
-      <pc:sldChg chg="modSp add mod ord">
-        <pc:chgData name="Matthieu De Mari" userId="dfb708c9-d8dc-439f-9a3b-c772bf4a311c" providerId="ADAL" clId="{95DC2182-BA54-4583-9E8E-B21E5C8D4D55}" dt="2023-02-26T07:35:56.470" v="19349" actId="20577"/>
-        <pc:sldMkLst>
-          <pc:docMk/>
-          <pc:sldMk cId="1663617131" sldId="404"/>
-        </pc:sldMkLst>
-      </pc:sldChg>
-      <pc:sldChg chg="modSp new mod ord">
-        <pc:chgData name="Matthieu De Mari" userId="dfb708c9-d8dc-439f-9a3b-c772bf4a311c" providerId="ADAL" clId="{95DC2182-BA54-4583-9E8E-B21E5C8D4D55}" dt="2023-02-23T03:01:30.211" v="9898" actId="20577"/>
-        <pc:sldMkLst>
-          <pc:docMk/>
-          <pc:sldMk cId="2755235485" sldId="405"/>
-        </pc:sldMkLst>
-      </pc:sldChg>
-      <pc:sldChg chg="modSp new mod">
-        <pc:chgData name="Matthieu De Mari" userId="dfb708c9-d8dc-439f-9a3b-c772bf4a311c" providerId="ADAL" clId="{95DC2182-BA54-4583-9E8E-B21E5C8D4D55}" dt="2023-02-23T03:03:41.570" v="9949" actId="20577"/>
-        <pc:sldMkLst>
-          <pc:docMk/>
-          <pc:sldMk cId="2781272903" sldId="406"/>
-        </pc:sldMkLst>
-      </pc:sldChg>
-      <pc:sldChg chg="addSp modSp new mod ord modClrScheme chgLayout">
-        <pc:chgData name="Matthieu De Mari" userId="dfb708c9-d8dc-439f-9a3b-c772bf4a311c" providerId="ADAL" clId="{95DC2182-BA54-4583-9E8E-B21E5C8D4D55}" dt="2023-02-26T08:51:59.487" v="25507"/>
-        <pc:sldMkLst>
-          <pc:docMk/>
-          <pc:sldMk cId="3425780644" sldId="407"/>
-        </pc:sldMkLst>
-      </pc:sldChg>
-      <pc:sldChg chg="modSp new del mod ord">
-        <pc:chgData name="Matthieu De Mari" userId="dfb708c9-d8dc-439f-9a3b-c772bf4a311c" providerId="ADAL" clId="{95DC2182-BA54-4583-9E8E-B21E5C8D4D55}" dt="2023-02-17T09:58:52.785" v="4408" actId="2696"/>
-        <pc:sldMkLst>
-          <pc:docMk/>
-          <pc:sldMk cId="720065278" sldId="408"/>
-        </pc:sldMkLst>
-      </pc:sldChg>
-      <pc:sldChg chg="modSp add mod">
-        <pc:chgData name="Matthieu De Mari" userId="dfb708c9-d8dc-439f-9a3b-c772bf4a311c" providerId="ADAL" clId="{95DC2182-BA54-4583-9E8E-B21E5C8D4D55}" dt="2023-02-23T06:53:08.162" v="14364"/>
-        <pc:sldMkLst>
-          <pc:docMk/>
-          <pc:sldMk cId="1300324164" sldId="408"/>
-        </pc:sldMkLst>
-      </pc:sldChg>
-      <pc:sldChg chg="modSp new del mod">
-        <pc:chgData name="Matthieu De Mari" userId="dfb708c9-d8dc-439f-9a3b-c772bf4a311c" providerId="ADAL" clId="{95DC2182-BA54-4583-9E8E-B21E5C8D4D55}" dt="2023-02-26T08:25:23.381" v="22856" actId="47"/>
-        <pc:sldMkLst>
-          <pc:docMk/>
-          <pc:sldMk cId="2990823243" sldId="409"/>
-        </pc:sldMkLst>
-      </pc:sldChg>
-      <pc:sldChg chg="modSp new mod ord">
-        <pc:chgData name="Matthieu De Mari" userId="dfb708c9-d8dc-439f-9a3b-c772bf4a311c" providerId="ADAL" clId="{95DC2182-BA54-4583-9E8E-B21E5C8D4D55}" dt="2023-02-26T07:38:17.095" v="19376" actId="113"/>
-        <pc:sldMkLst>
-          <pc:docMk/>
-          <pc:sldMk cId="3793163593" sldId="410"/>
-        </pc:sldMkLst>
-      </pc:sldChg>
-      <pc:sldChg chg="modSp new del mod">
-        <pc:chgData name="Matthieu De Mari" userId="dfb708c9-d8dc-439f-9a3b-c772bf4a311c" providerId="ADAL" clId="{95DC2182-BA54-4583-9E8E-B21E5C8D4D55}" dt="2023-02-21T10:36:46.337" v="7652" actId="47"/>
-        <pc:sldMkLst>
-          <pc:docMk/>
-          <pc:sldMk cId="1374902952" sldId="411"/>
-        </pc:sldMkLst>
-      </pc:sldChg>
-      <pc:sldChg chg="new del">
-        <pc:chgData name="Matthieu De Mari" userId="dfb708c9-d8dc-439f-9a3b-c772bf4a311c" providerId="ADAL" clId="{95DC2182-BA54-4583-9E8E-B21E5C8D4D55}" dt="2023-02-17T09:59:05.481" v="4413" actId="47"/>
-        <pc:sldMkLst>
-          <pc:docMk/>
-          <pc:sldMk cId="1249392804" sldId="412"/>
-        </pc:sldMkLst>
-      </pc:sldChg>
-      <pc:sldChg chg="new del">
-        <pc:chgData name="Matthieu De Mari" userId="dfb708c9-d8dc-439f-9a3b-c772bf4a311c" providerId="ADAL" clId="{95DC2182-BA54-4583-9E8E-B21E5C8D4D55}" dt="2023-02-21T10:36:26.763" v="7648" actId="47"/>
-        <pc:sldMkLst>
-          <pc:docMk/>
-          <pc:sldMk cId="3553139110" sldId="412"/>
-        </pc:sldMkLst>
-      </pc:sldChg>
-      <pc:sldChg chg="modSp add mod">
-        <pc:chgData name="Matthieu De Mari" userId="dfb708c9-d8dc-439f-9a3b-c772bf4a311c" providerId="ADAL" clId="{95DC2182-BA54-4583-9E8E-B21E5C8D4D55}" dt="2023-02-23T06:51:59.350" v="14354" actId="20577"/>
-        <pc:sldMkLst>
-          <pc:docMk/>
-          <pc:sldMk cId="1165688587" sldId="571"/>
-        </pc:sldMkLst>
-      </pc:sldChg>
-      <pc:sldChg chg="modSp add del mod">
-        <pc:chgData name="Matthieu De Mari" userId="dfb708c9-d8dc-439f-9a3b-c772bf4a311c" providerId="ADAL" clId="{95DC2182-BA54-4583-9E8E-B21E5C8D4D55}" dt="2023-02-21T09:56:31.484" v="4852" actId="47"/>
-        <pc:sldMkLst>
-          <pc:docMk/>
-          <pc:sldMk cId="2791256840" sldId="572"/>
-        </pc:sldMkLst>
-      </pc:sldChg>
-      <pc:sldChg chg="add del">
-        <pc:chgData name="Matthieu De Mari" userId="dfb708c9-d8dc-439f-9a3b-c772bf4a311c" providerId="ADAL" clId="{95DC2182-BA54-4583-9E8E-B21E5C8D4D55}" dt="2023-02-21T09:58:08.296" v="4895" actId="47"/>
-        <pc:sldMkLst>
-          <pc:docMk/>
-          <pc:sldMk cId="2218721771" sldId="573"/>
-        </pc:sldMkLst>
-      </pc:sldChg>
-      <pc:sldChg chg="modSp add del mod ord">
-        <pc:chgData name="Matthieu De Mari" userId="dfb708c9-d8dc-439f-9a3b-c772bf4a311c" providerId="ADAL" clId="{95DC2182-BA54-4583-9E8E-B21E5C8D4D55}" dt="2023-02-21T10:03:31.963" v="5683" actId="2696"/>
-        <pc:sldMkLst>
-          <pc:docMk/>
-          <pc:sldMk cId="1165490893" sldId="574"/>
-        </pc:sldMkLst>
-      </pc:sldChg>
-      <pc:sldChg chg="modSp add mod ord">
-        <pc:chgData name="Matthieu De Mari" userId="dfb708c9-d8dc-439f-9a3b-c772bf4a311c" providerId="ADAL" clId="{95DC2182-BA54-4583-9E8E-B21E5C8D4D55}" dt="2023-02-26T07:36:09.332" v="19354" actId="20577"/>
-        <pc:sldMkLst>
-          <pc:docMk/>
-          <pc:sldMk cId="3078664734" sldId="574"/>
-        </pc:sldMkLst>
-      </pc:sldChg>
-      <pc:sldChg chg="modSp new del mod">
-        <pc:chgData name="Matthieu De Mari" userId="dfb708c9-d8dc-439f-9a3b-c772bf4a311c" providerId="ADAL" clId="{95DC2182-BA54-4583-9E8E-B21E5C8D4D55}" dt="2023-02-21T09:56:32.308" v="4853" actId="47"/>
-        <pc:sldMkLst>
-          <pc:docMk/>
-          <pc:sldMk cId="937325559" sldId="575"/>
-        </pc:sldMkLst>
-      </pc:sldChg>
-      <pc:sldChg chg="modSp add mod">
-        <pc:chgData name="Matthieu De Mari" userId="dfb708c9-d8dc-439f-9a3b-c772bf4a311c" providerId="ADAL" clId="{95DC2182-BA54-4583-9E8E-B21E5C8D4D55}" dt="2023-02-23T03:01:12.697" v="9892" actId="20577"/>
-        <pc:sldMkLst>
-          <pc:docMk/>
-          <pc:sldMk cId="3542276236" sldId="575"/>
-        </pc:sldMkLst>
-      </pc:sldChg>
-      <pc:sldChg chg="modSp new mod ord">
-        <pc:chgData name="Matthieu De Mari" userId="dfb708c9-d8dc-439f-9a3b-c772bf4a311c" providerId="ADAL" clId="{95DC2182-BA54-4583-9E8E-B21E5C8D4D55}" dt="2023-02-23T03:02:15.773" v="9930"/>
-        <pc:sldMkLst>
-          <pc:docMk/>
-          <pc:sldMk cId="1343460073" sldId="576"/>
-        </pc:sldMkLst>
-      </pc:sldChg>
-      <pc:sldChg chg="addSp modSp add mod ord">
-        <pc:chgData name="Matthieu De Mari" userId="dfb708c9-d8dc-439f-9a3b-c772bf4a311c" providerId="ADAL" clId="{95DC2182-BA54-4583-9E8E-B21E5C8D4D55}" dt="2023-02-23T03:02:10.624" v="9929" actId="113"/>
-        <pc:sldMkLst>
-          <pc:docMk/>
-          <pc:sldMk cId="3821622736" sldId="577"/>
-        </pc:sldMkLst>
-      </pc:sldChg>
-      <pc:sldChg chg="modSp new mod">
-        <pc:chgData name="Matthieu De Mari" userId="dfb708c9-d8dc-439f-9a3b-c772bf4a311c" providerId="ADAL" clId="{95DC2182-BA54-4583-9E8E-B21E5C8D4D55}" dt="2023-02-23T03:02:42.860" v="9932" actId="20577"/>
-        <pc:sldMkLst>
-          <pc:docMk/>
-          <pc:sldMk cId="3867797258" sldId="578"/>
-        </pc:sldMkLst>
-      </pc:sldChg>
-      <pc:sldChg chg="add del ord">
-        <pc:chgData name="Matthieu De Mari" userId="dfb708c9-d8dc-439f-9a3b-c772bf4a311c" providerId="ADAL" clId="{95DC2182-BA54-4583-9E8E-B21E5C8D4D55}" dt="2023-02-21T10:36:15.246" v="7647" actId="47"/>
-        <pc:sldMkLst>
-          <pc:docMk/>
-          <pc:sldMk cId="796962667" sldId="579"/>
-        </pc:sldMkLst>
-      </pc:sldChg>
-      <pc:sldChg chg="modSp add mod">
-        <pc:chgData name="Matthieu De Mari" userId="dfb708c9-d8dc-439f-9a3b-c772bf4a311c" providerId="ADAL" clId="{95DC2182-BA54-4583-9E8E-B21E5C8D4D55}" dt="2023-02-23T03:02:23.621" v="9931"/>
-        <pc:sldMkLst>
-          <pc:docMk/>
-          <pc:sldMk cId="884373967" sldId="580"/>
-        </pc:sldMkLst>
-      </pc:sldChg>
-      <pc:sldChg chg="addSp delSp modSp new mod">
-        <pc:chgData name="Matthieu De Mari" userId="dfb708c9-d8dc-439f-9a3b-c772bf4a311c" providerId="ADAL" clId="{95DC2182-BA54-4583-9E8E-B21E5C8D4D55}" dt="2023-02-21T10:37:11.013" v="7685" actId="122"/>
-        <pc:sldMkLst>
-          <pc:docMk/>
-          <pc:sldMk cId="4262229869" sldId="581"/>
-        </pc:sldMkLst>
-      </pc:sldChg>
-      <pc:sldChg chg="add">
-        <pc:chgData name="Matthieu De Mari" userId="dfb708c9-d8dc-439f-9a3b-c772bf4a311c" providerId="ADAL" clId="{95DC2182-BA54-4583-9E8E-B21E5C8D4D55}" dt="2023-02-21T10:42:01.942" v="8296"/>
-        <pc:sldMkLst>
-          <pc:docMk/>
-          <pc:sldMk cId="445144023" sldId="582"/>
-        </pc:sldMkLst>
-      </pc:sldChg>
-      <pc:sldChg chg="addSp delSp modSp new mod">
-        <pc:chgData name="Matthieu De Mari" userId="dfb708c9-d8dc-439f-9a3b-c772bf4a311c" providerId="ADAL" clId="{95DC2182-BA54-4583-9E8E-B21E5C8D4D55}" dt="2023-02-23T03:04:42.732" v="9954" actId="207"/>
-        <pc:sldMkLst>
-          <pc:docMk/>
-          <pc:sldMk cId="1327648275" sldId="583"/>
-        </pc:sldMkLst>
-      </pc:sldChg>
-      <pc:sldChg chg="addSp delSp modSp new mod">
-        <pc:chgData name="Matthieu De Mari" userId="dfb708c9-d8dc-439f-9a3b-c772bf4a311c" providerId="ADAL" clId="{95DC2182-BA54-4583-9E8E-B21E5C8D4D55}" dt="2023-02-21T10:52:14.651" v="9032" actId="1076"/>
-        <pc:sldMkLst>
-          <pc:docMk/>
-          <pc:sldMk cId="1700821507" sldId="584"/>
-        </pc:sldMkLst>
-      </pc:sldChg>
-      <pc:sldChg chg="addSp delSp modSp add mod">
-        <pc:chgData name="Matthieu De Mari" userId="dfb708c9-d8dc-439f-9a3b-c772bf4a311c" providerId="ADAL" clId="{95DC2182-BA54-4583-9E8E-B21E5C8D4D55}" dt="2023-02-26T07:35:23.013" v="19289" actId="14100"/>
-        <pc:sldMkLst>
-          <pc:docMk/>
-          <pc:sldMk cId="2986323806" sldId="585"/>
-        </pc:sldMkLst>
-      </pc:sldChg>
-      <pc:sldChg chg="addSp delSp modSp add mod">
-        <pc:chgData name="Matthieu De Mari" userId="dfb708c9-d8dc-439f-9a3b-c772bf4a311c" providerId="ADAL" clId="{95DC2182-BA54-4583-9E8E-B21E5C8D4D55}" dt="2023-02-21T10:54:10.017" v="9091" actId="20577"/>
-        <pc:sldMkLst>
-          <pc:docMk/>
-          <pc:sldMk cId="2080496661" sldId="586"/>
-        </pc:sldMkLst>
-      </pc:sldChg>
-      <pc:sldChg chg="new del">
-        <pc:chgData name="Matthieu De Mari" userId="dfb708c9-d8dc-439f-9a3b-c772bf4a311c" providerId="ADAL" clId="{95DC2182-BA54-4583-9E8E-B21E5C8D4D55}" dt="2023-02-21T10:54:41.672" v="9094" actId="47"/>
-        <pc:sldMkLst>
-          <pc:docMk/>
-          <pc:sldMk cId="2237088828" sldId="587"/>
-        </pc:sldMkLst>
-      </pc:sldChg>
-      <pc:sldChg chg="modSp add mod">
-        <pc:chgData name="Matthieu De Mari" userId="dfb708c9-d8dc-439f-9a3b-c772bf4a311c" providerId="ADAL" clId="{95DC2182-BA54-4583-9E8E-B21E5C8D4D55}" dt="2023-02-21T10:57:48.169" v="9418" actId="207"/>
-        <pc:sldMkLst>
-          <pc:docMk/>
-          <pc:sldMk cId="2743590117" sldId="588"/>
-        </pc:sldMkLst>
-      </pc:sldChg>
-      <pc:sldChg chg="modSp add mod">
-        <pc:chgData name="Matthieu De Mari" userId="dfb708c9-d8dc-439f-9a3b-c772bf4a311c" providerId="ADAL" clId="{95DC2182-BA54-4583-9E8E-B21E5C8D4D55}" dt="2023-02-23T03:06:37.700" v="10094" actId="20577"/>
-        <pc:sldMkLst>
-          <pc:docMk/>
-          <pc:sldMk cId="1885554493" sldId="589"/>
-        </pc:sldMkLst>
-      </pc:sldChg>
-      <pc:sldChg chg="modSp new mod ord">
-        <pc:chgData name="Matthieu De Mari" userId="dfb708c9-d8dc-439f-9a3b-c772bf4a311c" providerId="ADAL" clId="{95DC2182-BA54-4583-9E8E-B21E5C8D4D55}" dt="2023-02-26T08:51:59.487" v="25507"/>
-        <pc:sldMkLst>
-          <pc:docMk/>
-          <pc:sldMk cId="1038252774" sldId="590"/>
-        </pc:sldMkLst>
-      </pc:sldChg>
-      <pc:sldChg chg="modSp add mod">
-        <pc:chgData name="Matthieu De Mari" userId="dfb708c9-d8dc-439f-9a3b-c772bf4a311c" providerId="ADAL" clId="{95DC2182-BA54-4583-9E8E-B21E5C8D4D55}" dt="2023-02-21T11:02:29.181" v="9698" actId="20577"/>
-        <pc:sldMkLst>
-          <pc:docMk/>
-          <pc:sldMk cId="37425589" sldId="591"/>
-        </pc:sldMkLst>
-      </pc:sldChg>
-      <pc:sldChg chg="add ord">
-        <pc:chgData name="Matthieu De Mari" userId="dfb708c9-d8dc-439f-9a3b-c772bf4a311c" providerId="ADAL" clId="{95DC2182-BA54-4583-9E8E-B21E5C8D4D55}" dt="2023-02-26T08:51:59.487" v="25507"/>
-        <pc:sldMkLst>
-          <pc:docMk/>
-          <pc:sldMk cId="3688488777" sldId="592"/>
-        </pc:sldMkLst>
-      </pc:sldChg>
-      <pc:sldChg chg="add ord">
-        <pc:chgData name="Matthieu De Mari" userId="dfb708c9-d8dc-439f-9a3b-c772bf4a311c" providerId="ADAL" clId="{95DC2182-BA54-4583-9E8E-B21E5C8D4D55}" dt="2023-02-26T08:51:59.487" v="25507"/>
-        <pc:sldMkLst>
-          <pc:docMk/>
-          <pc:sldMk cId="3362761059" sldId="593"/>
-        </pc:sldMkLst>
-      </pc:sldChg>
-      <pc:sldChg chg="add ord">
-        <pc:chgData name="Matthieu De Mari" userId="dfb708c9-d8dc-439f-9a3b-c772bf4a311c" providerId="ADAL" clId="{95DC2182-BA54-4583-9E8E-B21E5C8D4D55}" dt="2023-02-26T08:51:59.487" v="25507"/>
-        <pc:sldMkLst>
-          <pc:docMk/>
-          <pc:sldMk cId="239607028" sldId="594"/>
-        </pc:sldMkLst>
-      </pc:sldChg>
-      <pc:sldChg chg="modSp add mod ord">
-        <pc:chgData name="Matthieu De Mari" userId="dfb708c9-d8dc-439f-9a3b-c772bf4a311c" providerId="ADAL" clId="{95DC2182-BA54-4583-9E8E-B21E5C8D4D55}" dt="2023-02-26T08:51:59.487" v="25507"/>
-        <pc:sldMkLst>
-          <pc:docMk/>
-          <pc:sldMk cId="3681758499" sldId="595"/>
-        </pc:sldMkLst>
-      </pc:sldChg>
-      <pc:sldChg chg="addSp delSp modSp add mod">
-        <pc:chgData name="Matthieu De Mari" userId="dfb708c9-d8dc-439f-9a3b-c772bf4a311c" providerId="ADAL" clId="{95DC2182-BA54-4583-9E8E-B21E5C8D4D55}" dt="2023-02-23T05:59:57.960" v="10204" actId="22"/>
-        <pc:sldMkLst>
-          <pc:docMk/>
-          <pc:sldMk cId="3292545768" sldId="596"/>
-        </pc:sldMkLst>
-      </pc:sldChg>
-      <pc:sldChg chg="add ord">
-        <pc:chgData name="Matthieu De Mari" userId="dfb708c9-d8dc-439f-9a3b-c772bf4a311c" providerId="ADAL" clId="{95DC2182-BA54-4583-9E8E-B21E5C8D4D55}" dt="2023-02-26T08:51:59.487" v="25507"/>
-        <pc:sldMkLst>
-          <pc:docMk/>
-          <pc:sldMk cId="337788125" sldId="597"/>
-        </pc:sldMkLst>
-      </pc:sldChg>
-      <pc:sldChg chg="addSp delSp modSp new mod ord modClrScheme chgLayout">
-        <pc:chgData name="Matthieu De Mari" userId="dfb708c9-d8dc-439f-9a3b-c772bf4a311c" providerId="ADAL" clId="{95DC2182-BA54-4583-9E8E-B21E5C8D4D55}" dt="2023-02-26T08:51:59.487" v="25507"/>
-        <pc:sldMkLst>
-          <pc:docMk/>
-          <pc:sldMk cId="2646292586" sldId="598"/>
-        </pc:sldMkLst>
-      </pc:sldChg>
-      <pc:sldChg chg="modSp new mod ord">
-        <pc:chgData name="Matthieu De Mari" userId="dfb708c9-d8dc-439f-9a3b-c772bf4a311c" providerId="ADAL" clId="{95DC2182-BA54-4583-9E8E-B21E5C8D4D55}" dt="2023-02-26T08:51:59.487" v="25507"/>
-        <pc:sldMkLst>
-          <pc:docMk/>
-          <pc:sldMk cId="1390758074" sldId="599"/>
-        </pc:sldMkLst>
-      </pc:sldChg>
-      <pc:sldChg chg="addSp delSp modSp new mod modClrScheme chgLayout">
-        <pc:chgData name="Matthieu De Mari" userId="dfb708c9-d8dc-439f-9a3b-c772bf4a311c" providerId="ADAL" clId="{95DC2182-BA54-4583-9E8E-B21E5C8D4D55}" dt="2023-02-26T07:37:19.683" v="19358" actId="113"/>
-        <pc:sldMkLst>
-          <pc:docMk/>
-          <pc:sldMk cId="3499753351" sldId="600"/>
-        </pc:sldMkLst>
-      </pc:sldChg>
-      <pc:sldChg chg="addSp delSp modSp new mod">
-        <pc:chgData name="Matthieu De Mari" userId="dfb708c9-d8dc-439f-9a3b-c772bf4a311c" providerId="ADAL" clId="{95DC2182-BA54-4583-9E8E-B21E5C8D4D55}" dt="2023-02-23T06:38:30.396" v="13775"/>
-        <pc:sldMkLst>
-          <pc:docMk/>
-          <pc:sldMk cId="1913740079" sldId="601"/>
-        </pc:sldMkLst>
-      </pc:sldChg>
-      <pc:sldChg chg="addSp delSp modSp add mod">
-        <pc:chgData name="Matthieu De Mari" userId="dfb708c9-d8dc-439f-9a3b-c772bf4a311c" providerId="ADAL" clId="{95DC2182-BA54-4583-9E8E-B21E5C8D4D55}" dt="2023-02-26T07:37:49.435" v="19374" actId="20577"/>
-        <pc:sldMkLst>
-          <pc:docMk/>
-          <pc:sldMk cId="4011461575" sldId="602"/>
-        </pc:sldMkLst>
-      </pc:sldChg>
-      <pc:sldChg chg="addSp delSp modSp add mod">
-        <pc:chgData name="Matthieu De Mari" userId="dfb708c9-d8dc-439f-9a3b-c772bf4a311c" providerId="ADAL" clId="{95DC2182-BA54-4583-9E8E-B21E5C8D4D55}" dt="2023-02-23T06:38:32.702" v="13777"/>
-        <pc:sldMkLst>
-          <pc:docMk/>
-          <pc:sldMk cId="2445909842" sldId="603"/>
-        </pc:sldMkLst>
-      </pc:sldChg>
-      <pc:sldChg chg="addSp modSp add mod">
-        <pc:chgData name="Matthieu De Mari" userId="dfb708c9-d8dc-439f-9a3b-c772bf4a311c" providerId="ADAL" clId="{95DC2182-BA54-4583-9E8E-B21E5C8D4D55}" dt="2023-02-23T06:38:27.236" v="13773" actId="1076"/>
-        <pc:sldMkLst>
-          <pc:docMk/>
-          <pc:sldMk cId="1888637577" sldId="604"/>
-        </pc:sldMkLst>
-      </pc:sldChg>
-      <pc:sldChg chg="addSp delSp modSp add mod modClrScheme chgLayout">
-        <pc:chgData name="Matthieu De Mari" userId="dfb708c9-d8dc-439f-9a3b-c772bf4a311c" providerId="ADAL" clId="{95DC2182-BA54-4583-9E8E-B21E5C8D4D55}" dt="2023-02-23T11:36:18.598" v="17804" actId="5793"/>
-        <pc:sldMkLst>
-          <pc:docMk/>
-          <pc:sldMk cId="3313007867" sldId="605"/>
-        </pc:sldMkLst>
-      </pc:sldChg>
-      <pc:sldChg chg="addSp delSp modSp new add del mod ord">
-        <pc:chgData name="Matthieu De Mari" userId="dfb708c9-d8dc-439f-9a3b-c772bf4a311c" providerId="ADAL" clId="{95DC2182-BA54-4583-9E8E-B21E5C8D4D55}" dt="2023-02-23T11:01:07.522" v="17147" actId="1076"/>
-        <pc:sldMkLst>
-          <pc:docMk/>
-          <pc:sldMk cId="544744450" sldId="606"/>
-        </pc:sldMkLst>
-      </pc:sldChg>
-      <pc:sldChg chg="addSp delSp modSp add mod modClrScheme chgLayout">
-        <pc:chgData name="Matthieu De Mari" userId="dfb708c9-d8dc-439f-9a3b-c772bf4a311c" providerId="ADAL" clId="{95DC2182-BA54-4583-9E8E-B21E5C8D4D55}" dt="2023-02-23T09:34:43.593" v="16656" actId="1076"/>
-        <pc:sldMkLst>
-          <pc:docMk/>
-          <pc:sldMk cId="2835508014" sldId="607"/>
-        </pc:sldMkLst>
-      </pc:sldChg>
-      <pc:sldChg chg="addSp delSp modSp add mod modClrScheme chgLayout">
-        <pc:chgData name="Matthieu De Mari" userId="dfb708c9-d8dc-439f-9a3b-c772bf4a311c" providerId="ADAL" clId="{95DC2182-BA54-4583-9E8E-B21E5C8D4D55}" dt="2023-02-23T09:43:19.433" v="16892" actId="20577"/>
-        <pc:sldMkLst>
-          <pc:docMk/>
-          <pc:sldMk cId="3494463352" sldId="608"/>
-        </pc:sldMkLst>
-      </pc:sldChg>
-      <pc:sldChg chg="modSp add mod">
-        <pc:chgData name="Matthieu De Mari" userId="dfb708c9-d8dc-439f-9a3b-c772bf4a311c" providerId="ADAL" clId="{95DC2182-BA54-4583-9E8E-B21E5C8D4D55}" dt="2023-02-23T11:36:16.260" v="17803" actId="5793"/>
-        <pc:sldMkLst>
-          <pc:docMk/>
-          <pc:sldMk cId="1274089717" sldId="609"/>
-        </pc:sldMkLst>
-      </pc:sldChg>
-      <pc:sldChg chg="modSp add mod">
-        <pc:chgData name="Matthieu De Mari" userId="dfb708c9-d8dc-439f-9a3b-c772bf4a311c" providerId="ADAL" clId="{95DC2182-BA54-4583-9E8E-B21E5C8D4D55}" dt="2023-02-23T09:42:56.991" v="16878" actId="27636"/>
-        <pc:sldMkLst>
-          <pc:docMk/>
-          <pc:sldMk cId="1149178855" sldId="610"/>
-        </pc:sldMkLst>
-      </pc:sldChg>
-      <pc:sldChg chg="modSp add mod">
-        <pc:chgData name="Matthieu De Mari" userId="dfb708c9-d8dc-439f-9a3b-c772bf4a311c" providerId="ADAL" clId="{95DC2182-BA54-4583-9E8E-B21E5C8D4D55}" dt="2023-02-23T09:32:16.226" v="16259" actId="5793"/>
-        <pc:sldMkLst>
-          <pc:docMk/>
-          <pc:sldMk cId="1655947162" sldId="611"/>
-        </pc:sldMkLst>
-      </pc:sldChg>
-      <pc:sldChg chg="add ord">
-        <pc:chgData name="Matthieu De Mari" userId="dfb708c9-d8dc-439f-9a3b-c772bf4a311c" providerId="ADAL" clId="{95DC2182-BA54-4583-9E8E-B21E5C8D4D55}" dt="2023-02-23T11:04:15.978" v="17200"/>
-        <pc:sldMkLst>
-          <pc:docMk/>
-          <pc:sldMk cId="1079237185" sldId="612"/>
-        </pc:sldMkLst>
-      </pc:sldChg>
-      <pc:sldChg chg="addSp delSp modSp new mod">
-        <pc:chgData name="Matthieu De Mari" userId="dfb708c9-d8dc-439f-9a3b-c772bf4a311c" providerId="ADAL" clId="{95DC2182-BA54-4583-9E8E-B21E5C8D4D55}" dt="2023-02-23T09:38:29.534" v="16823" actId="20577"/>
-        <pc:sldMkLst>
-          <pc:docMk/>
-          <pc:sldMk cId="3584089474" sldId="613"/>
-        </pc:sldMkLst>
-      </pc:sldChg>
-      <pc:sldChg chg="addSp delSp modSp add mod modClrScheme chgLayout">
-        <pc:chgData name="Matthieu De Mari" userId="dfb708c9-d8dc-439f-9a3b-c772bf4a311c" providerId="ADAL" clId="{95DC2182-BA54-4583-9E8E-B21E5C8D4D55}" dt="2023-02-23T11:05:02.668" v="17237" actId="20577"/>
-        <pc:sldMkLst>
-          <pc:docMk/>
-          <pc:sldMk cId="1726322392" sldId="614"/>
-        </pc:sldMkLst>
-      </pc:sldChg>
-      <pc:sldChg chg="addSp delSp modSp new del mod">
-        <pc:chgData name="Matthieu De Mari" userId="dfb708c9-d8dc-439f-9a3b-c772bf4a311c" providerId="ADAL" clId="{95DC2182-BA54-4583-9E8E-B21E5C8D4D55}" dt="2023-02-23T11:00:47.480" v="17143" actId="47"/>
-        <pc:sldMkLst>
-          <pc:docMk/>
-          <pc:sldMk cId="469800146" sldId="615"/>
-        </pc:sldMkLst>
-      </pc:sldChg>
-      <pc:sldChg chg="addSp delSp modSp add mod">
-        <pc:chgData name="Matthieu De Mari" userId="dfb708c9-d8dc-439f-9a3b-c772bf4a311c" providerId="ADAL" clId="{95DC2182-BA54-4583-9E8E-B21E5C8D4D55}" dt="2023-02-23T11:01:35.124" v="17195" actId="1076"/>
-        <pc:sldMkLst>
-          <pc:docMk/>
-          <pc:sldMk cId="1478687394" sldId="615"/>
-        </pc:sldMkLst>
-      </pc:sldChg>
-      <pc:sldChg chg="add del ord">
-        <pc:chgData name="Matthieu De Mari" userId="dfb708c9-d8dc-439f-9a3b-c772bf4a311c" providerId="ADAL" clId="{95DC2182-BA54-4583-9E8E-B21E5C8D4D55}" dt="2023-02-23T11:22:28.169" v="17391" actId="2696"/>
-        <pc:sldMkLst>
-          <pc:docMk/>
-          <pc:sldMk cId="2287299756" sldId="616"/>
-        </pc:sldMkLst>
-      </pc:sldChg>
-      <pc:sldChg chg="addSp modSp add mod ord modClrScheme chgLayout">
-        <pc:chgData name="Matthieu De Mari" userId="dfb708c9-d8dc-439f-9a3b-c772bf4a311c" providerId="ADAL" clId="{95DC2182-BA54-4583-9E8E-B21E5C8D4D55}" dt="2023-02-23T11:24:51.984" v="17467" actId="20577"/>
-        <pc:sldMkLst>
-          <pc:docMk/>
-          <pc:sldMk cId="2697134679" sldId="616"/>
-        </pc:sldMkLst>
-      </pc:sldChg>
-      <pc:sldChg chg="addSp delSp modSp add del mod">
-        <pc:chgData name="Matthieu De Mari" userId="dfb708c9-d8dc-439f-9a3b-c772bf4a311c" providerId="ADAL" clId="{95DC2182-BA54-4583-9E8E-B21E5C8D4D55}" dt="2023-02-23T11:00:48.453" v="17144" actId="47"/>
-        <pc:sldMkLst>
-          <pc:docMk/>
-          <pc:sldMk cId="2860911120" sldId="616"/>
-        </pc:sldMkLst>
-      </pc:sldChg>
-      <pc:sldChg chg="modSp add mod">
-        <pc:chgData name="Matthieu De Mari" userId="dfb708c9-d8dc-439f-9a3b-c772bf4a311c" providerId="ADAL" clId="{95DC2182-BA54-4583-9E8E-B21E5C8D4D55}" dt="2023-02-26T07:38:59.531" v="19401" actId="113"/>
-        <pc:sldMkLst>
-          <pc:docMk/>
-          <pc:sldMk cId="1087818113" sldId="617"/>
-        </pc:sldMkLst>
-      </pc:sldChg>
-      <pc:sldChg chg="addSp delSp modSp add del mod">
-        <pc:chgData name="Matthieu De Mari" userId="dfb708c9-d8dc-439f-9a3b-c772bf4a311c" providerId="ADAL" clId="{95DC2182-BA54-4583-9E8E-B21E5C8D4D55}" dt="2023-02-23T11:00:50.614" v="17145" actId="47"/>
-        <pc:sldMkLst>
-          <pc:docMk/>
-          <pc:sldMk cId="2582365728" sldId="617"/>
-        </pc:sldMkLst>
-      </pc:sldChg>
-      <pc:sldChg chg="modSp new del mod">
-        <pc:chgData name="Matthieu De Mari" userId="dfb708c9-d8dc-439f-9a3b-c772bf4a311c" providerId="ADAL" clId="{95DC2182-BA54-4583-9E8E-B21E5C8D4D55}" dt="2023-02-23T11:25:02.305" v="17470" actId="47"/>
-        <pc:sldMkLst>
-          <pc:docMk/>
-          <pc:sldMk cId="1744965747" sldId="618"/>
-        </pc:sldMkLst>
-      </pc:sldChg>
-      <pc:sldChg chg="modSp add mod">
-        <pc:chgData name="Matthieu De Mari" userId="dfb708c9-d8dc-439f-9a3b-c772bf4a311c" providerId="ADAL" clId="{95DC2182-BA54-4583-9E8E-B21E5C8D4D55}" dt="2023-02-23T11:26:25.692" v="17518" actId="20577"/>
-        <pc:sldMkLst>
-          <pc:docMk/>
-          <pc:sldMk cId="2052607657" sldId="619"/>
-        </pc:sldMkLst>
-      </pc:sldChg>
-      <pc:sldChg chg="modSp add mod">
-        <pc:chgData name="Matthieu De Mari" userId="dfb708c9-d8dc-439f-9a3b-c772bf4a311c" providerId="ADAL" clId="{95DC2182-BA54-4583-9E8E-B21E5C8D4D55}" dt="2023-02-23T11:30:14.608" v="17593" actId="20577"/>
-        <pc:sldMkLst>
-          <pc:docMk/>
-          <pc:sldMk cId="1028237814" sldId="620"/>
-        </pc:sldMkLst>
-      </pc:sldChg>
-      <pc:sldChg chg="modSp new del mod">
-        <pc:chgData name="Matthieu De Mari" userId="dfb708c9-d8dc-439f-9a3b-c772bf4a311c" providerId="ADAL" clId="{95DC2182-BA54-4583-9E8E-B21E5C8D4D55}" dt="2023-02-23T11:32:21.609" v="17677" actId="47"/>
-        <pc:sldMkLst>
-          <pc:docMk/>
-          <pc:sldMk cId="674043654" sldId="621"/>
-        </pc:sldMkLst>
-      </pc:sldChg>
-      <pc:sldChg chg="modSp add mod">
-        <pc:chgData name="Matthieu De Mari" userId="dfb708c9-d8dc-439f-9a3b-c772bf4a311c" providerId="ADAL" clId="{95DC2182-BA54-4583-9E8E-B21E5C8D4D55}" dt="2023-02-23T11:40:07.473" v="17897" actId="113"/>
-        <pc:sldMkLst>
-          <pc:docMk/>
-          <pc:sldMk cId="204647563" sldId="622"/>
-        </pc:sldMkLst>
-      </pc:sldChg>
-      <pc:sldChg chg="add del">
-        <pc:chgData name="Matthieu De Mari" userId="dfb708c9-d8dc-439f-9a3b-c772bf4a311c" providerId="ADAL" clId="{95DC2182-BA54-4583-9E8E-B21E5C8D4D55}" dt="2023-02-23T11:32:32.069" v="17686" actId="47"/>
-        <pc:sldMkLst>
-          <pc:docMk/>
-          <pc:sldMk cId="1519993866" sldId="623"/>
-        </pc:sldMkLst>
-      </pc:sldChg>
-      <pc:sldChg chg="modSp add mod">
-        <pc:chgData name="Matthieu De Mari" userId="dfb708c9-d8dc-439f-9a3b-c772bf4a311c" providerId="ADAL" clId="{95DC2182-BA54-4583-9E8E-B21E5C8D4D55}" dt="2023-02-23T11:46:58.301" v="18586" actId="20577"/>
-        <pc:sldMkLst>
-          <pc:docMk/>
-          <pc:sldMk cId="3109980527" sldId="624"/>
-        </pc:sldMkLst>
-      </pc:sldChg>
-      <pc:sldChg chg="add del">
-        <pc:chgData name="Matthieu De Mari" userId="dfb708c9-d8dc-439f-9a3b-c772bf4a311c" providerId="ADAL" clId="{95DC2182-BA54-4583-9E8E-B21E5C8D4D55}" dt="2023-02-23T11:32:33.987" v="17687" actId="47"/>
-        <pc:sldMkLst>
-          <pc:docMk/>
-          <pc:sldMk cId="1400857828" sldId="625"/>
-        </pc:sldMkLst>
-      </pc:sldChg>
-      <pc:sldChg chg="add del">
-        <pc:chgData name="Matthieu De Mari" userId="dfb708c9-d8dc-439f-9a3b-c772bf4a311c" providerId="ADAL" clId="{95DC2182-BA54-4583-9E8E-B21E5C8D4D55}" dt="2023-02-23T11:32:35.205" v="17688" actId="47"/>
-        <pc:sldMkLst>
-          <pc:docMk/>
-          <pc:sldMk cId="2617072352" sldId="626"/>
-        </pc:sldMkLst>
-      </pc:sldChg>
-      <pc:sldChg chg="addSp delSp modSp add mod">
-        <pc:chgData name="Matthieu De Mari" userId="dfb708c9-d8dc-439f-9a3b-c772bf4a311c" providerId="ADAL" clId="{95DC2182-BA54-4583-9E8E-B21E5C8D4D55}" dt="2023-02-26T07:39:25.714" v="19403"/>
-        <pc:sldMkLst>
-          <pc:docMk/>
-          <pc:sldMk cId="491578291" sldId="627"/>
-        </pc:sldMkLst>
-      </pc:sldChg>
-      <pc:sldChg chg="addSp delSp modSp add mod">
-        <pc:chgData name="Matthieu De Mari" userId="dfb708c9-d8dc-439f-9a3b-c772bf4a311c" providerId="ADAL" clId="{95DC2182-BA54-4583-9E8E-B21E5C8D4D55}" dt="2023-02-23T11:57:51.740" v="19189" actId="20577"/>
-        <pc:sldMkLst>
-          <pc:docMk/>
-          <pc:sldMk cId="4059265678" sldId="628"/>
-        </pc:sldMkLst>
-      </pc:sldChg>
-      <pc:sldChg chg="addSp delSp modSp add mod">
-        <pc:chgData name="Matthieu De Mari" userId="dfb708c9-d8dc-439f-9a3b-c772bf4a311c" providerId="ADAL" clId="{95DC2182-BA54-4583-9E8E-B21E5C8D4D55}" dt="2023-02-23T11:58:11.946" v="19193" actId="1076"/>
-        <pc:sldMkLst>
-          <pc:docMk/>
-          <pc:sldMk cId="2696285505" sldId="629"/>
-        </pc:sldMkLst>
-      </pc:sldChg>
-      <pc:sldChg chg="addSp delSp modSp add mod">
-        <pc:chgData name="Matthieu De Mari" userId="dfb708c9-d8dc-439f-9a3b-c772bf4a311c" providerId="ADAL" clId="{95DC2182-BA54-4583-9E8E-B21E5C8D4D55}" dt="2023-02-23T11:58:24.032" v="19195" actId="1076"/>
-        <pc:sldMkLst>
-          <pc:docMk/>
-          <pc:sldMk cId="3403244392" sldId="630"/>
-        </pc:sldMkLst>
-      </pc:sldChg>
-      <pc:sldChg chg="addSp delSp modSp add mod">
-        <pc:chgData name="Matthieu De Mari" userId="dfb708c9-d8dc-439f-9a3b-c772bf4a311c" providerId="ADAL" clId="{95DC2182-BA54-4583-9E8E-B21E5C8D4D55}" dt="2023-02-23T11:58:36.759" v="19197" actId="1076"/>
-        <pc:sldMkLst>
-          <pc:docMk/>
-          <pc:sldMk cId="3378674748" sldId="631"/>
-        </pc:sldMkLst>
-      </pc:sldChg>
-      <pc:sldChg chg="addSp delSp modSp add mod">
-        <pc:chgData name="Matthieu De Mari" userId="dfb708c9-d8dc-439f-9a3b-c772bf4a311c" providerId="ADAL" clId="{95DC2182-BA54-4583-9E8E-B21E5C8D4D55}" dt="2023-02-23T11:58:58.685" v="19200" actId="1076"/>
-        <pc:sldMkLst>
-          <pc:docMk/>
-          <pc:sldMk cId="3237577112" sldId="632"/>
-        </pc:sldMkLst>
-      </pc:sldChg>
-      <pc:sldChg chg="modSp add mod">
-        <pc:chgData name="Matthieu De Mari" userId="dfb708c9-d8dc-439f-9a3b-c772bf4a311c" providerId="ADAL" clId="{95DC2182-BA54-4583-9E8E-B21E5C8D4D55}" dt="2023-02-23T11:44:43.452" v="18255" actId="113"/>
-        <pc:sldMkLst>
-          <pc:docMk/>
-          <pc:sldMk cId="3821484596" sldId="633"/>
-        </pc:sldMkLst>
-      </pc:sldChg>
-      <pc:sldChg chg="modSp add mod">
-        <pc:chgData name="Matthieu De Mari" userId="dfb708c9-d8dc-439f-9a3b-c772bf4a311c" providerId="ADAL" clId="{95DC2182-BA54-4583-9E8E-B21E5C8D4D55}" dt="2023-02-26T07:39:41.850" v="19415" actId="20577"/>
-        <pc:sldMkLst>
-          <pc:docMk/>
-          <pc:sldMk cId="875945898" sldId="634"/>
-        </pc:sldMkLst>
-      </pc:sldChg>
-      <pc:sldChg chg="addSp modSp add mod modClrScheme chgLayout">
-        <pc:chgData name="Matthieu De Mari" userId="dfb708c9-d8dc-439f-9a3b-c772bf4a311c" providerId="ADAL" clId="{95DC2182-BA54-4583-9E8E-B21E5C8D4D55}" dt="2023-02-26T07:40:44.893" v="19434" actId="20577"/>
-        <pc:sldMkLst>
-          <pc:docMk/>
-          <pc:sldMk cId="956888542" sldId="635"/>
-        </pc:sldMkLst>
-      </pc:sldChg>
-      <pc:sldChg chg="modSp add mod">
-        <pc:chgData name="Matthieu De Mari" userId="dfb708c9-d8dc-439f-9a3b-c772bf4a311c" providerId="ADAL" clId="{95DC2182-BA54-4583-9E8E-B21E5C8D4D55}" dt="2023-02-26T07:41:01.441" v="19435"/>
-        <pc:sldMkLst>
-          <pc:docMk/>
-          <pc:sldMk cId="9821103" sldId="636"/>
-        </pc:sldMkLst>
-      </pc:sldChg>
-      <pc:sldChg chg="addSp delSp modSp new mod">
-        <pc:chgData name="Matthieu De Mari" userId="dfb708c9-d8dc-439f-9a3b-c772bf4a311c" providerId="ADAL" clId="{95DC2182-BA54-4583-9E8E-B21E5C8D4D55}" dt="2023-02-26T08:33:50.414" v="23836" actId="20577"/>
-        <pc:sldMkLst>
-          <pc:docMk/>
-          <pc:sldMk cId="1731878414" sldId="637"/>
-        </pc:sldMkLst>
-      </pc:sldChg>
-      <pc:sldChg chg="addSp delSp modSp new mod modClrScheme chgLayout">
-        <pc:chgData name="Matthieu De Mari" userId="dfb708c9-d8dc-439f-9a3b-c772bf4a311c" providerId="ADAL" clId="{95DC2182-BA54-4583-9E8E-B21E5C8D4D55}" dt="2023-02-26T07:51:17.949" v="20100" actId="207"/>
-        <pc:sldMkLst>
-          <pc:docMk/>
-          <pc:sldMk cId="1290242122" sldId="638"/>
-        </pc:sldMkLst>
-      </pc:sldChg>
-      <pc:sldChg chg="addSp delSp modSp new mod">
-        <pc:chgData name="Matthieu De Mari" userId="dfb708c9-d8dc-439f-9a3b-c772bf4a311c" providerId="ADAL" clId="{95DC2182-BA54-4583-9E8E-B21E5C8D4D55}" dt="2023-02-26T07:49:29.626" v="19989" actId="208"/>
-        <pc:sldMkLst>
-          <pc:docMk/>
-          <pc:sldMk cId="4283342382" sldId="639"/>
-        </pc:sldMkLst>
-      </pc:sldChg>
-      <pc:sldChg chg="addSp delSp modSp new mod">
-        <pc:chgData name="Matthieu De Mari" userId="dfb708c9-d8dc-439f-9a3b-c772bf4a311c" providerId="ADAL" clId="{95DC2182-BA54-4583-9E8E-B21E5C8D4D55}" dt="2023-02-26T07:54:53.760" v="20579" actId="14100"/>
-        <pc:sldMkLst>
-          <pc:docMk/>
-          <pc:sldMk cId="3527748531" sldId="640"/>
-        </pc:sldMkLst>
-      </pc:sldChg>
-      <pc:sldChg chg="modSp add mod">
-        <pc:chgData name="Matthieu De Mari" userId="dfb708c9-d8dc-439f-9a3b-c772bf4a311c" providerId="ADAL" clId="{95DC2182-BA54-4583-9E8E-B21E5C8D4D55}" dt="2023-02-26T08:01:55.944" v="21493" actId="20577"/>
-        <pc:sldMkLst>
-          <pc:docMk/>
-          <pc:sldMk cId="3298110552" sldId="641"/>
-        </pc:sldMkLst>
-      </pc:sldChg>
-      <pc:sldChg chg="addSp modSp add mod">
-        <pc:chgData name="Matthieu De Mari" userId="dfb708c9-d8dc-439f-9a3b-c772bf4a311c" providerId="ADAL" clId="{95DC2182-BA54-4583-9E8E-B21E5C8D4D55}" dt="2023-02-26T07:55:50.474" v="20800" actId="1076"/>
-        <pc:sldMkLst>
-          <pc:docMk/>
-          <pc:sldMk cId="4241197121" sldId="642"/>
-        </pc:sldMkLst>
-      </pc:sldChg>
-      <pc:sldChg chg="add del">
-        <pc:chgData name="Matthieu De Mari" userId="dfb708c9-d8dc-439f-9a3b-c772bf4a311c" providerId="ADAL" clId="{95DC2182-BA54-4583-9E8E-B21E5C8D4D55}" dt="2023-02-26T07:55:43.929" v="20797"/>
-        <pc:sldMkLst>
-          <pc:docMk/>
-          <pc:sldMk cId="610146181" sldId="643"/>
-        </pc:sldMkLst>
-      </pc:sldChg>
-      <pc:sldChg chg="addSp delSp modSp add mod">
-        <pc:chgData name="Matthieu De Mari" userId="dfb708c9-d8dc-439f-9a3b-c772bf4a311c" providerId="ADAL" clId="{95DC2182-BA54-4583-9E8E-B21E5C8D4D55}" dt="2023-02-26T08:02:06.838" v="21504" actId="20577"/>
-        <pc:sldMkLst>
-          <pc:docMk/>
-          <pc:sldMk cId="1487822837" sldId="643"/>
-        </pc:sldMkLst>
-      </pc:sldChg>
-      <pc:sldChg chg="addSp delSp modSp add mod">
-        <pc:chgData name="Matthieu De Mari" userId="dfb708c9-d8dc-439f-9a3b-c772bf4a311c" providerId="ADAL" clId="{95DC2182-BA54-4583-9E8E-B21E5C8D4D55}" dt="2023-02-26T08:02:12.887" v="21513" actId="20577"/>
-        <pc:sldMkLst>
-          <pc:docMk/>
-          <pc:sldMk cId="715032396" sldId="644"/>
-        </pc:sldMkLst>
-      </pc:sldChg>
-      <pc:sldChg chg="addSp delSp modSp add mod chgLayout">
-        <pc:chgData name="Matthieu De Mari" userId="dfb708c9-d8dc-439f-9a3b-c772bf4a311c" providerId="ADAL" clId="{95DC2182-BA54-4583-9E8E-B21E5C8D4D55}" dt="2023-02-26T08:08:00.561" v="21944" actId="20577"/>
-        <pc:sldMkLst>
-          <pc:docMk/>
-          <pc:sldMk cId="1850403076" sldId="645"/>
-        </pc:sldMkLst>
-      </pc:sldChg>
-      <pc:sldChg chg="addSp delSp modSp add mod">
-        <pc:chgData name="Matthieu De Mari" userId="dfb708c9-d8dc-439f-9a3b-c772bf4a311c" providerId="ADAL" clId="{95DC2182-BA54-4583-9E8E-B21E5C8D4D55}" dt="2023-02-26T08:03:15.451" v="21600" actId="1076"/>
-        <pc:sldMkLst>
-          <pc:docMk/>
-          <pc:sldMk cId="3708794977" sldId="646"/>
-        </pc:sldMkLst>
-      </pc:sldChg>
-      <pc:sldChg chg="new del">
-        <pc:chgData name="Matthieu De Mari" userId="dfb708c9-d8dc-439f-9a3b-c772bf4a311c" providerId="ADAL" clId="{95DC2182-BA54-4583-9E8E-B21E5C8D4D55}" dt="2023-02-26T08:25:21.334" v="22855" actId="47"/>
-        <pc:sldMkLst>
-          <pc:docMk/>
-          <pc:sldMk cId="643363626" sldId="647"/>
-        </pc:sldMkLst>
-      </pc:sldChg>
-      <pc:sldChg chg="addSp delSp modSp add mod ord">
-        <pc:chgData name="Matthieu De Mari" userId="dfb708c9-d8dc-439f-9a3b-c772bf4a311c" providerId="ADAL" clId="{95DC2182-BA54-4583-9E8E-B21E5C8D4D55}" dt="2023-02-26T08:25:45.717" v="22863" actId="20577"/>
-        <pc:sldMkLst>
-          <pc:docMk/>
-          <pc:sldMk cId="2404237809" sldId="648"/>
-        </pc:sldMkLst>
-      </pc:sldChg>
-      <pc:sldChg chg="addSp modSp add mod ord">
-        <pc:chgData name="Matthieu De Mari" userId="dfb708c9-d8dc-439f-9a3b-c772bf4a311c" providerId="ADAL" clId="{95DC2182-BA54-4583-9E8E-B21E5C8D4D55}" dt="2023-02-26T08:26:02.661" v="22885"/>
-        <pc:sldMkLst>
-          <pc:docMk/>
-          <pc:sldMk cId="1952442680" sldId="649"/>
-        </pc:sldMkLst>
-      </pc:sldChg>
-      <pc:sldChg chg="modSp add mod">
-        <pc:chgData name="Matthieu De Mari" userId="dfb708c9-d8dc-439f-9a3b-c772bf4a311c" providerId="ADAL" clId="{95DC2182-BA54-4583-9E8E-B21E5C8D4D55}" dt="2023-02-26T08:25:58.425" v="22884" actId="20577"/>
-        <pc:sldMkLst>
-          <pc:docMk/>
-          <pc:sldMk cId="3215884619" sldId="650"/>
-        </pc:sldMkLst>
-      </pc:sldChg>
-      <pc:sldChg chg="addSp modSp add mod">
-        <pc:chgData name="Matthieu De Mari" userId="dfb708c9-d8dc-439f-9a3b-c772bf4a311c" providerId="ADAL" clId="{95DC2182-BA54-4583-9E8E-B21E5C8D4D55}" dt="2023-02-26T08:21:09.108" v="22566" actId="1076"/>
-        <pc:sldMkLst>
-          <pc:docMk/>
-          <pc:sldMk cId="2595195584" sldId="651"/>
-        </pc:sldMkLst>
-      </pc:sldChg>
-      <pc:sldChg chg="addSp modSp add mod">
-        <pc:chgData name="Matthieu De Mari" userId="dfb708c9-d8dc-439f-9a3b-c772bf4a311c" providerId="ADAL" clId="{95DC2182-BA54-4583-9E8E-B21E5C8D4D55}" dt="2023-02-26T08:22:28.656" v="22594" actId="1037"/>
-        <pc:sldMkLst>
-          <pc:docMk/>
-          <pc:sldMk cId="773672680" sldId="652"/>
-        </pc:sldMkLst>
-      </pc:sldChg>
-      <pc:sldChg chg="addSp delSp modSp add mod chgLayout">
-        <pc:chgData name="Matthieu De Mari" userId="dfb708c9-d8dc-439f-9a3b-c772bf4a311c" providerId="ADAL" clId="{95DC2182-BA54-4583-9E8E-B21E5C8D4D55}" dt="2023-02-26T08:29:10.127" v="23267" actId="20577"/>
-        <pc:sldMkLst>
-          <pc:docMk/>
-          <pc:sldMk cId="855321949" sldId="653"/>
-        </pc:sldMkLst>
-      </pc:sldChg>
-      <pc:sldChg chg="addSp delSp modSp new mod ord modClrScheme chgLayout">
-        <pc:chgData name="Matthieu De Mari" userId="dfb708c9-d8dc-439f-9a3b-c772bf4a311c" providerId="ADAL" clId="{95DC2182-BA54-4583-9E8E-B21E5C8D4D55}" dt="2023-02-26T08:30:34.396" v="23518" actId="1076"/>
-        <pc:sldMkLst>
-          <pc:docMk/>
-          <pc:sldMk cId="2099660639" sldId="654"/>
-        </pc:sldMkLst>
-      </pc:sldChg>
-      <pc:sldChg chg="addSp delSp modSp add mod modClrScheme chgLayout">
-        <pc:chgData name="Matthieu De Mari" userId="dfb708c9-d8dc-439f-9a3b-c772bf4a311c" providerId="ADAL" clId="{95DC2182-BA54-4583-9E8E-B21E5C8D4D55}" dt="2023-02-26T08:45:11.474" v="24818" actId="20577"/>
-        <pc:sldMkLst>
-          <pc:docMk/>
-          <pc:sldMk cId="2451971174" sldId="655"/>
-        </pc:sldMkLst>
-      </pc:sldChg>
-      <pc:sldChg chg="addSp modSp add mod">
-        <pc:chgData name="Matthieu De Mari" userId="dfb708c9-d8dc-439f-9a3b-c772bf4a311c" providerId="ADAL" clId="{95DC2182-BA54-4583-9E8E-B21E5C8D4D55}" dt="2023-02-26T08:35:48.718" v="23984" actId="20577"/>
-        <pc:sldMkLst>
-          <pc:docMk/>
-          <pc:sldMk cId="148017835" sldId="656"/>
-        </pc:sldMkLst>
-      </pc:sldChg>
-      <pc:sldChg chg="addSp delSp modSp add mod">
-        <pc:chgData name="Matthieu De Mari" userId="dfb708c9-d8dc-439f-9a3b-c772bf4a311c" providerId="ADAL" clId="{95DC2182-BA54-4583-9E8E-B21E5C8D4D55}" dt="2023-02-26T08:37:03.529" v="24034" actId="20577"/>
-        <pc:sldMkLst>
-          <pc:docMk/>
-          <pc:sldMk cId="1922511899" sldId="657"/>
-        </pc:sldMkLst>
-      </pc:sldChg>
-      <pc:sldChg chg="addSp delSp modSp add mod">
-        <pc:chgData name="Matthieu De Mari" userId="dfb708c9-d8dc-439f-9a3b-c772bf4a311c" providerId="ADAL" clId="{95DC2182-BA54-4583-9E8E-B21E5C8D4D55}" dt="2023-02-26T08:45:36.452" v="24846" actId="20577"/>
-        <pc:sldMkLst>
-          <pc:docMk/>
-          <pc:sldMk cId="4035742227" sldId="658"/>
-        </pc:sldMkLst>
-      </pc:sldChg>
-      <pc:sldChg chg="addSp modSp add mod">
-        <pc:chgData name="Matthieu De Mari" userId="dfb708c9-d8dc-439f-9a3b-c772bf4a311c" providerId="ADAL" clId="{95DC2182-BA54-4583-9E8E-B21E5C8D4D55}" dt="2023-02-26T08:48:44.816" v="25240" actId="208"/>
-        <pc:sldMkLst>
-          <pc:docMk/>
-          <pc:sldMk cId="2096824087" sldId="659"/>
-        </pc:sldMkLst>
-      </pc:sldChg>
-      <pc:sldChg chg="addSp modSp add mod">
-        <pc:chgData name="Matthieu De Mari" userId="dfb708c9-d8dc-439f-9a3b-c772bf4a311c" providerId="ADAL" clId="{95DC2182-BA54-4583-9E8E-B21E5C8D4D55}" dt="2023-02-26T08:50:31.401" v="25403" actId="27636"/>
-        <pc:sldMkLst>
-          <pc:docMk/>
-          <pc:sldMk cId="3023865042" sldId="660"/>
-        </pc:sldMkLst>
-      </pc:sldChg>
-      <pc:sldChg chg="addSp delSp modSp add mod modClrScheme chgLayout">
-        <pc:chgData name="Matthieu De Mari" userId="dfb708c9-d8dc-439f-9a3b-c772bf4a311c" providerId="ADAL" clId="{95DC2182-BA54-4583-9E8E-B21E5C8D4D55}" dt="2023-02-26T08:59:57.695" v="26564" actId="27614"/>
-        <pc:sldMkLst>
-          <pc:docMk/>
-          <pc:sldMk cId="2303339168" sldId="661"/>
-        </pc:sldMkLst>
-      </pc:sldChg>
-      <pc:sldChg chg="modSp add mod">
-        <pc:chgData name="Matthieu De Mari" userId="dfb708c9-d8dc-439f-9a3b-c772bf4a311c" providerId="ADAL" clId="{95DC2182-BA54-4583-9E8E-B21E5C8D4D55}" dt="2023-02-26T08:57:11.565" v="26343" actId="113"/>
-        <pc:sldMkLst>
-          <pc:docMk/>
-          <pc:sldMk cId="444206811" sldId="662"/>
-        </pc:sldMkLst>
-      </pc:sldChg>
-      <pc:sldChg chg="modSp add mod">
-        <pc:chgData name="Matthieu De Mari" userId="dfb708c9-d8dc-439f-9a3b-c772bf4a311c" providerId="ADAL" clId="{95DC2182-BA54-4583-9E8E-B21E5C8D4D55}" dt="2023-02-26T08:59:51.154" v="26561" actId="20577"/>
-        <pc:sldMkLst>
-          <pc:docMk/>
-          <pc:sldMk cId="365986058" sldId="663"/>
-        </pc:sldMkLst>
-      </pc:sldChg>
-      <pc:sldChg chg="add del">
-        <pc:chgData name="Matthieu De Mari" userId="dfb708c9-d8dc-439f-9a3b-c772bf4a311c" providerId="ADAL" clId="{95DC2182-BA54-4583-9E8E-B21E5C8D4D55}" dt="2023-02-26T09:02:25.500" v="26957" actId="47"/>
-        <pc:sldMkLst>
-          <pc:docMk/>
-          <pc:sldMk cId="2221986219" sldId="664"/>
-        </pc:sldMkLst>
-      </pc:sldChg>
-      <pc:sldChg chg="add del">
-        <pc:chgData name="Matthieu De Mari" userId="dfb708c9-d8dc-439f-9a3b-c772bf4a311c" providerId="ADAL" clId="{95DC2182-BA54-4583-9E8E-B21E5C8D4D55}" dt="2023-02-26T09:02:26.166" v="26958" actId="47"/>
-        <pc:sldMkLst>
-          <pc:docMk/>
-          <pc:sldMk cId="2597465754" sldId="665"/>
-        </pc:sldMkLst>
       </pc:sldChg>
     </pc:docChg>
   </pc:docChgLst>
@@ -3378,7 +369,7 @@
           <a:p>
             <a:fld id="{61478373-EB31-4867-8CF0-FA31364748A5}" type="datetimeFigureOut">
               <a:rPr lang="en-GB" smtClean="0"/>
-              <a:t>03/03/2025</a:t>
+              <a:t>18/12/2025</a:t>
             </a:fld>
             <a:endParaRPr lang="en-GB"/>
           </a:p>
@@ -3795,7 +786,7 @@
           <a:p>
             <a:fld id="{E85DF616-B21E-4EF6-A6A5-95E2FB3EB1A1}" type="datetimeFigureOut">
               <a:rPr lang="en-GB" smtClean="0"/>
-              <a:t>03/03/2025</a:t>
+              <a:t>18/12/2025</a:t>
             </a:fld>
             <a:endParaRPr lang="en-GB"/>
           </a:p>
@@ -3995,7 +986,7 @@
           <a:p>
             <a:fld id="{E85DF616-B21E-4EF6-A6A5-95E2FB3EB1A1}" type="datetimeFigureOut">
               <a:rPr lang="en-GB" smtClean="0"/>
-              <a:t>03/03/2025</a:t>
+              <a:t>18/12/2025</a:t>
             </a:fld>
             <a:endParaRPr lang="en-GB"/>
           </a:p>
@@ -4205,7 +1196,7 @@
           <a:p>
             <a:fld id="{E85DF616-B21E-4EF6-A6A5-95E2FB3EB1A1}" type="datetimeFigureOut">
               <a:rPr lang="en-GB" smtClean="0"/>
-              <a:t>03/03/2025</a:t>
+              <a:t>18/12/2025</a:t>
             </a:fld>
             <a:endParaRPr lang="en-GB"/>
           </a:p>
@@ -4405,7 +1396,7 @@
           <a:p>
             <a:fld id="{E85DF616-B21E-4EF6-A6A5-95E2FB3EB1A1}" type="datetimeFigureOut">
               <a:rPr lang="en-GB" smtClean="0"/>
-              <a:t>03/03/2025</a:t>
+              <a:t>18/12/2025</a:t>
             </a:fld>
             <a:endParaRPr lang="en-GB"/>
           </a:p>
@@ -4681,7 +1672,7 @@
           <a:p>
             <a:fld id="{E85DF616-B21E-4EF6-A6A5-95E2FB3EB1A1}" type="datetimeFigureOut">
               <a:rPr lang="en-GB" smtClean="0"/>
-              <a:t>03/03/2025</a:t>
+              <a:t>18/12/2025</a:t>
             </a:fld>
             <a:endParaRPr lang="en-GB"/>
           </a:p>
@@ -4949,7 +1940,7 @@
           <a:p>
             <a:fld id="{E85DF616-B21E-4EF6-A6A5-95E2FB3EB1A1}" type="datetimeFigureOut">
               <a:rPr lang="en-GB" smtClean="0"/>
-              <a:t>03/03/2025</a:t>
+              <a:t>18/12/2025</a:t>
             </a:fld>
             <a:endParaRPr lang="en-GB"/>
           </a:p>
@@ -5364,7 +2355,7 @@
           <a:p>
             <a:fld id="{E85DF616-B21E-4EF6-A6A5-95E2FB3EB1A1}" type="datetimeFigureOut">
               <a:rPr lang="en-GB" smtClean="0"/>
-              <a:t>03/03/2025</a:t>
+              <a:t>18/12/2025</a:t>
             </a:fld>
             <a:endParaRPr lang="en-GB"/>
           </a:p>
@@ -5506,7 +2497,7 @@
           <a:p>
             <a:fld id="{E85DF616-B21E-4EF6-A6A5-95E2FB3EB1A1}" type="datetimeFigureOut">
               <a:rPr lang="en-GB" smtClean="0"/>
-              <a:t>03/03/2025</a:t>
+              <a:t>18/12/2025</a:t>
             </a:fld>
             <a:endParaRPr lang="en-GB"/>
           </a:p>
@@ -5619,7 +2610,7 @@
           <a:p>
             <a:fld id="{E85DF616-B21E-4EF6-A6A5-95E2FB3EB1A1}" type="datetimeFigureOut">
               <a:rPr lang="en-GB" smtClean="0"/>
-              <a:t>03/03/2025</a:t>
+              <a:t>18/12/2025</a:t>
             </a:fld>
             <a:endParaRPr lang="en-GB"/>
           </a:p>
@@ -5932,7 +2923,7 @@
           <a:p>
             <a:fld id="{E85DF616-B21E-4EF6-A6A5-95E2FB3EB1A1}" type="datetimeFigureOut">
               <a:rPr lang="en-GB" smtClean="0"/>
-              <a:t>03/03/2025</a:t>
+              <a:t>18/12/2025</a:t>
             </a:fld>
             <a:endParaRPr lang="en-GB"/>
           </a:p>
@@ -6221,7 +3212,7 @@
           <a:p>
             <a:fld id="{E85DF616-B21E-4EF6-A6A5-95E2FB3EB1A1}" type="datetimeFigureOut">
               <a:rPr lang="en-GB" smtClean="0"/>
-              <a:t>03/03/2025</a:t>
+              <a:t>18/12/2025</a:t>
             </a:fld>
             <a:endParaRPr lang="en-GB"/>
           </a:p>
@@ -6464,7 +3455,7 @@
           <a:p>
             <a:fld id="{E85DF616-B21E-4EF6-A6A5-95E2FB3EB1A1}" type="datetimeFigureOut">
               <a:rPr lang="en-GB" smtClean="0"/>
-              <a:t>03/03/2025</a:t>
+              <a:t>18/12/2025</a:t>
             </a:fld>
             <a:endParaRPr lang="en-GB"/>
           </a:p>
@@ -8277,7 +5268,7 @@
             </a:pPr>
             <a:r>
               <a:rPr lang="en-GB" b="1" dirty="0"/>
-              <a:t>But, hold on a second, what is the brain doing when it comes to memory anyway?</a:t>
+              <a:t>But hold on a second, what is the brain doing when it comes to memory anyway?</a:t>
             </a:r>
           </a:p>
           <a:p>

</xml_diff>